<commit_message>
summarized mean missing values for all LH traits compared with key LH traits
</commit_message>
<xml_diff>
--- a/AABA-Poster/GM-AABA2026Poster-Draft3.pptx
+++ b/AABA-Poster/GM-AABA2026Poster-Draft3.pptx
@@ -249,7 +249,7 @@
           <a:p>
             <a:fld id="{0E19EFA1-6199-496A-BC1D-DE705E3EBA0B}" type="datetimeFigureOut">
               <a:rPr lang="en-US" smtClean="0"/>
-              <a:t>3/12/2026</a:t>
+              <a:t>3/15/2026</a:t>
             </a:fld>
             <a:endParaRPr lang="en-US"/>
           </a:p>
@@ -419,7 +419,7 @@
           <a:p>
             <a:fld id="{0E19EFA1-6199-496A-BC1D-DE705E3EBA0B}" type="datetimeFigureOut">
               <a:rPr lang="en-US" smtClean="0"/>
-              <a:t>3/12/2026</a:t>
+              <a:t>3/15/2026</a:t>
             </a:fld>
             <a:endParaRPr lang="en-US"/>
           </a:p>
@@ -599,7 +599,7 @@
           <a:p>
             <a:fld id="{0E19EFA1-6199-496A-BC1D-DE705E3EBA0B}" type="datetimeFigureOut">
               <a:rPr lang="en-US" smtClean="0"/>
-              <a:t>3/12/2026</a:t>
+              <a:t>3/15/2026</a:t>
             </a:fld>
             <a:endParaRPr lang="en-US"/>
           </a:p>
@@ -769,7 +769,7 @@
           <a:p>
             <a:fld id="{0E19EFA1-6199-496A-BC1D-DE705E3EBA0B}" type="datetimeFigureOut">
               <a:rPr lang="en-US" smtClean="0"/>
-              <a:t>3/12/2026</a:t>
+              <a:t>3/15/2026</a:t>
             </a:fld>
             <a:endParaRPr lang="en-US"/>
           </a:p>
@@ -1015,7 +1015,7 @@
           <a:p>
             <a:fld id="{0E19EFA1-6199-496A-BC1D-DE705E3EBA0B}" type="datetimeFigureOut">
               <a:rPr lang="en-US" smtClean="0"/>
-              <a:t>3/12/2026</a:t>
+              <a:t>3/15/2026</a:t>
             </a:fld>
             <a:endParaRPr lang="en-US"/>
           </a:p>
@@ -1247,7 +1247,7 @@
           <a:p>
             <a:fld id="{0E19EFA1-6199-496A-BC1D-DE705E3EBA0B}" type="datetimeFigureOut">
               <a:rPr lang="en-US" smtClean="0"/>
-              <a:t>3/12/2026</a:t>
+              <a:t>3/15/2026</a:t>
             </a:fld>
             <a:endParaRPr lang="en-US"/>
           </a:p>
@@ -1614,7 +1614,7 @@
           <a:p>
             <a:fld id="{0E19EFA1-6199-496A-BC1D-DE705E3EBA0B}" type="datetimeFigureOut">
               <a:rPr lang="en-US" smtClean="0"/>
-              <a:t>3/12/2026</a:t>
+              <a:t>3/15/2026</a:t>
             </a:fld>
             <a:endParaRPr lang="en-US"/>
           </a:p>
@@ -1732,7 +1732,7 @@
           <a:p>
             <a:fld id="{0E19EFA1-6199-496A-BC1D-DE705E3EBA0B}" type="datetimeFigureOut">
               <a:rPr lang="en-US" smtClean="0"/>
-              <a:t>3/12/2026</a:t>
+              <a:t>3/15/2026</a:t>
             </a:fld>
             <a:endParaRPr lang="en-US"/>
           </a:p>
@@ -1827,7 +1827,7 @@
           <a:p>
             <a:fld id="{0E19EFA1-6199-496A-BC1D-DE705E3EBA0B}" type="datetimeFigureOut">
               <a:rPr lang="en-US" smtClean="0"/>
-              <a:t>3/12/2026</a:t>
+              <a:t>3/15/2026</a:t>
             </a:fld>
             <a:endParaRPr lang="en-US"/>
           </a:p>
@@ -2104,7 +2104,7 @@
           <a:p>
             <a:fld id="{0E19EFA1-6199-496A-BC1D-DE705E3EBA0B}" type="datetimeFigureOut">
               <a:rPr lang="en-US" smtClean="0"/>
-              <a:t>3/12/2026</a:t>
+              <a:t>3/15/2026</a:t>
             </a:fld>
             <a:endParaRPr lang="en-US"/>
           </a:p>
@@ -2361,7 +2361,7 @@
           <a:p>
             <a:fld id="{0E19EFA1-6199-496A-BC1D-DE705E3EBA0B}" type="datetimeFigureOut">
               <a:rPr lang="en-US" smtClean="0"/>
-              <a:t>3/12/2026</a:t>
+              <a:t>3/15/2026</a:t>
             </a:fld>
             <a:endParaRPr lang="en-US"/>
           </a:p>
@@ -2574,7 +2574,7 @@
           <a:p>
             <a:fld id="{0E19EFA1-6199-496A-BC1D-DE705E3EBA0B}" type="datetimeFigureOut">
               <a:rPr lang="en-US" smtClean="0"/>
-              <a:t>3/12/2026</a:t>
+              <a:t>3/15/2026</a:t>
             </a:fld>
             <a:endParaRPr lang="en-US"/>
           </a:p>
@@ -3042,36 +3042,6 @@
           </a:p>
         </p:txBody>
       </p:sp>
-      <p:pic>
-        <p:nvPicPr>
-          <p:cNvPr id="5" name="Picture 4">
-            <a:extLst>
-              <a:ext uri="{FF2B5EF4-FFF2-40B4-BE49-F238E27FC236}">
-                <a16:creationId xmlns:a16="http://schemas.microsoft.com/office/drawing/2014/main" id="{F3661E49-5892-B4AA-D399-65B7959839C7}"/>
-              </a:ext>
-            </a:extLst>
-          </p:cNvPr>
-          <p:cNvPicPr>
-            <a:picLocks noChangeAspect="1"/>
-          </p:cNvPicPr>
-          <p:nvPr/>
-        </p:nvPicPr>
-        <p:blipFill>
-          <a:blip r:embed="rId2"/>
-          <a:stretch>
-            <a:fillRect/>
-          </a:stretch>
-        </p:blipFill>
-        <p:spPr>
-          <a:xfrm>
-            <a:off x="5280996" y="27366629"/>
-            <a:ext cx="8272140" cy="6128775"/>
-          </a:xfrm>
-          <a:prstGeom prst="rect">
-            <a:avLst/>
-          </a:prstGeom>
-        </p:spPr>
-      </p:pic>
       <p:sp>
         <p:nvSpPr>
           <p:cNvPr id="12" name="TextBox 11">
@@ -4468,7 +4438,7 @@
         </p:nvSpPr>
         <p:spPr>
           <a:xfrm>
-            <a:off x="13802438" y="30591639"/>
+            <a:off x="15658344" y="26691004"/>
             <a:ext cx="7931966" cy="6654194"/>
           </a:xfrm>
           <a:prstGeom prst="rect">
@@ -4528,7 +4498,7 @@
               <a:rPr lang="en-US" dirty="0">
                 <a:latin typeface="Arial" panose="020B0604020202020204" pitchFamily="34" charset="0"/>
                 <a:cs typeface="Arial" panose="020B0604020202020204" pitchFamily="34" charset="0"/>
-                <a:hlinkClick r:id="rId3"/>
+                <a:hlinkClick r:id="rId2"/>
               </a:rPr>
               <a:t>https://bygentry.github.io/LHDB-PCA/Variable-Definitions.html</a:t>
             </a:r>
@@ -4692,138 +4662,6 @@
                 <a:cs typeface="Arial" panose="020B0604020202020204" pitchFamily="34" charset="0"/>
               </a:rPr>
               <a:t>highlight that no database reports  both ASM and AFR</a:t>
-            </a:r>
-          </a:p>
-        </p:txBody>
-      </p:sp>
-      <p:sp>
-        <p:nvSpPr>
-          <p:cNvPr id="7" name="TextBox 6">
-            <a:extLst>
-              <a:ext uri="{FF2B5EF4-FFF2-40B4-BE49-F238E27FC236}">
-                <a16:creationId xmlns:a16="http://schemas.microsoft.com/office/drawing/2014/main" id="{44E99FFA-8C44-4A71-F567-29D2A6F969CE}"/>
-              </a:ext>
-            </a:extLst>
-          </p:cNvPr>
-          <p:cNvSpPr txBox="1"/>
-          <p:nvPr/>
-        </p:nvSpPr>
-        <p:spPr>
-          <a:xfrm>
-            <a:off x="16689390" y="22118398"/>
-            <a:ext cx="8272139" cy="7104317"/>
-          </a:xfrm>
-          <a:prstGeom prst="rect">
-            <a:avLst/>
-          </a:prstGeom>
-          <a:noFill/>
-          <a:ln>
-            <a:solidFill>
-              <a:schemeClr val="tx1"/>
-            </a:solidFill>
-          </a:ln>
-        </p:spPr>
-        <p:txBody>
-          <a:bodyPr wrap="square" rtlCol="0">
-            <a:spAutoFit/>
-          </a:bodyPr>
-          <a:lstStyle/>
-          <a:p>
-            <a:pPr algn="ctr">
-              <a:lnSpc>
-                <a:spcPct val="150000"/>
-              </a:lnSpc>
-            </a:pPr>
-            <a:r>
-              <a:rPr lang="en-US" sz="4400" b="1" u="sng" dirty="0">
-                <a:latin typeface="Arial" panose="020B0604020202020204" pitchFamily="34" charset="0"/>
-                <a:cs typeface="Arial" panose="020B0604020202020204" pitchFamily="34" charset="0"/>
-              </a:rPr>
-              <a:t>Table with descriptive stats for databases</a:t>
-            </a:r>
-            <a:endParaRPr lang="en-US" sz="4400" dirty="0">
-              <a:latin typeface="Arial" panose="020B0604020202020204" pitchFamily="34" charset="0"/>
-              <a:cs typeface="Arial" panose="020B0604020202020204" pitchFamily="34" charset="0"/>
-            </a:endParaRPr>
-          </a:p>
-          <a:p>
-            <a:pPr marL="571500" indent="-571500">
-              <a:lnSpc>
-                <a:spcPct val="150000"/>
-              </a:lnSpc>
-              <a:buFont typeface="Arial" panose="020B0604020202020204" pitchFamily="34" charset="0"/>
-              <a:buChar char="•"/>
-            </a:pPr>
-            <a:r>
-              <a:rPr lang="en-US" sz="4400" dirty="0">
-                <a:latin typeface="Arial" panose="020B0604020202020204" pitchFamily="34" charset="0"/>
-                <a:cs typeface="Arial" panose="020B0604020202020204" pitchFamily="34" charset="0"/>
-              </a:rPr>
-              <a:t>scores from table below</a:t>
-            </a:r>
-          </a:p>
-          <a:p>
-            <a:pPr marL="571500" indent="-571500">
-              <a:lnSpc>
-                <a:spcPct val="150000"/>
-              </a:lnSpc>
-              <a:buFont typeface="Arial" panose="020B0604020202020204" pitchFamily="34" charset="0"/>
-              <a:buChar char="•"/>
-            </a:pPr>
-            <a:r>
-              <a:rPr lang="en-US" sz="4400" dirty="0">
-                <a:latin typeface="Arial" panose="020B0604020202020204" pitchFamily="34" charset="0"/>
-                <a:cs typeface="Arial" panose="020B0604020202020204" pitchFamily="34" charset="0"/>
-              </a:rPr>
-              <a:t>n primate variables</a:t>
-            </a:r>
-          </a:p>
-          <a:p>
-            <a:pPr marL="571500" indent="-571500">
-              <a:lnSpc>
-                <a:spcPct val="150000"/>
-              </a:lnSpc>
-              <a:buFont typeface="Arial" panose="020B0604020202020204" pitchFamily="34" charset="0"/>
-              <a:buChar char="•"/>
-            </a:pPr>
-            <a:r>
-              <a:rPr lang="en-US" sz="4400" dirty="0">
-                <a:latin typeface="Arial" panose="020B0604020202020204" pitchFamily="34" charset="0"/>
-                <a:cs typeface="Arial" panose="020B0604020202020204" pitchFamily="34" charset="0"/>
-              </a:rPr>
-              <a:t>p missing values for key traits</a:t>
-            </a:r>
-          </a:p>
-          <a:p>
-            <a:pPr marL="571500" indent="-571500">
-              <a:lnSpc>
-                <a:spcPct val="150000"/>
-              </a:lnSpc>
-              <a:buFont typeface="Arial" panose="020B0604020202020204" pitchFamily="34" charset="0"/>
-              <a:buChar char="•"/>
-            </a:pPr>
-            <a:r>
-              <a:rPr lang="en-US" sz="4400" dirty="0">
-                <a:latin typeface="Arial" panose="020B0604020202020204" pitchFamily="34" charset="0"/>
-                <a:cs typeface="Arial" panose="020B0604020202020204" pitchFamily="34" charset="0"/>
-              </a:rPr>
-              <a:t>n species</a:t>
-            </a:r>
-          </a:p>
-          <a:p>
-            <a:pPr marL="571500" indent="-571500">
-              <a:lnSpc>
-                <a:spcPct val="150000"/>
-              </a:lnSpc>
-              <a:buFont typeface="Arial" panose="020B0604020202020204" pitchFamily="34" charset="0"/>
-              <a:buChar char="•"/>
-            </a:pPr>
-            <a:r>
-              <a:rPr lang="en-US" sz="4400" dirty="0">
-                <a:latin typeface="Arial" panose="020B0604020202020204" pitchFamily="34" charset="0"/>
-                <a:cs typeface="Arial" panose="020B0604020202020204" pitchFamily="34" charset="0"/>
-              </a:rPr>
-              <a:t>etc.</a:t>
             </a:r>
           </a:p>
         </p:txBody>
@@ -4843,7 +4681,7 @@
           <p:nvPr/>
         </p:nvPicPr>
         <p:blipFill>
-          <a:blip r:embed="rId4"/>
+          <a:blip r:embed="rId3"/>
           <a:stretch>
             <a:fillRect/>
           </a:stretch>
@@ -4873,7 +4711,7 @@
           <p:nvPr/>
         </p:nvPicPr>
         <p:blipFill rotWithShape="1">
-          <a:blip r:embed="rId5">
+          <a:blip r:embed="rId4">
             <a:extLst>
               <a:ext uri="{28A0092B-C50C-407E-A947-70E740481C1C}">
                 <a14:useLocalDpi xmlns:a14="http://schemas.microsoft.com/office/drawing/2010/main" val="0"/>
@@ -4920,7 +4758,7 @@
           <p:nvPr/>
         </p:nvPicPr>
         <p:blipFill>
-          <a:blip r:embed="rId6"/>
+          <a:blip r:embed="rId5"/>
           <a:srcRect t="576" r="632" b="531"/>
           <a:stretch>
             <a:fillRect/>
@@ -5248,7 +5086,7 @@
         </p:nvSpPr>
         <p:spPr>
           <a:xfrm>
-            <a:off x="286410" y="24652261"/>
+            <a:off x="299864" y="26541434"/>
             <a:ext cx="3931921" cy="593047"/>
           </a:xfrm>
           <a:prstGeom prst="rect">
@@ -5283,6 +5121,776 @@
               <a:latin typeface="Arial" panose="020B0604020202020204" pitchFamily="34" charset="0"/>
               <a:cs typeface="Arial" panose="020B0604020202020204" pitchFamily="34" charset="0"/>
             </a:endParaRPr>
+          </a:p>
+        </p:txBody>
+      </p:sp>
+      <p:graphicFrame>
+        <p:nvGraphicFramePr>
+          <p:cNvPr id="6" name="Table 5">
+            <a:extLst>
+              <a:ext uri="{FF2B5EF4-FFF2-40B4-BE49-F238E27FC236}">
+                <a16:creationId xmlns:a16="http://schemas.microsoft.com/office/drawing/2014/main" id="{210694A0-A394-18DA-555B-5EF8C2E9B080}"/>
+              </a:ext>
+            </a:extLst>
+          </p:cNvPr>
+          <p:cNvGraphicFramePr>
+            <a:graphicFrameLocks noGrp="1"/>
+          </p:cNvGraphicFramePr>
+          <p:nvPr>
+            <p:extLst>
+              <p:ext uri="{D42A27DB-BD31-4B8C-83A1-F6EECF244321}">
+                <p14:modId xmlns:p14="http://schemas.microsoft.com/office/powerpoint/2010/main" val="2081878916"/>
+              </p:ext>
+            </p:extLst>
+          </p:nvPr>
+        </p:nvGraphicFramePr>
+        <p:xfrm>
+          <a:off x="13688043" y="22279769"/>
+          <a:ext cx="15149852" cy="3962400"/>
+        </p:xfrm>
+        <a:graphic>
+          <a:graphicData uri="http://schemas.openxmlformats.org/drawingml/2006/table">
+            <a:tbl>
+              <a:tblPr firstRow="1" bandRow="1">
+                <a:tableStyleId>{5C22544A-7EE6-4342-B048-85BDC9FD1C3A}</a:tableStyleId>
+              </a:tblPr>
+              <a:tblGrid>
+                <a:gridCol w="2048682">
+                  <a:extLst>
+                    <a:ext uri="{9D8B030D-6E8A-4147-A177-3AD203B41FA5}">
+                      <a16:colId xmlns:a16="http://schemas.microsoft.com/office/drawing/2014/main" val="2495585869"/>
+                    </a:ext>
+                  </a:extLst>
+                </a:gridCol>
+                <a:gridCol w="2495874">
+                  <a:extLst>
+                    <a:ext uri="{9D8B030D-6E8A-4147-A177-3AD203B41FA5}">
+                      <a16:colId xmlns:a16="http://schemas.microsoft.com/office/drawing/2014/main" val="3601265924"/>
+                    </a:ext>
+                  </a:extLst>
+                </a:gridCol>
+                <a:gridCol w="1504335">
+                  <a:extLst>
+                    <a:ext uri="{9D8B030D-6E8A-4147-A177-3AD203B41FA5}">
+                      <a16:colId xmlns:a16="http://schemas.microsoft.com/office/drawing/2014/main" val="984202891"/>
+                    </a:ext>
+                  </a:extLst>
+                </a:gridCol>
+                <a:gridCol w="2271252">
+                  <a:extLst>
+                    <a:ext uri="{9D8B030D-6E8A-4147-A177-3AD203B41FA5}">
+                      <a16:colId xmlns:a16="http://schemas.microsoft.com/office/drawing/2014/main" val="1450671555"/>
+                    </a:ext>
+                  </a:extLst>
+                </a:gridCol>
+                <a:gridCol w="1828800">
+                  <a:extLst>
+                    <a:ext uri="{9D8B030D-6E8A-4147-A177-3AD203B41FA5}">
+                      <a16:colId xmlns:a16="http://schemas.microsoft.com/office/drawing/2014/main" val="3671337353"/>
+                    </a:ext>
+                  </a:extLst>
+                </a:gridCol>
+                <a:gridCol w="2979174">
+                  <a:extLst>
+                    <a:ext uri="{9D8B030D-6E8A-4147-A177-3AD203B41FA5}">
+                      <a16:colId xmlns:a16="http://schemas.microsoft.com/office/drawing/2014/main" val="1165741138"/>
+                    </a:ext>
+                  </a:extLst>
+                </a:gridCol>
+                <a:gridCol w="2021735">
+                  <a:extLst>
+                    <a:ext uri="{9D8B030D-6E8A-4147-A177-3AD203B41FA5}">
+                      <a16:colId xmlns:a16="http://schemas.microsoft.com/office/drawing/2014/main" val="3607082557"/>
+                    </a:ext>
+                  </a:extLst>
+                </a:gridCol>
+              </a:tblGrid>
+              <a:tr h="376525">
+                <a:tc>
+                  <a:txBody>
+                    <a:bodyPr/>
+                    <a:lstStyle/>
+                    <a:p>
+                      <a:r>
+                        <a:rPr lang="en-US" sz="2800" b="1" dirty="0"/>
+                        <a:t>Source</a:t>
+                      </a:r>
+                    </a:p>
+                  </a:txBody>
+                  <a:tcPr/>
+                </a:tc>
+                <a:tc>
+                  <a:txBody>
+                    <a:bodyPr/>
+                    <a:lstStyle/>
+                    <a:p>
+                      <a:r>
+                        <a:rPr lang="en-US" sz="2800" dirty="0"/>
+                        <a:t>Actively Maintained?</a:t>
+                      </a:r>
+                    </a:p>
+                  </a:txBody>
+                  <a:tcPr/>
+                </a:tc>
+                <a:tc>
+                  <a:txBody>
+                    <a:bodyPr/>
+                    <a:lstStyle/>
+                    <a:p>
+                      <a:r>
+                        <a:rPr lang="en-US" sz="2800" dirty="0"/>
+                        <a:t>N species</a:t>
+                      </a:r>
+                    </a:p>
+                  </a:txBody>
+                  <a:tcPr/>
+                </a:tc>
+                <a:tc>
+                  <a:txBody>
+                    <a:bodyPr/>
+                    <a:lstStyle/>
+                    <a:p>
+                      <a:r>
+                        <a:rPr lang="en-US" sz="2800" dirty="0"/>
+                        <a:t>P species represented</a:t>
+                      </a:r>
+                    </a:p>
+                  </a:txBody>
+                  <a:tcPr/>
+                </a:tc>
+                <a:tc>
+                  <a:txBody>
+                    <a:bodyPr/>
+                    <a:lstStyle/>
+                    <a:p>
+                      <a:r>
+                        <a:rPr lang="en-US" sz="2800" dirty="0"/>
+                        <a:t>N LH stats</a:t>
+                      </a:r>
+                    </a:p>
+                  </a:txBody>
+                  <a:tcPr/>
+                </a:tc>
+                <a:tc>
+                  <a:txBody>
+                    <a:bodyPr/>
+                    <a:lstStyle/>
+                    <a:p>
+                      <a:r>
+                        <a:rPr lang="en-US" sz="2800" dirty="0"/>
+                        <a:t>P missing values (Key traits)</a:t>
+                      </a:r>
+                    </a:p>
+                  </a:txBody>
+                  <a:tcPr/>
+                </a:tc>
+                <a:tc>
+                  <a:txBody>
+                    <a:bodyPr/>
+                    <a:lstStyle/>
+                    <a:p>
+                      <a:r>
+                        <a:rPr lang="en-US" sz="2800" dirty="0"/>
+                        <a:t>P missing values (All)</a:t>
+                      </a:r>
+                    </a:p>
+                  </a:txBody>
+                  <a:tcPr/>
+                </a:tc>
+                <a:extLst>
+                  <a:ext uri="{0D108BD9-81ED-4DB2-BD59-A6C34878D82A}">
+                    <a16:rowId xmlns:a16="http://schemas.microsoft.com/office/drawing/2014/main" val="3004830895"/>
+                  </a:ext>
+                </a:extLst>
+              </a:tr>
+              <a:tr h="206482">
+                <a:tc>
+                  <a:txBody>
+                    <a:bodyPr/>
+                    <a:lstStyle/>
+                    <a:p>
+                      <a:r>
+                        <a:rPr lang="en-US" sz="2800" dirty="0"/>
+                        <a:t>Amniotes</a:t>
+                      </a:r>
+                    </a:p>
+                  </a:txBody>
+                  <a:tcPr/>
+                </a:tc>
+                <a:tc>
+                  <a:txBody>
+                    <a:bodyPr/>
+                    <a:lstStyle/>
+                    <a:p>
+                      <a:r>
+                        <a:rPr lang="en-US" sz="2800" dirty="0"/>
+                        <a:t>No</a:t>
+                      </a:r>
+                    </a:p>
+                  </a:txBody>
+                  <a:tcPr/>
+                </a:tc>
+                <a:tc>
+                  <a:txBody>
+                    <a:bodyPr/>
+                    <a:lstStyle/>
+                    <a:p>
+                      <a:r>
+                        <a:rPr lang="en-US" sz="2800" dirty="0"/>
+                        <a:t>365</a:t>
+                      </a:r>
+                    </a:p>
+                  </a:txBody>
+                  <a:tcPr/>
+                </a:tc>
+                <a:tc>
+                  <a:txBody>
+                    <a:bodyPr/>
+                    <a:lstStyle/>
+                    <a:p>
+                      <a:r>
+                        <a:rPr lang="en-US" sz="2800" dirty="0"/>
+                        <a:t>.68</a:t>
+                      </a:r>
+                    </a:p>
+                  </a:txBody>
+                  <a:tcPr/>
+                </a:tc>
+                <a:tc>
+                  <a:txBody>
+                    <a:bodyPr/>
+                    <a:lstStyle/>
+                    <a:p>
+                      <a:r>
+                        <a:rPr lang="en-US" sz="2800" dirty="0"/>
+                        <a:t>23</a:t>
+                      </a:r>
+                    </a:p>
+                  </a:txBody>
+                  <a:tcPr/>
+                </a:tc>
+                <a:tc>
+                  <a:txBody>
+                    <a:bodyPr/>
+                    <a:lstStyle/>
+                    <a:p>
+                      <a:r>
+                        <a:rPr lang="en-US" sz="2800" dirty="0"/>
+                        <a:t>.34</a:t>
+                      </a:r>
+                    </a:p>
+                  </a:txBody>
+                  <a:tcPr/>
+                </a:tc>
+                <a:tc>
+                  <a:txBody>
+                    <a:bodyPr/>
+                    <a:lstStyle/>
+                    <a:p>
+                      <a:r>
+                        <a:rPr lang="en-US" sz="2800" dirty="0"/>
+                        <a:t>.54</a:t>
+                      </a:r>
+                    </a:p>
+                  </a:txBody>
+                  <a:tcPr/>
+                </a:tc>
+                <a:extLst>
+                  <a:ext uri="{0D108BD9-81ED-4DB2-BD59-A6C34878D82A}">
+                    <a16:rowId xmlns:a16="http://schemas.microsoft.com/office/drawing/2014/main" val="1504921128"/>
+                  </a:ext>
+                </a:extLst>
+              </a:tr>
+              <a:tr h="206482">
+                <a:tc>
+                  <a:txBody>
+                    <a:bodyPr/>
+                    <a:lstStyle/>
+                    <a:p>
+                      <a:r>
+                        <a:rPr lang="en-US" sz="2800" dirty="0" err="1"/>
+                        <a:t>AnAge</a:t>
+                      </a:r>
+                      <a:endParaRPr lang="en-US" sz="2800" dirty="0"/>
+                    </a:p>
+                  </a:txBody>
+                  <a:tcPr/>
+                </a:tc>
+                <a:tc>
+                  <a:txBody>
+                    <a:bodyPr/>
+                    <a:lstStyle/>
+                    <a:p>
+                      <a:r>
+                        <a:rPr lang="en-US" sz="2800" dirty="0"/>
+                        <a:t>Yes</a:t>
+                      </a:r>
+                    </a:p>
+                  </a:txBody>
+                  <a:tcPr/>
+                </a:tc>
+                <a:tc>
+                  <a:txBody>
+                    <a:bodyPr/>
+                    <a:lstStyle/>
+                    <a:p>
+                      <a:r>
+                        <a:rPr lang="en-US" sz="2800" dirty="0"/>
+                        <a:t>174</a:t>
+                      </a:r>
+                    </a:p>
+                  </a:txBody>
+                  <a:tcPr/>
+                </a:tc>
+                <a:tc>
+                  <a:txBody>
+                    <a:bodyPr/>
+                    <a:lstStyle/>
+                    <a:p>
+                      <a:r>
+                        <a:rPr lang="en-US" sz="2800" dirty="0"/>
+                        <a:t>.33</a:t>
+                      </a:r>
+                    </a:p>
+                  </a:txBody>
+                  <a:tcPr/>
+                </a:tc>
+                <a:tc>
+                  <a:txBody>
+                    <a:bodyPr/>
+                    <a:lstStyle/>
+                    <a:p>
+                      <a:r>
+                        <a:rPr lang="en-US" sz="2800" dirty="0"/>
+                        <a:t>19</a:t>
+                      </a:r>
+                    </a:p>
+                  </a:txBody>
+                  <a:tcPr/>
+                </a:tc>
+                <a:tc>
+                  <a:txBody>
+                    <a:bodyPr/>
+                    <a:lstStyle/>
+                    <a:p>
+                      <a:r>
+                        <a:rPr lang="en-US" sz="2800" dirty="0"/>
+                        <a:t>.37</a:t>
+                      </a:r>
+                    </a:p>
+                  </a:txBody>
+                  <a:tcPr/>
+                </a:tc>
+                <a:tc>
+                  <a:txBody>
+                    <a:bodyPr/>
+                    <a:lstStyle/>
+                    <a:p>
+                      <a:r>
+                        <a:rPr lang="en-US" sz="2800" dirty="0"/>
+                        <a:t>.46</a:t>
+                      </a:r>
+                    </a:p>
+                  </a:txBody>
+                  <a:tcPr/>
+                </a:tc>
+                <a:extLst>
+                  <a:ext uri="{0D108BD9-81ED-4DB2-BD59-A6C34878D82A}">
+                    <a16:rowId xmlns:a16="http://schemas.microsoft.com/office/drawing/2014/main" val="1182304281"/>
+                  </a:ext>
+                </a:extLst>
+              </a:tr>
+              <a:tr h="206482">
+                <a:tc>
+                  <a:txBody>
+                    <a:bodyPr/>
+                    <a:lstStyle/>
+                    <a:p>
+                      <a:r>
+                        <a:rPr lang="en-US" sz="2800" dirty="0"/>
+                        <a:t>Ernest</a:t>
+                      </a:r>
+                    </a:p>
+                  </a:txBody>
+                  <a:tcPr/>
+                </a:tc>
+                <a:tc>
+                  <a:txBody>
+                    <a:bodyPr/>
+                    <a:lstStyle/>
+                    <a:p>
+                      <a:r>
+                        <a:rPr lang="en-US" sz="2800" dirty="0"/>
+                        <a:t>No</a:t>
+                      </a:r>
+                    </a:p>
+                  </a:txBody>
+                  <a:tcPr/>
+                </a:tc>
+                <a:tc>
+                  <a:txBody>
+                    <a:bodyPr/>
+                    <a:lstStyle/>
+                    <a:p>
+                      <a:r>
+                        <a:rPr lang="en-US" sz="2800" dirty="0"/>
+                        <a:t>156</a:t>
+                      </a:r>
+                    </a:p>
+                  </a:txBody>
+                  <a:tcPr/>
+                </a:tc>
+                <a:tc>
+                  <a:txBody>
+                    <a:bodyPr/>
+                    <a:lstStyle/>
+                    <a:p>
+                      <a:r>
+                        <a:rPr lang="en-US" sz="2800" dirty="0"/>
+                        <a:t>.29</a:t>
+                      </a:r>
+                    </a:p>
+                  </a:txBody>
+                  <a:tcPr/>
+                </a:tc>
+                <a:tc>
+                  <a:txBody>
+                    <a:bodyPr/>
+                    <a:lstStyle/>
+                    <a:p>
+                      <a:r>
+                        <a:rPr lang="en-US" sz="2800" dirty="0"/>
+                        <a:t>9</a:t>
+                      </a:r>
+                    </a:p>
+                  </a:txBody>
+                  <a:tcPr/>
+                </a:tc>
+                <a:tc>
+                  <a:txBody>
+                    <a:bodyPr/>
+                    <a:lstStyle/>
+                    <a:p>
+                      <a:r>
+                        <a:rPr lang="en-US" sz="2800" dirty="0"/>
+                        <a:t>.31</a:t>
+                      </a:r>
+                    </a:p>
+                  </a:txBody>
+                  <a:tcPr/>
+                </a:tc>
+                <a:tc>
+                  <a:txBody>
+                    <a:bodyPr/>
+                    <a:lstStyle/>
+                    <a:p>
+                      <a:r>
+                        <a:rPr lang="en-US" sz="2800" dirty="0"/>
+                        <a:t>.32</a:t>
+                      </a:r>
+                    </a:p>
+                  </a:txBody>
+                  <a:tcPr/>
+                </a:tc>
+                <a:extLst>
+                  <a:ext uri="{0D108BD9-81ED-4DB2-BD59-A6C34878D82A}">
+                    <a16:rowId xmlns:a16="http://schemas.microsoft.com/office/drawing/2014/main" val="4040463589"/>
+                  </a:ext>
+                </a:extLst>
+              </a:tr>
+              <a:tr h="376525">
+                <a:tc>
+                  <a:txBody>
+                    <a:bodyPr/>
+                    <a:lstStyle/>
+                    <a:p>
+                      <a:r>
+                        <a:rPr lang="en-US" sz="2800" dirty="0"/>
+                        <a:t>Kappeler &amp; Pereira</a:t>
+                      </a:r>
+                    </a:p>
+                  </a:txBody>
+                  <a:tcPr/>
+                </a:tc>
+                <a:tc>
+                  <a:txBody>
+                    <a:bodyPr/>
+                    <a:lstStyle/>
+                    <a:p>
+                      <a:r>
+                        <a:rPr lang="en-US" sz="2800" dirty="0"/>
+                        <a:t>No</a:t>
+                      </a:r>
+                    </a:p>
+                  </a:txBody>
+                  <a:tcPr/>
+                </a:tc>
+                <a:tc>
+                  <a:txBody>
+                    <a:bodyPr/>
+                    <a:lstStyle/>
+                    <a:p>
+                      <a:r>
+                        <a:rPr lang="en-US" sz="2800" dirty="0"/>
+                        <a:t>310</a:t>
+                      </a:r>
+                    </a:p>
+                  </a:txBody>
+                  <a:tcPr/>
+                </a:tc>
+                <a:tc>
+                  <a:txBody>
+                    <a:bodyPr/>
+                    <a:lstStyle/>
+                    <a:p>
+                      <a:r>
+                        <a:rPr lang="en-US" sz="2800" dirty="0"/>
+                        <a:t>.58</a:t>
+                      </a:r>
+                    </a:p>
+                  </a:txBody>
+                  <a:tcPr/>
+                </a:tc>
+                <a:tc>
+                  <a:txBody>
+                    <a:bodyPr/>
+                    <a:lstStyle/>
+                    <a:p>
+                      <a:r>
+                        <a:rPr lang="en-US" sz="2800" dirty="0"/>
+                        <a:t>13</a:t>
+                      </a:r>
+                    </a:p>
+                  </a:txBody>
+                  <a:tcPr/>
+                </a:tc>
+                <a:tc>
+                  <a:txBody>
+                    <a:bodyPr/>
+                    <a:lstStyle/>
+                    <a:p>
+                      <a:r>
+                        <a:rPr lang="en-US" sz="2800" dirty="0"/>
+                        <a:t>.69</a:t>
+                      </a:r>
+                    </a:p>
+                  </a:txBody>
+                  <a:tcPr/>
+                </a:tc>
+                <a:tc>
+                  <a:txBody>
+                    <a:bodyPr/>
+                    <a:lstStyle/>
+                    <a:p>
+                      <a:r>
+                        <a:rPr lang="en-US" sz="2800" dirty="0"/>
+                        <a:t>.76</a:t>
+                      </a:r>
+                    </a:p>
+                  </a:txBody>
+                  <a:tcPr/>
+                </a:tc>
+                <a:extLst>
+                  <a:ext uri="{0D108BD9-81ED-4DB2-BD59-A6C34878D82A}">
+                    <a16:rowId xmlns:a16="http://schemas.microsoft.com/office/drawing/2014/main" val="3353418559"/>
+                  </a:ext>
+                </a:extLst>
+              </a:tr>
+              <a:tr h="206482">
+                <a:tc>
+                  <a:txBody>
+                    <a:bodyPr/>
+                    <a:lstStyle/>
+                    <a:p>
+                      <a:r>
+                        <a:rPr lang="en-US" sz="2800" dirty="0" err="1"/>
+                        <a:t>PanTHERIA</a:t>
+                      </a:r>
+                      <a:endParaRPr lang="en-US" sz="2800" dirty="0"/>
+                    </a:p>
+                  </a:txBody>
+                  <a:tcPr/>
+                </a:tc>
+                <a:tc>
+                  <a:txBody>
+                    <a:bodyPr/>
+                    <a:lstStyle/>
+                    <a:p>
+                      <a:r>
+                        <a:rPr lang="en-US" sz="2800" dirty="0"/>
+                        <a:t>No</a:t>
+                      </a:r>
+                    </a:p>
+                  </a:txBody>
+                  <a:tcPr/>
+                </a:tc>
+                <a:tc>
+                  <a:txBody>
+                    <a:bodyPr/>
+                    <a:lstStyle/>
+                    <a:p>
+                      <a:r>
+                        <a:rPr lang="en-US" sz="2800" dirty="0"/>
+                        <a:t>376</a:t>
+                      </a:r>
+                    </a:p>
+                  </a:txBody>
+                  <a:tcPr/>
+                </a:tc>
+                <a:tc>
+                  <a:txBody>
+                    <a:bodyPr/>
+                    <a:lstStyle/>
+                    <a:p>
+                      <a:r>
+                        <a:rPr lang="en-US" sz="2800" dirty="0"/>
+                        <a:t>.70</a:t>
+                      </a:r>
+                    </a:p>
+                  </a:txBody>
+                  <a:tcPr/>
+                </a:tc>
+                <a:tc>
+                  <a:txBody>
+                    <a:bodyPr/>
+                    <a:lstStyle/>
+                    <a:p>
+                      <a:r>
+                        <a:rPr lang="en-US" sz="2800" dirty="0"/>
+                        <a:t>29</a:t>
+                      </a:r>
+                    </a:p>
+                  </a:txBody>
+                  <a:tcPr/>
+                </a:tc>
+                <a:tc>
+                  <a:txBody>
+                    <a:bodyPr/>
+                    <a:lstStyle/>
+                    <a:p>
+                      <a:r>
+                        <a:rPr lang="en-US" sz="2800" dirty="0"/>
+                        <a:t>.63</a:t>
+                      </a:r>
+                    </a:p>
+                  </a:txBody>
+                  <a:tcPr/>
+                </a:tc>
+                <a:tc>
+                  <a:txBody>
+                    <a:bodyPr/>
+                    <a:lstStyle/>
+                    <a:p>
+                      <a:r>
+                        <a:rPr lang="en-US" sz="2800" dirty="0"/>
+                        <a:t>.72</a:t>
+                      </a:r>
+                    </a:p>
+                  </a:txBody>
+                  <a:tcPr/>
+                </a:tc>
+                <a:extLst>
+                  <a:ext uri="{0D108BD9-81ED-4DB2-BD59-A6C34878D82A}">
+                    <a16:rowId xmlns:a16="http://schemas.microsoft.com/office/drawing/2014/main" val="1345818191"/>
+                  </a:ext>
+                </a:extLst>
+              </a:tr>
+            </a:tbl>
+          </a:graphicData>
+        </a:graphic>
+      </p:graphicFrame>
+      <p:pic>
+        <p:nvPicPr>
+          <p:cNvPr id="11" name="Picture 10">
+            <a:extLst>
+              <a:ext uri="{FF2B5EF4-FFF2-40B4-BE49-F238E27FC236}">
+                <a16:creationId xmlns:a16="http://schemas.microsoft.com/office/drawing/2014/main" id="{3422488E-57F3-7910-F955-AE55A30FD5E9}"/>
+              </a:ext>
+            </a:extLst>
+          </p:cNvPr>
+          <p:cNvPicPr>
+            <a:picLocks noChangeAspect="1"/>
+          </p:cNvPicPr>
+          <p:nvPr/>
+        </p:nvPicPr>
+        <p:blipFill>
+          <a:blip r:embed="rId6"/>
+          <a:stretch>
+            <a:fillRect/>
+          </a:stretch>
+        </p:blipFill>
+        <p:spPr>
+          <a:xfrm>
+            <a:off x="4892222" y="26691004"/>
+            <a:ext cx="10298811" cy="9351596"/>
+          </a:xfrm>
+          <a:prstGeom prst="rect">
+            <a:avLst/>
+          </a:prstGeom>
+          <a:ln w="38100">
+            <a:solidFill>
+              <a:schemeClr val="accent1"/>
+            </a:solidFill>
+          </a:ln>
+        </p:spPr>
+      </p:pic>
+      <p:sp>
+        <p:nvSpPr>
+          <p:cNvPr id="15" name="TextBox 14">
+            <a:extLst>
+              <a:ext uri="{FF2B5EF4-FFF2-40B4-BE49-F238E27FC236}">
+                <a16:creationId xmlns:a16="http://schemas.microsoft.com/office/drawing/2014/main" id="{D27A7744-9494-CE5D-21E0-EC7C48E39EE3}"/>
+              </a:ext>
+            </a:extLst>
+          </p:cNvPr>
+          <p:cNvSpPr txBox="1"/>
+          <p:nvPr/>
+        </p:nvSpPr>
+        <p:spPr>
+          <a:xfrm>
+            <a:off x="13694799" y="20895394"/>
+            <a:ext cx="15143096" cy="1384995"/>
+          </a:xfrm>
+          <a:prstGeom prst="rect">
+            <a:avLst/>
+          </a:prstGeom>
+          <a:noFill/>
+        </p:spPr>
+        <p:txBody>
+          <a:bodyPr wrap="square" rtlCol="0">
+            <a:spAutoFit/>
+          </a:bodyPr>
+          <a:lstStyle/>
+          <a:p>
+            <a:r>
+              <a:rPr lang="en-US" sz="2800" b="1" dirty="0">
+                <a:latin typeface="Arial" panose="020B0604020202020204" pitchFamily="34" charset="0"/>
+                <a:cs typeface="Arial" panose="020B0604020202020204" pitchFamily="34" charset="0"/>
+              </a:rPr>
+              <a:t>Table 1. </a:t>
+            </a:r>
+            <a:r>
+              <a:rPr lang="en-US" sz="2800" dirty="0">
+                <a:latin typeface="Arial" panose="020B0604020202020204" pitchFamily="34" charset="0"/>
+                <a:cs typeface="Arial" panose="020B0604020202020204" pitchFamily="34" charset="0"/>
+              </a:rPr>
+              <a:t>Descriptive statistics of primate life-history statistics for each database. </a:t>
+            </a:r>
+            <a:r>
+              <a:rPr lang="en-US" sz="2800" dirty="0" err="1">
+                <a:latin typeface="Arial" panose="020B0604020202020204" pitchFamily="34" charset="0"/>
+                <a:cs typeface="Arial" panose="020B0604020202020204" pitchFamily="34" charset="0"/>
+              </a:rPr>
+              <a:t>AnAge</a:t>
+            </a:r>
+            <a:r>
+              <a:rPr lang="en-US" sz="2800" dirty="0">
+                <a:latin typeface="Arial" panose="020B0604020202020204" pitchFamily="34" charset="0"/>
+                <a:cs typeface="Arial" panose="020B0604020202020204" pitchFamily="34" charset="0"/>
+              </a:rPr>
+              <a:t> is the only database that is continually updated, with its last update in 2023. Each database has fewer missing values for our selected key life-history traits compared with reported statistics.</a:t>
+            </a:r>
+            <a:endParaRPr lang="en-US" sz="2800" dirty="0"/>
           </a:p>
         </p:txBody>
       </p:sp>

</xml_diff>

<commit_message>
continued writing and spot checking, added section for determining least complete trait
</commit_message>
<xml_diff>
--- a/AABA-Poster/GM-AABA2026Poster-Draft3.pptx
+++ b/AABA-Poster/GM-AABA2026Poster-Draft3.pptx
@@ -3377,21 +3377,7 @@
                 <a:latin typeface="Arial" panose="020B0604020202020204" pitchFamily="34" charset="0"/>
                 <a:cs typeface="Arial" panose="020B0604020202020204" pitchFamily="34" charset="0"/>
               </a:rPr>
-              <a:t>Jones, K. E., Bielby, J., Cardillo, M., et al. (2009). </a:t>
-            </a:r>
-            <a:r>
-              <a:rPr lang="en-US" dirty="0" err="1">
-                <a:latin typeface="Arial" panose="020B0604020202020204" pitchFamily="34" charset="0"/>
-                <a:cs typeface="Arial" panose="020B0604020202020204" pitchFamily="34" charset="0"/>
-              </a:rPr>
-              <a:t>PanTHERIA</a:t>
-            </a:r>
-            <a:r>
-              <a:rPr lang="en-US" dirty="0">
-                <a:latin typeface="Arial" panose="020B0604020202020204" pitchFamily="34" charset="0"/>
-                <a:cs typeface="Arial" panose="020B0604020202020204" pitchFamily="34" charset="0"/>
-              </a:rPr>
-              <a:t>: A species-level database of life history, ecology, and geography of extant and recently extinct mammals. Ecology, 90(9), 2648–2648. </a:t>
+              <a:t>Jones, K. E., Bielby, J., Cardillo, M., et al. (2009). PanTHERIA: A species-level database of life history, ecology, and geography of extant and recently extinct mammals. Ecology, 90(9), 2648–2648. </a:t>
             </a:r>
           </a:p>
           <a:p>
@@ -3505,21 +3491,7 @@
                 <a:latin typeface="Arial" panose="020B0604020202020204" pitchFamily="34" charset="0"/>
                 <a:cs typeface="Arial" panose="020B0604020202020204" pitchFamily="34" charset="0"/>
               </a:rPr>
-              <a:t> KB, Altmann J, Brockman DK, et al. (2010) The Primate Life History Database: A unique shared ecological data resource. Methods </a:t>
-            </a:r>
-            <a:r>
-              <a:rPr lang="en-US" dirty="0" err="1">
-                <a:latin typeface="Arial" panose="020B0604020202020204" pitchFamily="34" charset="0"/>
-                <a:cs typeface="Arial" panose="020B0604020202020204" pitchFamily="34" charset="0"/>
-              </a:rPr>
-              <a:t>Ecol</a:t>
-            </a:r>
-            <a:r>
-              <a:rPr lang="en-US" dirty="0">
-                <a:latin typeface="Arial" panose="020B0604020202020204" pitchFamily="34" charset="0"/>
-                <a:cs typeface="Arial" panose="020B0604020202020204" pitchFamily="34" charset="0"/>
-              </a:rPr>
-              <a:t> Evol., 1(2):199-211.</a:t>
+              <a:t> KB, Altmann J, Brockman DK, et al. (2010) The Primate Life History Database: A unique shared ecological data resource. Methods Ecol Evol., 1(2):199-211.</a:t>
             </a:r>
           </a:p>
         </p:txBody>
@@ -3703,8 +3675,8 @@
         </p:nvSpPr>
         <p:spPr>
           <a:xfrm>
-            <a:off x="29305206" y="5466463"/>
-            <a:ext cx="8488295" cy="22080083"/>
+            <a:off x="28991530" y="5466463"/>
+            <a:ext cx="9022919" cy="20141091"/>
           </a:xfrm>
           <a:custGeom>
             <a:avLst/>
@@ -3941,7 +3913,7 @@
                 <a:latin typeface="Arial" panose="020B0604020202020204" pitchFamily="34" charset="0"/>
                 <a:cs typeface="Arial" panose="020B0604020202020204" pitchFamily="34" charset="0"/>
               </a:rPr>
-              <a:t>We generated descriptive statistics of the data (i.e. n species, n variables, etc.) to compare their structures and find common variables.</a:t>
+              <a:t>We generated descriptive statistics of the data to compare their structures and find common variables.</a:t>
             </a:r>
           </a:p>
           <a:p>
@@ -3973,7 +3945,7 @@
                 <a:latin typeface="Arial" panose="020B0604020202020204" pitchFamily="34" charset="0"/>
                 <a:cs typeface="Arial" panose="020B0604020202020204" pitchFamily="34" charset="0"/>
               </a:rPr>
-              <a:t>We compared these datasets using three metrics:</a:t>
+              <a:t>We compared these datasets using three metrics: The presence of values, taxonomic representation, and metadata accessibility and content.</a:t>
             </a:r>
           </a:p>
           <a:p>
@@ -3989,22 +3961,6 @@
                 <a:latin typeface="Arial" panose="020B0604020202020204" pitchFamily="34" charset="0"/>
                 <a:cs typeface="Arial" panose="020B0604020202020204" pitchFamily="34" charset="0"/>
               </a:rPr>
-              <a:t>The presence of values for key traits:</a:t>
-            </a:r>
-          </a:p>
-          <a:p>
-            <a:pPr marL="1371600" lvl="2" indent="-457200">
-              <a:lnSpc>
-                <a:spcPct val="150000"/>
-              </a:lnSpc>
-              <a:buFont typeface="Wingdings" panose="05000000000000000000" pitchFamily="2" charset="2"/>
-              <a:buChar char="v"/>
-            </a:pPr>
-            <a:r>
-              <a:rPr lang="en-US" sz="2800" dirty="0">
-                <a:latin typeface="Arial" panose="020B0604020202020204" pitchFamily="34" charset="0"/>
-                <a:cs typeface="Arial" panose="020B0604020202020204" pitchFamily="34" charset="0"/>
-              </a:rPr>
               <a:t>For each database, we quantified the proportion of values equivalent to “NA” for all available key traits for each species.</a:t>
             </a:r>
           </a:p>
@@ -4021,22 +3977,6 @@
                 <a:latin typeface="Arial" panose="020B0604020202020204" pitchFamily="34" charset="0"/>
                 <a:cs typeface="Arial" panose="020B0604020202020204" pitchFamily="34" charset="0"/>
               </a:rPr>
-              <a:t>Taxonomic representation and biases:</a:t>
-            </a:r>
-          </a:p>
-          <a:p>
-            <a:pPr marL="1371600" lvl="2" indent="-457200">
-              <a:lnSpc>
-                <a:spcPct val="150000"/>
-              </a:lnSpc>
-              <a:buFont typeface="Wingdings" panose="05000000000000000000" pitchFamily="2" charset="2"/>
-              <a:buChar char="v"/>
-            </a:pPr>
-            <a:r>
-              <a:rPr lang="en-US" sz="2800" dirty="0">
-                <a:latin typeface="Arial" panose="020B0604020202020204" pitchFamily="34" charset="0"/>
-                <a:cs typeface="Arial" panose="020B0604020202020204" pitchFamily="34" charset="0"/>
-              </a:rPr>
               <a:t>We quantified the relative proportions of primate species at the family level and compared each database to examine biases in species coverage.</a:t>
             </a:r>
           </a:p>
@@ -4053,11 +3993,11 @@
                 <a:latin typeface="Arial" panose="020B0604020202020204" pitchFamily="34" charset="0"/>
                 <a:cs typeface="Arial" panose="020B0604020202020204" pitchFamily="34" charset="0"/>
               </a:rPr>
-              <a:t>Metadata accessibility and content:</a:t>
-            </a:r>
-          </a:p>
-          <a:p>
-            <a:pPr marL="1371600" lvl="2" indent="-457200">
+              <a:t>We designed a rubric to objectively score the metadata availability, accessibility, and content of each dataset.</a:t>
+            </a:r>
+          </a:p>
+          <a:p>
+            <a:pPr marL="914400" lvl="1" indent="-457200">
               <a:lnSpc>
                 <a:spcPct val="150000"/>
               </a:lnSpc>
@@ -4069,23 +4009,7 @@
                 <a:latin typeface="Arial" panose="020B0604020202020204" pitchFamily="34" charset="0"/>
                 <a:cs typeface="Arial" panose="020B0604020202020204" pitchFamily="34" charset="0"/>
               </a:rPr>
-              <a:t>We designed a rubric to objectively score the metadata availability, accessibility, and content of each dataset.</a:t>
-            </a:r>
-          </a:p>
-          <a:p>
-            <a:pPr marL="1371600" lvl="2" indent="-457200">
-              <a:lnSpc>
-                <a:spcPct val="150000"/>
-              </a:lnSpc>
-              <a:buFont typeface="Wingdings" panose="05000000000000000000" pitchFamily="2" charset="2"/>
-              <a:buChar char="v"/>
-            </a:pPr>
-            <a:r>
-              <a:rPr lang="en-US" sz="2800" dirty="0">
-                <a:latin typeface="Arial" panose="020B0604020202020204" pitchFamily="34" charset="0"/>
-                <a:cs typeface="Arial" panose="020B0604020202020204" pitchFamily="34" charset="0"/>
-              </a:rPr>
-              <a:t>We quantified the proportion of variables described by the authors and evaluated the detail of description based on the presence of variable units, statistic type, and citation.</a:t>
+              <a:t>We categorically scored the proportion of variables described by the authors and evaluated the detail of description based on the presence of variable units, measurement type, and citation.</a:t>
             </a:r>
           </a:p>
           <a:p>
@@ -4101,7 +4025,7 @@
                 <a:latin typeface="Arial" panose="020B0604020202020204" pitchFamily="34" charset="0"/>
                 <a:cs typeface="Arial" panose="020B0604020202020204" pitchFamily="34" charset="0"/>
               </a:rPr>
-              <a:t>Additionally, we attempted to validate the division of age of sexual maturity across species into sex classes by comparison to the dimorphism rates of body mass.</a:t>
+              <a:t>Additionally, we attempted to validate the division of age of sexual maturity (ASM) into sex classes by comparison to the dimorphism rates of adult body mass using Wilcoxon rank sum and signed rank tests with continuity corrections .</a:t>
             </a:r>
           </a:p>
         </p:txBody>
@@ -4116,14 +4040,14 @@
             </a:extLst>
           </p:cNvPr>
           <p:cNvSpPr txBox="1">
-            <a:spLocks/>
+            <a:spLocks noChangeAspect="1"/>
           </p:cNvSpPr>
           <p:nvPr/>
         </p:nvSpPr>
         <p:spPr>
           <a:xfrm>
-            <a:off x="4892224" y="5485289"/>
-            <a:ext cx="8488295" cy="20756880"/>
+            <a:off x="4736692" y="5485290"/>
+            <a:ext cx="8488295" cy="20848320"/>
           </a:xfrm>
           <a:prstGeom prst="rect">
             <a:avLst/>
@@ -4165,11 +4089,18 @@
               <a:buChar char="v"/>
             </a:pPr>
             <a:r>
+              <a:rPr lang="en-US" sz="2800" b="1" dirty="0">
+                <a:latin typeface="Arial" panose="020B0604020202020204" pitchFamily="34" charset="0"/>
+                <a:cs typeface="Arial" panose="020B0604020202020204" pitchFamily="34" charset="0"/>
+              </a:rPr>
+              <a:t>Life history (LH) theory </a:t>
+            </a:r>
+            <a:r>
               <a:rPr lang="en-US" sz="2800" dirty="0">
                 <a:latin typeface="Arial" panose="020B0604020202020204" pitchFamily="34" charset="0"/>
                 <a:cs typeface="Arial" panose="020B0604020202020204" pitchFamily="34" charset="0"/>
               </a:rPr>
-              <a:t>Life history (LH) theory provides us with a lexicon of variables that characterize the timing and durations of growth and reproduction to maximize fitness. [5, 10]</a:t>
+              <a:t>provides us with a lexicon of variables that characterize the timing and durations of growth and reproduction to maximize fitness. [5, 10]</a:t>
             </a:r>
           </a:p>
           <a:p>
@@ -4185,7 +4116,21 @@
                 <a:latin typeface="Arial" panose="020B0604020202020204" pitchFamily="34" charset="0"/>
                 <a:cs typeface="Arial" panose="020B0604020202020204" pitchFamily="34" charset="0"/>
               </a:rPr>
-              <a:t>Quantifying life history traits requires abundant, high-quality, longitudinal data to observe and infer population-level rates. [5, 11]</a:t>
+              <a:t>Quantifying life history traits requires </a:t>
+            </a:r>
+            <a:r>
+              <a:rPr lang="en-US" sz="2800" b="1" dirty="0">
+                <a:latin typeface="Arial" panose="020B0604020202020204" pitchFamily="34" charset="0"/>
+                <a:cs typeface="Arial" panose="020B0604020202020204" pitchFamily="34" charset="0"/>
+              </a:rPr>
+              <a:t>abundant, high-quality, longitudinal data</a:t>
+            </a:r>
+            <a:r>
+              <a:rPr lang="en-US" sz="2800" dirty="0">
+                <a:latin typeface="Arial" panose="020B0604020202020204" pitchFamily="34" charset="0"/>
+                <a:cs typeface="Arial" panose="020B0604020202020204" pitchFamily="34" charset="0"/>
+              </a:rPr>
+              <a:t> to observe and infer population-level rates. [5, 11]</a:t>
             </a:r>
           </a:p>
           <a:p>
@@ -4201,7 +4146,21 @@
                 <a:latin typeface="Arial" panose="020B0604020202020204" pitchFamily="34" charset="0"/>
                 <a:cs typeface="Arial" panose="020B0604020202020204" pitchFamily="34" charset="0"/>
               </a:rPr>
-              <a:t>Life history strategies are defined by covariation [11], complicating investigations when some traits are unrecorded for a focal species.</a:t>
+              <a:t>Life history strategies are defined by covariation [11], complicating investigations when </a:t>
+            </a:r>
+            <a:r>
+              <a:rPr lang="en-US" sz="2800" b="1" dirty="0">
+                <a:latin typeface="Arial" panose="020B0604020202020204" pitchFamily="34" charset="0"/>
+                <a:cs typeface="Arial" panose="020B0604020202020204" pitchFamily="34" charset="0"/>
+              </a:rPr>
+              <a:t>some traits are unrecorded</a:t>
+            </a:r>
+            <a:r>
+              <a:rPr lang="en-US" sz="2800" dirty="0">
+                <a:latin typeface="Arial" panose="020B0604020202020204" pitchFamily="34" charset="0"/>
+                <a:cs typeface="Arial" panose="020B0604020202020204" pitchFamily="34" charset="0"/>
+              </a:rPr>
+              <a:t> for a focal species.</a:t>
             </a:r>
           </a:p>
           <a:p>
@@ -4217,7 +4176,21 @@
                 <a:latin typeface="Arial" panose="020B0604020202020204" pitchFamily="34" charset="0"/>
                 <a:cs typeface="Arial" panose="020B0604020202020204" pitchFamily="34" charset="0"/>
               </a:rPr>
-              <a:t>Researchers face consistent methodological challenges in collating LH data for inter-species comparisons [1, 5, 11, 12], such as:</a:t>
+              <a:t>Researchers face consistent </a:t>
+            </a:r>
+            <a:r>
+              <a:rPr lang="en-US" sz="2800" b="1" dirty="0">
+                <a:latin typeface="Arial" panose="020B0604020202020204" pitchFamily="34" charset="0"/>
+                <a:cs typeface="Arial" panose="020B0604020202020204" pitchFamily="34" charset="0"/>
+              </a:rPr>
+              <a:t>methodological challenges</a:t>
+            </a:r>
+            <a:r>
+              <a:rPr lang="en-US" sz="2800" dirty="0">
+                <a:latin typeface="Arial" panose="020B0604020202020204" pitchFamily="34" charset="0"/>
+                <a:cs typeface="Arial" panose="020B0604020202020204" pitchFamily="34" charset="0"/>
+              </a:rPr>
+              <a:t> in collating LH data for inter-species comparisons [1, 5, 11, 12], such as:</a:t>
             </a:r>
             <a:r>
               <a:rPr lang="en-US" sz="2800" strike="sngStrike" dirty="0">
@@ -4314,7 +4287,7 @@
         </p:nvSpPr>
         <p:spPr>
           <a:xfrm>
-            <a:off x="5632418" y="18023770"/>
+            <a:off x="5476886" y="18023771"/>
             <a:ext cx="7007905" cy="7878503"/>
           </a:xfrm>
           <a:prstGeom prst="rect">
@@ -4359,35 +4332,7 @@
                 <a:latin typeface="Arial" panose="020B0604020202020204" pitchFamily="34" charset="0"/>
                 <a:cs typeface="Arial" panose="020B0604020202020204" pitchFamily="34" charset="0"/>
               </a:rPr>
-              <a:t>To examine the primate LH characteristics of the Ernest [2], </a:t>
-            </a:r>
-            <a:r>
-              <a:rPr lang="en-US" sz="2800" dirty="0" err="1">
-                <a:latin typeface="Arial" panose="020B0604020202020204" pitchFamily="34" charset="0"/>
-                <a:cs typeface="Arial" panose="020B0604020202020204" pitchFamily="34" charset="0"/>
-              </a:rPr>
-              <a:t>AnAge</a:t>
-            </a:r>
-            <a:r>
-              <a:rPr lang="en-US" sz="2800" dirty="0">
-                <a:latin typeface="Arial" panose="020B0604020202020204" pitchFamily="34" charset="0"/>
-                <a:cs typeface="Arial" panose="020B0604020202020204" pitchFamily="34" charset="0"/>
-              </a:rPr>
-              <a:t> [3, 4], </a:t>
-            </a:r>
-            <a:r>
-              <a:rPr lang="en-US" sz="2800" dirty="0" err="1">
-                <a:latin typeface="Arial" panose="020B0604020202020204" pitchFamily="34" charset="0"/>
-                <a:cs typeface="Arial" panose="020B0604020202020204" pitchFamily="34" charset="0"/>
-              </a:rPr>
-              <a:t>PanTHERIA</a:t>
-            </a:r>
-            <a:r>
-              <a:rPr lang="en-US" sz="2800" dirty="0">
-                <a:latin typeface="Arial" panose="020B0604020202020204" pitchFamily="34" charset="0"/>
-                <a:cs typeface="Arial" panose="020B0604020202020204" pitchFamily="34" charset="0"/>
-              </a:rPr>
-              <a:t> [7],  Kappeler &amp; Pereira [8], and Amniotes [9] databases.</a:t>
+              <a:t>To examine the primate LH characteristics of the Ernest [2], AnAge [3, 4], PanTHERIA [7],  Kappeler &amp; Pereira [8], and Amniotes [9] databases.</a:t>
             </a:r>
           </a:p>
           <a:p>
@@ -4438,7 +4383,7 @@
         </p:nvSpPr>
         <p:spPr>
           <a:xfrm>
-            <a:off x="15658344" y="26691004"/>
+            <a:off x="14411818" y="30769285"/>
             <a:ext cx="7931966" cy="6654194"/>
           </a:xfrm>
           <a:prstGeom prst="rect">
@@ -4766,8 +4711,8 @@
         </p:blipFill>
         <p:spPr>
           <a:xfrm>
-            <a:off x="13694799" y="5485290"/>
-            <a:ext cx="15343254" cy="12843927"/>
+            <a:off x="13534601" y="5466463"/>
+            <a:ext cx="15324961" cy="12828613"/>
           </a:xfrm>
           <a:prstGeom prst="rect">
             <a:avLst/>
@@ -4857,8 +4802,8 @@
         </p:nvSpPr>
         <p:spPr>
           <a:xfrm>
-            <a:off x="29259819" y="27976555"/>
-            <a:ext cx="8488295" cy="3831818"/>
+            <a:off x="29014414" y="25680880"/>
+            <a:ext cx="8977149" cy="12385122"/>
           </a:xfrm>
           <a:prstGeom prst="rect">
             <a:avLst/>
@@ -4890,6 +4835,10 @@
               </a:rPr>
               <a:t>RESULTS</a:t>
             </a:r>
+            <a:endParaRPr lang="en-US" dirty="0">
+              <a:latin typeface="Arial" panose="020B0604020202020204" pitchFamily="34" charset="0"/>
+              <a:cs typeface="Arial" panose="020B0604020202020204" pitchFamily="34" charset="0"/>
+            </a:endParaRPr>
           </a:p>
           <a:p>
             <a:pPr marL="685800" indent="-685800">
@@ -4899,10 +4848,30 @@
               <a:buFont typeface="Wingdings" panose="05000000000000000000" pitchFamily="2" charset="2"/>
               <a:buChar char="v"/>
             </a:pPr>
-            <a:endParaRPr lang="en-US" dirty="0">
-              <a:latin typeface="Arial" panose="020B0604020202020204" pitchFamily="34" charset="0"/>
-              <a:cs typeface="Arial" panose="020B0604020202020204" pitchFamily="34" charset="0"/>
-            </a:endParaRPr>
+            <a:r>
+              <a:rPr lang="en-US" sz="2800" dirty="0">
+                <a:latin typeface="Arial" panose="020B0604020202020204" pitchFamily="34" charset="0"/>
+                <a:cs typeface="Arial" panose="020B0604020202020204" pitchFamily="34" charset="0"/>
+              </a:rPr>
+              <a:t>No dataset represented more than </a:t>
+            </a:r>
+            <a:r>
+              <a:rPr lang="en-US" sz="2800" dirty="0">
+                <a:solidFill>
+                  <a:srgbClr val="FF0000"/>
+                </a:solidFill>
+                <a:latin typeface="Arial" panose="020B0604020202020204" pitchFamily="34" charset="0"/>
+                <a:cs typeface="Arial" panose="020B0604020202020204" pitchFamily="34" charset="0"/>
+              </a:rPr>
+              <a:t>70%</a:t>
+            </a:r>
+            <a:r>
+              <a:rPr lang="en-US" sz="2800" dirty="0">
+                <a:latin typeface="Arial" panose="020B0604020202020204" pitchFamily="34" charset="0"/>
+                <a:cs typeface="Arial" panose="020B0604020202020204" pitchFamily="34" charset="0"/>
+              </a:rPr>
+              <a:t> of recognized primate species.</a:t>
+            </a:r>
           </a:p>
           <a:p>
             <a:pPr marL="685800" indent="-685800">
@@ -4912,26 +4881,175 @@
               <a:buFont typeface="Wingdings" panose="05000000000000000000" pitchFamily="2" charset="2"/>
               <a:buChar char="v"/>
             </a:pPr>
-            <a:endParaRPr lang="en-US" sz="3600" dirty="0">
-              <a:latin typeface="Arial" panose="020B0604020202020204" pitchFamily="34" charset="0"/>
-              <a:cs typeface="Arial" panose="020B0604020202020204" pitchFamily="34" charset="0"/>
-            </a:endParaRPr>
-          </a:p>
-          <a:p>
-            <a:pPr marL="685800" indent="-685800" algn="ctr">
+            <a:r>
+              <a:rPr lang="en-US" sz="2800" dirty="0">
+                <a:latin typeface="Arial" panose="020B0604020202020204" pitchFamily="34" charset="0"/>
+                <a:cs typeface="Arial" panose="020B0604020202020204" pitchFamily="34" charset="0"/>
+              </a:rPr>
+              <a:t>All</a:t>
+            </a:r>
+            <a:r>
+              <a:rPr lang="en-US" sz="2800" b="1" dirty="0">
+                <a:latin typeface="Arial" panose="020B0604020202020204" pitchFamily="34" charset="0"/>
+                <a:cs typeface="Arial" panose="020B0604020202020204" pitchFamily="34" charset="0"/>
+              </a:rPr>
+              <a:t> </a:t>
+            </a:r>
+            <a:r>
+              <a:rPr lang="en-US" sz="2800" dirty="0">
+                <a:latin typeface="Arial" panose="020B0604020202020204" pitchFamily="34" charset="0"/>
+                <a:cs typeface="Arial" panose="020B0604020202020204" pitchFamily="34" charset="0"/>
+              </a:rPr>
+              <a:t>datasets did not record </a:t>
+            </a:r>
+            <a:r>
+              <a:rPr lang="en-US" sz="2800" dirty="0">
+                <a:solidFill>
+                  <a:srgbClr val="FF0000"/>
+                </a:solidFill>
+                <a:latin typeface="Arial" panose="020B0604020202020204" pitchFamily="34" charset="0"/>
+                <a:cs typeface="Arial" panose="020B0604020202020204" pitchFamily="34" charset="0"/>
+              </a:rPr>
+              <a:t>at least two</a:t>
+            </a:r>
+            <a:r>
+              <a:rPr lang="en-US" sz="2800" dirty="0">
+                <a:latin typeface="Arial" panose="020B0604020202020204" pitchFamily="34" charset="0"/>
+                <a:cs typeface="Arial" panose="020B0604020202020204" pitchFamily="34" charset="0"/>
+              </a:rPr>
+              <a:t> of our “key” LH traits.</a:t>
+            </a:r>
+          </a:p>
+          <a:p>
+            <a:pPr marL="685800" indent="-685800">
               <a:lnSpc>
                 <a:spcPct val="150000"/>
               </a:lnSpc>
               <a:buFont typeface="Wingdings" panose="05000000000000000000" pitchFamily="2" charset="2"/>
               <a:buChar char="v"/>
             </a:pPr>
-            <a:endParaRPr lang="en-US" sz="3600" dirty="0">
-              <a:latin typeface="Arial" panose="020B0604020202020204" pitchFamily="34" charset="0"/>
-              <a:cs typeface="Arial" panose="020B0604020202020204" pitchFamily="34" charset="0"/>
-            </a:endParaRPr>
-          </a:p>
-          <a:p>
-            <a:endParaRPr lang="en-US" dirty="0">
+            <a:r>
+              <a:rPr lang="en-US" sz="2800" dirty="0">
+                <a:latin typeface="Arial" panose="020B0604020202020204" pitchFamily="34" charset="0"/>
+                <a:cs typeface="Arial" panose="020B0604020202020204" pitchFamily="34" charset="0"/>
+              </a:rPr>
+              <a:t>Between datasets, mean proportions of missing values for key traits ranged from </a:t>
+            </a:r>
+            <a:r>
+              <a:rPr lang="en-US" sz="2800" dirty="0">
+                <a:solidFill>
+                  <a:srgbClr val="FF0000"/>
+                </a:solidFill>
+                <a:latin typeface="Arial" panose="020B0604020202020204" pitchFamily="34" charset="0"/>
+                <a:cs typeface="Arial" panose="020B0604020202020204" pitchFamily="34" charset="0"/>
+              </a:rPr>
+              <a:t>30.7 to 68.8%.</a:t>
+            </a:r>
+          </a:p>
+          <a:p>
+            <a:pPr marL="1143000" lvl="1" indent="-685800">
+              <a:lnSpc>
+                <a:spcPct val="150000"/>
+              </a:lnSpc>
+              <a:buFont typeface="Wingdings" panose="05000000000000000000" pitchFamily="2" charset="2"/>
+              <a:buChar char="v"/>
+            </a:pPr>
+            <a:r>
+              <a:rPr lang="en-US" sz="2800" dirty="0">
+                <a:latin typeface="Arial" panose="020B0604020202020204" pitchFamily="34" charset="0"/>
+                <a:cs typeface="Arial" panose="020B0604020202020204" pitchFamily="34" charset="0"/>
+              </a:rPr>
+              <a:t>[8] had the most missing values (68.8%).</a:t>
+            </a:r>
+          </a:p>
+          <a:p>
+            <a:pPr marL="1143000" lvl="1" indent="-685800">
+              <a:lnSpc>
+                <a:spcPct val="150000"/>
+              </a:lnSpc>
+              <a:buFont typeface="Wingdings" panose="05000000000000000000" pitchFamily="2" charset="2"/>
+              <a:buChar char="v"/>
+            </a:pPr>
+            <a:r>
+              <a:rPr lang="en-US" sz="2800" dirty="0">
+                <a:latin typeface="Arial" panose="020B0604020202020204" pitchFamily="34" charset="0"/>
+                <a:cs typeface="Arial" panose="020B0604020202020204" pitchFamily="34" charset="0"/>
+              </a:rPr>
+              <a:t>Of the traits recorded in multiple datasets, </a:t>
+            </a:r>
+            <a:r>
+              <a:rPr lang="en-US" sz="2800" dirty="0">
+                <a:solidFill>
+                  <a:srgbClr val="FF0000"/>
+                </a:solidFill>
+                <a:latin typeface="Arial" panose="020B0604020202020204" pitchFamily="34" charset="0"/>
+                <a:cs typeface="Arial" panose="020B0604020202020204" pitchFamily="34" charset="0"/>
+              </a:rPr>
+              <a:t>AFR was the least complete among pooled data </a:t>
+            </a:r>
+            <a:r>
+              <a:rPr lang="en-US" sz="2800" dirty="0">
+                <a:latin typeface="Arial" panose="020B0604020202020204" pitchFamily="34" charset="0"/>
+                <a:cs typeface="Arial" panose="020B0604020202020204" pitchFamily="34" charset="0"/>
+              </a:rPr>
+              <a:t>with a proportion of missing values equal to .653.</a:t>
+            </a:r>
+          </a:p>
+          <a:p>
+            <a:pPr marL="685800" indent="-685800">
+              <a:lnSpc>
+                <a:spcPct val="150000"/>
+              </a:lnSpc>
+              <a:buFont typeface="Wingdings" panose="05000000000000000000" pitchFamily="2" charset="2"/>
+              <a:buChar char="v"/>
+            </a:pPr>
+            <a:r>
+              <a:rPr lang="en-US" sz="2800" dirty="0">
+                <a:latin typeface="Arial" panose="020B0604020202020204" pitchFamily="34" charset="0"/>
+                <a:cs typeface="Arial" panose="020B0604020202020204" pitchFamily="34" charset="0"/>
+              </a:rPr>
+              <a:t>Metadata content varied from complete and detailed to largely unavailable. </a:t>
+            </a:r>
+          </a:p>
+          <a:p>
+            <a:pPr marL="1143000" lvl="1" indent="-685800">
+              <a:lnSpc>
+                <a:spcPct val="150000"/>
+              </a:lnSpc>
+              <a:buFont typeface="Wingdings" panose="05000000000000000000" pitchFamily="2" charset="2"/>
+              <a:buChar char="v"/>
+            </a:pPr>
+            <a:r>
+              <a:rPr lang="en-US" sz="2800" dirty="0">
+                <a:latin typeface="Arial" panose="020B0604020202020204" pitchFamily="34" charset="0"/>
+                <a:cs typeface="Arial" panose="020B0604020202020204" pitchFamily="34" charset="0"/>
+              </a:rPr>
+              <a:t>For those with available metadata, quality and detail also ranged.</a:t>
+            </a:r>
+          </a:p>
+          <a:p>
+            <a:pPr marL="685800" indent="-685800">
+              <a:lnSpc>
+                <a:spcPct val="150000"/>
+              </a:lnSpc>
+              <a:buFont typeface="Wingdings" panose="05000000000000000000" pitchFamily="2" charset="2"/>
+              <a:buChar char="v"/>
+            </a:pPr>
+            <a:r>
+              <a:rPr lang="en-US" sz="2800" dirty="0">
+                <a:latin typeface="Arial" panose="020B0604020202020204" pitchFamily="34" charset="0"/>
+                <a:cs typeface="Arial" panose="020B0604020202020204" pitchFamily="34" charset="0"/>
+              </a:rPr>
+              <a:t>ASM was significantly less dimorphic than adult mass across primates and within species (p &lt; </a:t>
+            </a:r>
+            <a:r>
+              <a:rPr lang="en-US" sz="2800">
+                <a:latin typeface="Arial" panose="020B0604020202020204" pitchFamily="34" charset="0"/>
+                <a:cs typeface="Arial" panose="020B0604020202020204" pitchFamily="34" charset="0"/>
+              </a:rPr>
+              <a:t>.00001 &amp; p &lt; .001).</a:t>
+            </a:r>
+            <a:endParaRPr lang="en-US" sz="2800" dirty="0">
               <a:latin typeface="Arial" panose="020B0604020202020204" pitchFamily="34" charset="0"/>
               <a:cs typeface="Arial" panose="020B0604020202020204" pitchFamily="34" charset="0"/>
             </a:endParaRPr>
@@ -4952,8 +5070,8 @@
         </p:nvSpPr>
         <p:spPr>
           <a:xfrm>
-            <a:off x="23355300" y="32718041"/>
-            <a:ext cx="14392814" cy="5304016"/>
+            <a:off x="13733432" y="33192353"/>
+            <a:ext cx="14392814" cy="3503523"/>
           </a:xfrm>
           <a:prstGeom prst="rect">
             <a:avLst/>
@@ -4983,7 +5101,7 @@
                 <a:latin typeface="Arial" panose="020B0604020202020204" pitchFamily="34" charset="0"/>
                 <a:cs typeface="Arial" panose="020B0604020202020204" pitchFamily="34" charset="0"/>
               </a:rPr>
-              <a:t>CONCLUSIONS &amp; FUTURE RESEARCH</a:t>
+              <a:t>DISCUSSION</a:t>
             </a:r>
           </a:p>
           <a:p>
@@ -5039,35 +5157,7 @@
                 <a:latin typeface="Arial" panose="020B0604020202020204" pitchFamily="34" charset="0"/>
                 <a:cs typeface="Arial" panose="020B0604020202020204" pitchFamily="34" charset="0"/>
               </a:rPr>
-              <a:t>L</a:t>
-            </a:r>
-          </a:p>
-          <a:p>
-            <a:pPr>
-              <a:lnSpc>
-                <a:spcPct val="150000"/>
-              </a:lnSpc>
-            </a:pPr>
-            <a:r>
-              <a:rPr lang="en-US" dirty="0">
-                <a:latin typeface="Arial" panose="020B0604020202020204" pitchFamily="34" charset="0"/>
-                <a:cs typeface="Arial" panose="020B0604020202020204" pitchFamily="34" charset="0"/>
-              </a:rPr>
-              <a:t>L</a:t>
-            </a:r>
-          </a:p>
-          <a:p>
-            <a:pPr>
-              <a:lnSpc>
-                <a:spcPct val="150000"/>
-              </a:lnSpc>
-            </a:pPr>
-            <a:r>
-              <a:rPr lang="en-US" dirty="0">
-                <a:latin typeface="Arial" panose="020B0604020202020204" pitchFamily="34" charset="0"/>
-                <a:cs typeface="Arial" panose="020B0604020202020204" pitchFamily="34" charset="0"/>
-              </a:rPr>
-              <a:t>L</a:t>
+              <a:t>Ex: IBI descriptions for Amniotes &amp; PanTHERIA specify live offspring, while KP doesn’t specify; AnAge lacks any description of IBI, and Ernest does not record data for IBI.</a:t>
             </a:r>
           </a:p>
         </p:txBody>
@@ -5139,14 +5229,14 @@
           <p:nvPr>
             <p:extLst>
               <p:ext uri="{D42A27DB-BD31-4B8C-83A1-F6EECF244321}">
-                <p14:modId xmlns:p14="http://schemas.microsoft.com/office/powerpoint/2010/main" val="2081878916"/>
+                <p14:modId xmlns:p14="http://schemas.microsoft.com/office/powerpoint/2010/main" val="2889211633"/>
               </p:ext>
             </p:extLst>
           </p:nvPr>
         </p:nvGraphicFramePr>
         <p:xfrm>
-          <a:off x="13688043" y="22279769"/>
-          <a:ext cx="15149852" cy="3962400"/>
+          <a:off x="13667857" y="22161523"/>
+          <a:ext cx="15102725" cy="4138398"/>
         </p:xfrm>
         <a:graphic>
           <a:graphicData uri="http://schemas.openxmlformats.org/drawingml/2006/table">
@@ -5155,49 +5245,56 @@
                 <a:tableStyleId>{5C22544A-7EE6-4342-B048-85BDC9FD1C3A}</a:tableStyleId>
               </a:tblPr>
               <a:tblGrid>
-                <a:gridCol w="2048682">
+                <a:gridCol w="2197387">
                   <a:extLst>
                     <a:ext uri="{9D8B030D-6E8A-4147-A177-3AD203B41FA5}">
                       <a16:colId xmlns:a16="http://schemas.microsoft.com/office/drawing/2014/main" val="2495585869"/>
                     </a:ext>
                   </a:extLst>
                 </a:gridCol>
-                <a:gridCol w="2495874">
+                <a:gridCol w="1851702">
                   <a:extLst>
                     <a:ext uri="{9D8B030D-6E8A-4147-A177-3AD203B41FA5}">
                       <a16:colId xmlns:a16="http://schemas.microsoft.com/office/drawing/2014/main" val="3601265924"/>
                     </a:ext>
                   </a:extLst>
                 </a:gridCol>
-                <a:gridCol w="1504335">
+                <a:gridCol w="1562373">
                   <a:extLst>
                     <a:ext uri="{9D8B030D-6E8A-4147-A177-3AD203B41FA5}">
                       <a16:colId xmlns:a16="http://schemas.microsoft.com/office/drawing/2014/main" val="984202891"/>
                     </a:ext>
                   </a:extLst>
                 </a:gridCol>
-                <a:gridCol w="2271252">
+                <a:gridCol w="2112098">
                   <a:extLst>
                     <a:ext uri="{9D8B030D-6E8A-4147-A177-3AD203B41FA5}">
                       <a16:colId xmlns:a16="http://schemas.microsoft.com/office/drawing/2014/main" val="1450671555"/>
                     </a:ext>
                   </a:extLst>
                 </a:gridCol>
-                <a:gridCol w="1828800">
+                <a:gridCol w="2112098">
+                  <a:extLst>
+                    <a:ext uri="{9D8B030D-6E8A-4147-A177-3AD203B41FA5}">
+                      <a16:colId xmlns:a16="http://schemas.microsoft.com/office/drawing/2014/main" val="2092606652"/>
+                    </a:ext>
+                  </a:extLst>
+                </a:gridCol>
+                <a:gridCol w="1070515">
                   <a:extLst>
                     <a:ext uri="{9D8B030D-6E8A-4147-A177-3AD203B41FA5}">
                       <a16:colId xmlns:a16="http://schemas.microsoft.com/office/drawing/2014/main" val="3671337353"/>
                     </a:ext>
                   </a:extLst>
                 </a:gridCol>
-                <a:gridCol w="2979174">
+                <a:gridCol w="2155470">
                   <a:extLst>
                     <a:ext uri="{9D8B030D-6E8A-4147-A177-3AD203B41FA5}">
                       <a16:colId xmlns:a16="http://schemas.microsoft.com/office/drawing/2014/main" val="1165741138"/>
                     </a:ext>
                   </a:extLst>
                 </a:gridCol>
-                <a:gridCol w="2021735">
+                <a:gridCol w="2041082">
                   <a:extLst>
                     <a:ext uri="{9D8B030D-6E8A-4147-A177-3AD203B41FA5}">
                       <a16:colId xmlns:a16="http://schemas.microsoft.com/office/drawing/2014/main" val="3607082557"/>
@@ -5205,14 +5302,17 @@
                   </a:extLst>
                 </a:gridCol>
               </a:tblGrid>
-              <a:tr h="376525">
+              <a:tr h="826167">
                 <a:tc>
                   <a:txBody>
                     <a:bodyPr/>
                     <a:lstStyle/>
                     <a:p>
                       <a:r>
-                        <a:rPr lang="en-US" sz="2800" b="1" dirty="0"/>
+                        <a:rPr lang="en-US" sz="2600" b="1" dirty="0">
+                          <a:latin typeface="Arial" panose="020B0604020202020204" pitchFamily="34" charset="0"/>
+                          <a:cs typeface="Arial" panose="020B0604020202020204" pitchFamily="34" charset="0"/>
+                        </a:rPr>
                         <a:t>Source</a:t>
                       </a:r>
                     </a:p>
@@ -5225,8 +5325,11 @@
                     <a:lstStyle/>
                     <a:p>
                       <a:r>
-                        <a:rPr lang="en-US" sz="2800" dirty="0"/>
-                        <a:t>Actively Maintained?</a:t>
+                        <a:rPr lang="en-US" sz="2600" dirty="0">
+                          <a:latin typeface="Arial" panose="020B0604020202020204" pitchFamily="34" charset="0"/>
+                          <a:cs typeface="Arial" panose="020B0604020202020204" pitchFamily="34" charset="0"/>
+                        </a:rPr>
+                        <a:t>Actively Updated?</a:t>
                       </a:r>
                     </a:p>
                   </a:txBody>
@@ -5238,7 +5341,10 @@
                     <a:lstStyle/>
                     <a:p>
                       <a:r>
-                        <a:rPr lang="en-US" sz="2800" dirty="0"/>
+                        <a:rPr lang="en-US" sz="2600" dirty="0">
+                          <a:latin typeface="Arial" panose="020B0604020202020204" pitchFamily="34" charset="0"/>
+                          <a:cs typeface="Arial" panose="020B0604020202020204" pitchFamily="34" charset="0"/>
+                        </a:rPr>
                         <a:t>N species</a:t>
                       </a:r>
                     </a:p>
@@ -5251,7 +5357,10 @@
                     <a:lstStyle/>
                     <a:p>
                       <a:r>
-                        <a:rPr lang="en-US" sz="2800" dirty="0"/>
+                        <a:rPr lang="en-US" sz="2600" dirty="0">
+                          <a:latin typeface="Arial" panose="020B0604020202020204" pitchFamily="34" charset="0"/>
+                          <a:cs typeface="Arial" panose="020B0604020202020204" pitchFamily="34" charset="0"/>
+                        </a:rPr>
                         <a:t>P species represented</a:t>
                       </a:r>
                     </a:p>
@@ -5264,7 +5373,26 @@
                     <a:lstStyle/>
                     <a:p>
                       <a:r>
-                        <a:rPr lang="en-US" sz="2800" dirty="0"/>
+                        <a:rPr lang="en-US" sz="2600" dirty="0">
+                          <a:latin typeface="Arial" panose="020B0604020202020204" pitchFamily="34" charset="0"/>
+                          <a:cs typeface="Arial" panose="020B0604020202020204" pitchFamily="34" charset="0"/>
+                        </a:rPr>
+                        <a:t>Metadata Score (x/8)</a:t>
+                      </a:r>
+                    </a:p>
+                  </a:txBody>
+                  <a:tcPr/>
+                </a:tc>
+                <a:tc>
+                  <a:txBody>
+                    <a:bodyPr/>
+                    <a:lstStyle/>
+                    <a:p>
+                      <a:r>
+                        <a:rPr lang="en-US" sz="2600" dirty="0">
+                          <a:latin typeface="Arial" panose="020B0604020202020204" pitchFamily="34" charset="0"/>
+                          <a:cs typeface="Arial" panose="020B0604020202020204" pitchFamily="34" charset="0"/>
+                        </a:rPr>
                         <a:t>N LH stats</a:t>
                       </a:r>
                     </a:p>
@@ -5277,8 +5405,11 @@
                     <a:lstStyle/>
                     <a:p>
                       <a:r>
-                        <a:rPr lang="en-US" sz="2800" dirty="0"/>
-                        <a:t>P missing values (Key traits)</a:t>
+                        <a:rPr lang="en-US" sz="2600" dirty="0">
+                          <a:latin typeface="Arial" panose="020B0604020202020204" pitchFamily="34" charset="0"/>
+                          <a:cs typeface="Arial" panose="020B0604020202020204" pitchFamily="34" charset="0"/>
+                        </a:rPr>
+                        <a:t>P missing values (Key)</a:t>
                       </a:r>
                     </a:p>
                   </a:txBody>
@@ -5290,7 +5421,10 @@
                     <a:lstStyle/>
                     <a:p>
                       <a:r>
-                        <a:rPr lang="en-US" sz="2800" dirty="0"/>
+                        <a:rPr lang="en-US" sz="2600" dirty="0">
+                          <a:latin typeface="Arial" panose="020B0604020202020204" pitchFamily="34" charset="0"/>
+                          <a:cs typeface="Arial" panose="020B0604020202020204" pitchFamily="34" charset="0"/>
+                        </a:rPr>
                         <a:t>P missing values (All)</a:t>
                       </a:r>
                     </a:p>
@@ -5303,14 +5437,17 @@
                   </a:ext>
                 </a:extLst>
               </a:tr>
-              <a:tr h="206482">
+              <a:tr h="559910">
                 <a:tc>
                   <a:txBody>
                     <a:bodyPr/>
                     <a:lstStyle/>
                     <a:p>
                       <a:r>
-                        <a:rPr lang="en-US" sz="2800" dirty="0"/>
+                        <a:rPr lang="en-US" sz="2600" dirty="0">
+                          <a:latin typeface="Arial" panose="020B0604020202020204" pitchFamily="34" charset="0"/>
+                          <a:cs typeface="Arial" panose="020B0604020202020204" pitchFamily="34" charset="0"/>
+                        </a:rPr>
                         <a:t>Amniotes</a:t>
                       </a:r>
                     </a:p>
@@ -5323,7 +5460,10 @@
                     <a:lstStyle/>
                     <a:p>
                       <a:r>
-                        <a:rPr lang="en-US" sz="2800" dirty="0"/>
+                        <a:rPr lang="en-US" sz="2600" dirty="0">
+                          <a:latin typeface="Arial" panose="020B0604020202020204" pitchFamily="34" charset="0"/>
+                          <a:cs typeface="Arial" panose="020B0604020202020204" pitchFamily="34" charset="0"/>
+                        </a:rPr>
                         <a:t>No</a:t>
                       </a:r>
                     </a:p>
@@ -5336,7 +5476,10 @@
                     <a:lstStyle/>
                     <a:p>
                       <a:r>
-                        <a:rPr lang="en-US" sz="2800" dirty="0"/>
+                        <a:rPr lang="en-US" sz="2600" dirty="0">
+                          <a:latin typeface="Arial" panose="020B0604020202020204" pitchFamily="34" charset="0"/>
+                          <a:cs typeface="Arial" panose="020B0604020202020204" pitchFamily="34" charset="0"/>
+                        </a:rPr>
                         <a:t>365</a:t>
                       </a:r>
                     </a:p>
@@ -5349,7 +5492,10 @@
                     <a:lstStyle/>
                     <a:p>
                       <a:r>
-                        <a:rPr lang="en-US" sz="2800" dirty="0"/>
+                        <a:rPr lang="en-US" sz="2600" dirty="0">
+                          <a:latin typeface="Arial" panose="020B0604020202020204" pitchFamily="34" charset="0"/>
+                          <a:cs typeface="Arial" panose="020B0604020202020204" pitchFamily="34" charset="0"/>
+                        </a:rPr>
                         <a:t>.68</a:t>
                       </a:r>
                     </a:p>
@@ -5362,7 +5508,26 @@
                     <a:lstStyle/>
                     <a:p>
                       <a:r>
-                        <a:rPr lang="en-US" sz="2800" dirty="0"/>
+                        <a:rPr lang="en-US" sz="2600" dirty="0">
+                          <a:latin typeface="Arial" panose="020B0604020202020204" pitchFamily="34" charset="0"/>
+                          <a:cs typeface="Arial" panose="020B0604020202020204" pitchFamily="34" charset="0"/>
+                        </a:rPr>
+                        <a:t>8</a:t>
+                      </a:r>
+                    </a:p>
+                  </a:txBody>
+                  <a:tcPr/>
+                </a:tc>
+                <a:tc>
+                  <a:txBody>
+                    <a:bodyPr/>
+                    <a:lstStyle/>
+                    <a:p>
+                      <a:r>
+                        <a:rPr lang="en-US" sz="2600" dirty="0">
+                          <a:latin typeface="Arial" panose="020B0604020202020204" pitchFamily="34" charset="0"/>
+                          <a:cs typeface="Arial" panose="020B0604020202020204" pitchFamily="34" charset="0"/>
+                        </a:rPr>
                         <a:t>23</a:t>
                       </a:r>
                     </a:p>
@@ -5375,7 +5540,10 @@
                     <a:lstStyle/>
                     <a:p>
                       <a:r>
-                        <a:rPr lang="en-US" sz="2800" dirty="0"/>
+                        <a:rPr lang="en-US" sz="2600" dirty="0">
+                          <a:latin typeface="Arial" panose="020B0604020202020204" pitchFamily="34" charset="0"/>
+                          <a:cs typeface="Arial" panose="020B0604020202020204" pitchFamily="34" charset="0"/>
+                        </a:rPr>
                         <a:t>.34</a:t>
                       </a:r>
                     </a:p>
@@ -5388,7 +5556,10 @@
                     <a:lstStyle/>
                     <a:p>
                       <a:r>
-                        <a:rPr lang="en-US" sz="2800" dirty="0"/>
+                        <a:rPr lang="en-US" sz="2600" dirty="0">
+                          <a:latin typeface="Arial" panose="020B0604020202020204" pitchFamily="34" charset="0"/>
+                          <a:cs typeface="Arial" panose="020B0604020202020204" pitchFamily="34" charset="0"/>
+                        </a:rPr>
                         <a:t>.54</a:t>
                       </a:r>
                     </a:p>
@@ -5401,17 +5572,19 @@
                   </a:ext>
                 </a:extLst>
               </a:tr>
-              <a:tr h="206482">
+              <a:tr h="559910">
                 <a:tc>
                   <a:txBody>
                     <a:bodyPr/>
                     <a:lstStyle/>
                     <a:p>
                       <a:r>
-                        <a:rPr lang="en-US" sz="2800" dirty="0" err="1"/>
+                        <a:rPr lang="en-US" sz="2600" dirty="0">
+                          <a:latin typeface="Arial" panose="020B0604020202020204" pitchFamily="34" charset="0"/>
+                          <a:cs typeface="Arial" panose="020B0604020202020204" pitchFamily="34" charset="0"/>
+                        </a:rPr>
                         <a:t>AnAge</a:t>
                       </a:r>
-                      <a:endParaRPr lang="en-US" sz="2800" dirty="0"/>
                     </a:p>
                   </a:txBody>
                   <a:tcPr/>
@@ -5422,7 +5595,10 @@
                     <a:lstStyle/>
                     <a:p>
                       <a:r>
-                        <a:rPr lang="en-US" sz="2800" dirty="0"/>
+                        <a:rPr lang="en-US" sz="2600" dirty="0">
+                          <a:latin typeface="Arial" panose="020B0604020202020204" pitchFamily="34" charset="0"/>
+                          <a:cs typeface="Arial" panose="020B0604020202020204" pitchFamily="34" charset="0"/>
+                        </a:rPr>
                         <a:t>Yes</a:t>
                       </a:r>
                     </a:p>
@@ -5435,7 +5611,10 @@
                     <a:lstStyle/>
                     <a:p>
                       <a:r>
-                        <a:rPr lang="en-US" sz="2800" dirty="0"/>
+                        <a:rPr lang="en-US" sz="2600" dirty="0">
+                          <a:latin typeface="Arial" panose="020B0604020202020204" pitchFamily="34" charset="0"/>
+                          <a:cs typeface="Arial" panose="020B0604020202020204" pitchFamily="34" charset="0"/>
+                        </a:rPr>
                         <a:t>174</a:t>
                       </a:r>
                     </a:p>
@@ -5448,7 +5627,10 @@
                     <a:lstStyle/>
                     <a:p>
                       <a:r>
-                        <a:rPr lang="en-US" sz="2800" dirty="0"/>
+                        <a:rPr lang="en-US" sz="2600" dirty="0">
+                          <a:latin typeface="Arial" panose="020B0604020202020204" pitchFamily="34" charset="0"/>
+                          <a:cs typeface="Arial" panose="020B0604020202020204" pitchFamily="34" charset="0"/>
+                        </a:rPr>
                         <a:t>.33</a:t>
                       </a:r>
                     </a:p>
@@ -5461,7 +5643,26 @@
                     <a:lstStyle/>
                     <a:p>
                       <a:r>
-                        <a:rPr lang="en-US" sz="2800" dirty="0"/>
+                        <a:rPr lang="en-US" sz="2600" dirty="0">
+                          <a:latin typeface="Arial" panose="020B0604020202020204" pitchFamily="34" charset="0"/>
+                          <a:cs typeface="Arial" panose="020B0604020202020204" pitchFamily="34" charset="0"/>
+                        </a:rPr>
+                        <a:t>3</a:t>
+                      </a:r>
+                    </a:p>
+                  </a:txBody>
+                  <a:tcPr/>
+                </a:tc>
+                <a:tc>
+                  <a:txBody>
+                    <a:bodyPr/>
+                    <a:lstStyle/>
+                    <a:p>
+                      <a:r>
+                        <a:rPr lang="en-US" sz="2600" dirty="0">
+                          <a:latin typeface="Arial" panose="020B0604020202020204" pitchFamily="34" charset="0"/>
+                          <a:cs typeface="Arial" panose="020B0604020202020204" pitchFamily="34" charset="0"/>
+                        </a:rPr>
                         <a:t>19</a:t>
                       </a:r>
                     </a:p>
@@ -5474,7 +5675,10 @@
                     <a:lstStyle/>
                     <a:p>
                       <a:r>
-                        <a:rPr lang="en-US" sz="2800" dirty="0"/>
+                        <a:rPr lang="en-US" sz="2600" dirty="0">
+                          <a:latin typeface="Arial" panose="020B0604020202020204" pitchFamily="34" charset="0"/>
+                          <a:cs typeface="Arial" panose="020B0604020202020204" pitchFamily="34" charset="0"/>
+                        </a:rPr>
                         <a:t>.37</a:t>
                       </a:r>
                     </a:p>
@@ -5487,7 +5691,10 @@
                     <a:lstStyle/>
                     <a:p>
                       <a:r>
-                        <a:rPr lang="en-US" sz="2800" dirty="0"/>
+                        <a:rPr lang="en-US" sz="2600" dirty="0">
+                          <a:latin typeface="Arial" panose="020B0604020202020204" pitchFamily="34" charset="0"/>
+                          <a:cs typeface="Arial" panose="020B0604020202020204" pitchFamily="34" charset="0"/>
+                        </a:rPr>
                         <a:t>.46</a:t>
                       </a:r>
                     </a:p>
@@ -5500,14 +5707,17 @@
                   </a:ext>
                 </a:extLst>
               </a:tr>
-              <a:tr h="206482">
+              <a:tr h="559910">
                 <a:tc>
                   <a:txBody>
                     <a:bodyPr/>
                     <a:lstStyle/>
                     <a:p>
                       <a:r>
-                        <a:rPr lang="en-US" sz="2800" dirty="0"/>
+                        <a:rPr lang="en-US" sz="2600" dirty="0">
+                          <a:latin typeface="Arial" panose="020B0604020202020204" pitchFamily="34" charset="0"/>
+                          <a:cs typeface="Arial" panose="020B0604020202020204" pitchFamily="34" charset="0"/>
+                        </a:rPr>
                         <a:t>Ernest</a:t>
                       </a:r>
                     </a:p>
@@ -5520,7 +5730,10 @@
                     <a:lstStyle/>
                     <a:p>
                       <a:r>
-                        <a:rPr lang="en-US" sz="2800" dirty="0"/>
+                        <a:rPr lang="en-US" sz="2600" dirty="0">
+                          <a:latin typeface="Arial" panose="020B0604020202020204" pitchFamily="34" charset="0"/>
+                          <a:cs typeface="Arial" panose="020B0604020202020204" pitchFamily="34" charset="0"/>
+                        </a:rPr>
                         <a:t>No</a:t>
                       </a:r>
                     </a:p>
@@ -5533,7 +5746,10 @@
                     <a:lstStyle/>
                     <a:p>
                       <a:r>
-                        <a:rPr lang="en-US" sz="2800" dirty="0"/>
+                        <a:rPr lang="en-US" sz="2600" dirty="0">
+                          <a:latin typeface="Arial" panose="020B0604020202020204" pitchFamily="34" charset="0"/>
+                          <a:cs typeface="Arial" panose="020B0604020202020204" pitchFamily="34" charset="0"/>
+                        </a:rPr>
                         <a:t>156</a:t>
                       </a:r>
                     </a:p>
@@ -5546,7 +5762,10 @@
                     <a:lstStyle/>
                     <a:p>
                       <a:r>
-                        <a:rPr lang="en-US" sz="2800" dirty="0"/>
+                        <a:rPr lang="en-US" sz="2600" dirty="0">
+                          <a:latin typeface="Arial" panose="020B0604020202020204" pitchFamily="34" charset="0"/>
+                          <a:cs typeface="Arial" panose="020B0604020202020204" pitchFamily="34" charset="0"/>
+                        </a:rPr>
                         <a:t>.29</a:t>
                       </a:r>
                     </a:p>
@@ -5559,7 +5778,26 @@
                     <a:lstStyle/>
                     <a:p>
                       <a:r>
-                        <a:rPr lang="en-US" sz="2800" dirty="0"/>
+                        <a:rPr lang="en-US" sz="2600" dirty="0">
+                          <a:latin typeface="Arial" panose="020B0604020202020204" pitchFamily="34" charset="0"/>
+                          <a:cs typeface="Arial" panose="020B0604020202020204" pitchFamily="34" charset="0"/>
+                        </a:rPr>
+                        <a:t>8</a:t>
+                      </a:r>
+                    </a:p>
+                  </a:txBody>
+                  <a:tcPr/>
+                </a:tc>
+                <a:tc>
+                  <a:txBody>
+                    <a:bodyPr/>
+                    <a:lstStyle/>
+                    <a:p>
+                      <a:r>
+                        <a:rPr lang="en-US" sz="2600" dirty="0">
+                          <a:latin typeface="Arial" panose="020B0604020202020204" pitchFamily="34" charset="0"/>
+                          <a:cs typeface="Arial" panose="020B0604020202020204" pitchFamily="34" charset="0"/>
+                        </a:rPr>
                         <a:t>9</a:t>
                       </a:r>
                     </a:p>
@@ -5572,7 +5810,10 @@
                     <a:lstStyle/>
                     <a:p>
                       <a:r>
-                        <a:rPr lang="en-US" sz="2800" dirty="0"/>
+                        <a:rPr lang="en-US" sz="2600" dirty="0">
+                          <a:latin typeface="Arial" panose="020B0604020202020204" pitchFamily="34" charset="0"/>
+                          <a:cs typeface="Arial" panose="020B0604020202020204" pitchFamily="34" charset="0"/>
+                        </a:rPr>
                         <a:t>.31</a:t>
                       </a:r>
                     </a:p>
@@ -5585,7 +5826,10 @@
                     <a:lstStyle/>
                     <a:p>
                       <a:r>
-                        <a:rPr lang="en-US" sz="2800" dirty="0"/>
+                        <a:rPr lang="en-US" sz="2600" dirty="0">
+                          <a:latin typeface="Arial" panose="020B0604020202020204" pitchFamily="34" charset="0"/>
+                          <a:cs typeface="Arial" panose="020B0604020202020204" pitchFamily="34" charset="0"/>
+                        </a:rPr>
                         <a:t>.32</a:t>
                       </a:r>
                     </a:p>
@@ -5598,14 +5842,17 @@
                   </a:ext>
                 </a:extLst>
               </a:tr>
-              <a:tr h="376525">
+              <a:tr h="1014838">
                 <a:tc>
                   <a:txBody>
                     <a:bodyPr/>
                     <a:lstStyle/>
                     <a:p>
                       <a:r>
-                        <a:rPr lang="en-US" sz="2800" dirty="0"/>
+                        <a:rPr lang="en-US" sz="2600" dirty="0">
+                          <a:latin typeface="Arial" panose="020B0604020202020204" pitchFamily="34" charset="0"/>
+                          <a:cs typeface="Arial" panose="020B0604020202020204" pitchFamily="34" charset="0"/>
+                        </a:rPr>
                         <a:t>Kappeler &amp; Pereira</a:t>
                       </a:r>
                     </a:p>
@@ -5618,7 +5865,10 @@
                     <a:lstStyle/>
                     <a:p>
                       <a:r>
-                        <a:rPr lang="en-US" sz="2800" dirty="0"/>
+                        <a:rPr lang="en-US" sz="2600" dirty="0">
+                          <a:latin typeface="Arial" panose="020B0604020202020204" pitchFamily="34" charset="0"/>
+                          <a:cs typeface="Arial" panose="020B0604020202020204" pitchFamily="34" charset="0"/>
+                        </a:rPr>
                         <a:t>No</a:t>
                       </a:r>
                     </a:p>
@@ -5631,7 +5881,10 @@
                     <a:lstStyle/>
                     <a:p>
                       <a:r>
-                        <a:rPr lang="en-US" sz="2800" dirty="0"/>
+                        <a:rPr lang="en-US" sz="2600" dirty="0">
+                          <a:latin typeface="Arial" panose="020B0604020202020204" pitchFamily="34" charset="0"/>
+                          <a:cs typeface="Arial" panose="020B0604020202020204" pitchFamily="34" charset="0"/>
+                        </a:rPr>
                         <a:t>310</a:t>
                       </a:r>
                     </a:p>
@@ -5644,7 +5897,10 @@
                     <a:lstStyle/>
                     <a:p>
                       <a:r>
-                        <a:rPr lang="en-US" sz="2800" dirty="0"/>
+                        <a:rPr lang="en-US" sz="2600" dirty="0">
+                          <a:latin typeface="Arial" panose="020B0604020202020204" pitchFamily="34" charset="0"/>
+                          <a:cs typeface="Arial" panose="020B0604020202020204" pitchFamily="34" charset="0"/>
+                        </a:rPr>
                         <a:t>.58</a:t>
                       </a:r>
                     </a:p>
@@ -5657,7 +5913,26 @@
                     <a:lstStyle/>
                     <a:p>
                       <a:r>
-                        <a:rPr lang="en-US" sz="2800" dirty="0"/>
+                        <a:rPr lang="en-US" sz="2600" dirty="0">
+                          <a:latin typeface="Arial" panose="020B0604020202020204" pitchFamily="34" charset="0"/>
+                          <a:cs typeface="Arial" panose="020B0604020202020204" pitchFamily="34" charset="0"/>
+                        </a:rPr>
+                        <a:t>5</a:t>
+                      </a:r>
+                    </a:p>
+                  </a:txBody>
+                  <a:tcPr/>
+                </a:tc>
+                <a:tc>
+                  <a:txBody>
+                    <a:bodyPr/>
+                    <a:lstStyle/>
+                    <a:p>
+                      <a:r>
+                        <a:rPr lang="en-US" sz="2600" dirty="0">
+                          <a:latin typeface="Arial" panose="020B0604020202020204" pitchFamily="34" charset="0"/>
+                          <a:cs typeface="Arial" panose="020B0604020202020204" pitchFamily="34" charset="0"/>
+                        </a:rPr>
                         <a:t>13</a:t>
                       </a:r>
                     </a:p>
@@ -5670,7 +5945,10 @@
                     <a:lstStyle/>
                     <a:p>
                       <a:r>
-                        <a:rPr lang="en-US" sz="2800" dirty="0"/>
+                        <a:rPr lang="en-US" sz="2600" dirty="0">
+                          <a:latin typeface="Arial" panose="020B0604020202020204" pitchFamily="34" charset="0"/>
+                          <a:cs typeface="Arial" panose="020B0604020202020204" pitchFamily="34" charset="0"/>
+                        </a:rPr>
                         <a:t>.69</a:t>
                       </a:r>
                     </a:p>
@@ -5683,7 +5961,10 @@
                     <a:lstStyle/>
                     <a:p>
                       <a:r>
-                        <a:rPr lang="en-US" sz="2800" dirty="0"/>
+                        <a:rPr lang="en-US" sz="2600" dirty="0">
+                          <a:latin typeface="Arial" panose="020B0604020202020204" pitchFamily="34" charset="0"/>
+                          <a:cs typeface="Arial" panose="020B0604020202020204" pitchFamily="34" charset="0"/>
+                        </a:rPr>
                         <a:t>.76</a:t>
                       </a:r>
                     </a:p>
@@ -5696,17 +5977,19 @@
                   </a:ext>
                 </a:extLst>
               </a:tr>
-              <a:tr h="206482">
+              <a:tr h="559910">
                 <a:tc>
                   <a:txBody>
                     <a:bodyPr/>
                     <a:lstStyle/>
                     <a:p>
                       <a:r>
-                        <a:rPr lang="en-US" sz="2800" dirty="0" err="1"/>
+                        <a:rPr lang="en-US" sz="2600" dirty="0">
+                          <a:latin typeface="Arial" panose="020B0604020202020204" pitchFamily="34" charset="0"/>
+                          <a:cs typeface="Arial" panose="020B0604020202020204" pitchFamily="34" charset="0"/>
+                        </a:rPr>
                         <a:t>PanTHERIA</a:t>
                       </a:r>
-                      <a:endParaRPr lang="en-US" sz="2800" dirty="0"/>
                     </a:p>
                   </a:txBody>
                   <a:tcPr/>
@@ -5717,7 +6000,10 @@
                     <a:lstStyle/>
                     <a:p>
                       <a:r>
-                        <a:rPr lang="en-US" sz="2800" dirty="0"/>
+                        <a:rPr lang="en-US" sz="2600" dirty="0">
+                          <a:latin typeface="Arial" panose="020B0604020202020204" pitchFamily="34" charset="0"/>
+                          <a:cs typeface="Arial" panose="020B0604020202020204" pitchFamily="34" charset="0"/>
+                        </a:rPr>
                         <a:t>No</a:t>
                       </a:r>
                     </a:p>
@@ -5730,7 +6016,10 @@
                     <a:lstStyle/>
                     <a:p>
                       <a:r>
-                        <a:rPr lang="en-US" sz="2800" dirty="0"/>
+                        <a:rPr lang="en-US" sz="2600" dirty="0">
+                          <a:latin typeface="Arial" panose="020B0604020202020204" pitchFamily="34" charset="0"/>
+                          <a:cs typeface="Arial" panose="020B0604020202020204" pitchFamily="34" charset="0"/>
+                        </a:rPr>
                         <a:t>376</a:t>
                       </a:r>
                     </a:p>
@@ -5743,7 +6032,10 @@
                     <a:lstStyle/>
                     <a:p>
                       <a:r>
-                        <a:rPr lang="en-US" sz="2800" dirty="0"/>
+                        <a:rPr lang="en-US" sz="2600" dirty="0">
+                          <a:latin typeface="Arial" panose="020B0604020202020204" pitchFamily="34" charset="0"/>
+                          <a:cs typeface="Arial" panose="020B0604020202020204" pitchFamily="34" charset="0"/>
+                        </a:rPr>
                         <a:t>.70</a:t>
                       </a:r>
                     </a:p>
@@ -5756,7 +6048,26 @@
                     <a:lstStyle/>
                     <a:p>
                       <a:r>
-                        <a:rPr lang="en-US" sz="2800" dirty="0"/>
+                        <a:rPr lang="en-US" sz="2600" dirty="0">
+                          <a:latin typeface="Arial" panose="020B0604020202020204" pitchFamily="34" charset="0"/>
+                          <a:cs typeface="Arial" panose="020B0604020202020204" pitchFamily="34" charset="0"/>
+                        </a:rPr>
+                        <a:t>7</a:t>
+                      </a:r>
+                    </a:p>
+                  </a:txBody>
+                  <a:tcPr/>
+                </a:tc>
+                <a:tc>
+                  <a:txBody>
+                    <a:bodyPr/>
+                    <a:lstStyle/>
+                    <a:p>
+                      <a:r>
+                        <a:rPr lang="en-US" sz="2600" dirty="0">
+                          <a:latin typeface="Arial" panose="020B0604020202020204" pitchFamily="34" charset="0"/>
+                          <a:cs typeface="Arial" panose="020B0604020202020204" pitchFamily="34" charset="0"/>
+                        </a:rPr>
                         <a:t>29</a:t>
                       </a:r>
                     </a:p>
@@ -5769,7 +6080,10 @@
                     <a:lstStyle/>
                     <a:p>
                       <a:r>
-                        <a:rPr lang="en-US" sz="2800" dirty="0"/>
+                        <a:rPr lang="en-US" sz="2600" dirty="0">
+                          <a:latin typeface="Arial" panose="020B0604020202020204" pitchFamily="34" charset="0"/>
+                          <a:cs typeface="Arial" panose="020B0604020202020204" pitchFamily="34" charset="0"/>
+                        </a:rPr>
                         <a:t>.63</a:t>
                       </a:r>
                     </a:p>
@@ -5782,7 +6096,10 @@
                     <a:lstStyle/>
                     <a:p>
                       <a:r>
-                        <a:rPr lang="en-US" sz="2800" dirty="0"/>
+                        <a:rPr lang="en-US" sz="2600" dirty="0">
+                          <a:latin typeface="Arial" panose="020B0604020202020204" pitchFamily="34" charset="0"/>
+                          <a:cs typeface="Arial" panose="020B0604020202020204" pitchFamily="34" charset="0"/>
+                        </a:rPr>
                         <a:t>.72</a:t>
                       </a:r>
                     </a:p>
@@ -5814,22 +6131,27 @@
           <p:nvPr/>
         </p:nvPicPr>
         <p:blipFill>
-          <a:blip r:embed="rId6"/>
-          <a:stretch>
-            <a:fillRect/>
-          </a:stretch>
+          <a:blip r:embed="rId6">
+            <a:extLst>
+              <a:ext uri="{28A0092B-C50C-407E-A947-70E740481C1C}">
+                <a14:useLocalDpi xmlns:a14="http://schemas.microsoft.com/office/drawing/2010/main" val="0"/>
+              </a:ext>
+            </a:extLst>
+          </a:blip>
+          <a:srcRect/>
+          <a:stretch/>
         </p:blipFill>
         <p:spPr>
           <a:xfrm>
-            <a:off x="4892222" y="26691004"/>
-            <a:ext cx="10298811" cy="9351596"/>
+            <a:off x="4892222" y="30218561"/>
+            <a:ext cx="8488295" cy="6187438"/>
           </a:xfrm>
           <a:prstGeom prst="rect">
             <a:avLst/>
           </a:prstGeom>
           <a:ln w="38100">
             <a:solidFill>
-              <a:schemeClr val="accent1"/>
+              <a:schemeClr val="tx1"/>
             </a:solidFill>
           </a:ln>
         </p:spPr>
@@ -5848,8 +6170,8 @@
         </p:nvSpPr>
         <p:spPr>
           <a:xfrm>
-            <a:off x="13694799" y="20895394"/>
-            <a:ext cx="15143096" cy="1384995"/>
+            <a:off x="13694799" y="20225437"/>
+            <a:ext cx="15102725" cy="1965282"/>
           </a:xfrm>
           <a:prstGeom prst="rect">
             <a:avLst/>
@@ -5862,6 +6184,11 @@
           </a:bodyPr>
           <a:lstStyle/>
           <a:p>
+            <a:pPr>
+              <a:lnSpc>
+                <a:spcPct val="150000"/>
+              </a:lnSpc>
+            </a:pPr>
             <a:r>
               <a:rPr lang="en-US" sz="2800" b="1" dirty="0">
                 <a:latin typeface="Arial" panose="020B0604020202020204" pitchFamily="34" charset="0"/>
@@ -5874,23 +6201,63 @@
                 <a:latin typeface="Arial" panose="020B0604020202020204" pitchFamily="34" charset="0"/>
                 <a:cs typeface="Arial" panose="020B0604020202020204" pitchFamily="34" charset="0"/>
               </a:rPr>
-              <a:t>Descriptive statistics of primate life-history statistics for each database. </a:t>
-            </a:r>
-            <a:r>
-              <a:rPr lang="en-US" sz="2800" dirty="0" err="1">
-                <a:latin typeface="Arial" panose="020B0604020202020204" pitchFamily="34" charset="0"/>
-                <a:cs typeface="Arial" panose="020B0604020202020204" pitchFamily="34" charset="0"/>
-              </a:rPr>
-              <a:t>AnAge</a:t>
+              <a:t>Descriptive statistics of primate life-history statistics for each database. AnAge is the only database that is continually updated, with its last update in 2023. Each database has fewer missing values for our selected key life-history traits compared to all recorded statistics.</a:t>
+            </a:r>
+            <a:endParaRPr lang="en-US" sz="2800" dirty="0"/>
+          </a:p>
+        </p:txBody>
+      </p:sp>
+      <p:sp>
+        <p:nvSpPr>
+          <p:cNvPr id="16" name="TextBox 15">
+            <a:extLst>
+              <a:ext uri="{FF2B5EF4-FFF2-40B4-BE49-F238E27FC236}">
+                <a16:creationId xmlns:a16="http://schemas.microsoft.com/office/drawing/2014/main" id="{93DF6F33-EBCA-A373-C636-B42DAC9A95E5}"/>
+              </a:ext>
+            </a:extLst>
+          </p:cNvPr>
+          <p:cNvSpPr txBox="1"/>
+          <p:nvPr/>
+        </p:nvSpPr>
+        <p:spPr>
+          <a:xfrm>
+            <a:off x="4892222" y="36405999"/>
+            <a:ext cx="8488295" cy="1305165"/>
+          </a:xfrm>
+          <a:prstGeom prst="rect">
+            <a:avLst/>
+          </a:prstGeom>
+          <a:noFill/>
+        </p:spPr>
+        <p:txBody>
+          <a:bodyPr wrap="square" rtlCol="0">
+            <a:spAutoFit/>
+          </a:bodyPr>
+          <a:lstStyle/>
+          <a:p>
+            <a:pPr>
+              <a:lnSpc>
+                <a:spcPct val="150000"/>
+              </a:lnSpc>
+            </a:pPr>
+            <a:r>
+              <a:rPr lang="en-US" sz="2800" b="1" dirty="0">
+                <a:latin typeface="Arial" panose="020B0604020202020204" pitchFamily="34" charset="0"/>
+                <a:cs typeface="Arial" panose="020B0604020202020204" pitchFamily="34" charset="0"/>
+              </a:rPr>
+              <a:t>Figure 2. </a:t>
             </a:r>
             <a:r>
               <a:rPr lang="en-US" sz="2800" dirty="0">
                 <a:latin typeface="Arial" panose="020B0604020202020204" pitchFamily="34" charset="0"/>
                 <a:cs typeface="Arial" panose="020B0604020202020204" pitchFamily="34" charset="0"/>
               </a:rPr>
-              <a:t> is the only database that is continually updated, with its last update in 2023. Each database has fewer missing values for our selected key life-history traits compared with reported statistics.</a:t>
-            </a:r>
-            <a:endParaRPr lang="en-US" sz="2800" dirty="0"/>
+              <a:t>Relative proportions of different primate clades for each database. </a:t>
+            </a:r>
+            <a:endParaRPr lang="en-US" sz="2800" b="1" dirty="0">
+              <a:latin typeface="Arial" panose="020B0604020202020204" pitchFamily="34" charset="0"/>
+              <a:cs typeface="Arial" panose="020B0604020202020204" pitchFamily="34" charset="0"/>
+            </a:endParaRPr>
           </a:p>
         </p:txBody>
       </p:sp>

</xml_diff>

<commit_message>
finalized figures for poster and added poster drafts to repo
</commit_message>
<xml_diff>
--- a/AABA-Poster/GM-AABA2026Poster-Draft3.pptx
+++ b/AABA-Poster/GM-AABA2026Poster-Draft3.pptx
@@ -3057,7 +3057,7 @@
         <p:spPr>
           <a:xfrm>
             <a:off x="299864" y="5466463"/>
-            <a:ext cx="3931920" cy="20590252"/>
+            <a:ext cx="3931920" cy="24468237"/>
           </a:xfrm>
           <a:custGeom>
             <a:avLst/>
@@ -3301,6 +3301,18 @@
               </a:rPr>
               <a:t>Borries, C., Gordon, A. D., &amp; Koenig, A. (2013). Beware of Primate Life History Data: A Plea for Data Standards and a Repository. PLOS ONE, 8(6), e67200. </a:t>
             </a:r>
+            <a:r>
+              <a:rPr lang="en-US" u="sng" dirty="0">
+                <a:latin typeface="Arial" panose="020B0604020202020204" pitchFamily="34" charset="0"/>
+                <a:cs typeface="Arial" panose="020B0604020202020204" pitchFamily="34" charset="0"/>
+                <a:hlinkClick r:id="rId2"/>
+              </a:rPr>
+              <a:t>https://doi.org/10.1371/journal.pone.0067200</a:t>
+            </a:r>
+            <a:endParaRPr lang="en-US" dirty="0">
+              <a:latin typeface="Arial" panose="020B0604020202020204" pitchFamily="34" charset="0"/>
+              <a:cs typeface="Arial" panose="020B0604020202020204" pitchFamily="34" charset="0"/>
+            </a:endParaRPr>
           </a:p>
           <a:p>
             <a:pPr marL="460375" indent="-460375">
@@ -3314,6 +3326,18 @@
               </a:rPr>
               <a:t>Ernest, S.K.M. (2003), LIFE HISTORY CHARACTERISTICS OF PLACENTAL NONVOLANT MAMMALS. Ecology, 84: 3402-3402. </a:t>
             </a:r>
+            <a:r>
+              <a:rPr lang="en-US" u="sng" dirty="0">
+                <a:latin typeface="Arial" panose="020B0604020202020204" pitchFamily="34" charset="0"/>
+                <a:cs typeface="Arial" panose="020B0604020202020204" pitchFamily="34" charset="0"/>
+                <a:hlinkClick r:id="rId3"/>
+              </a:rPr>
+              <a:t>https://doi.org/10.1890/02-9002</a:t>
+            </a:r>
+            <a:endParaRPr lang="en-US" dirty="0">
+              <a:latin typeface="Arial" panose="020B0604020202020204" pitchFamily="34" charset="0"/>
+              <a:cs typeface="Arial" panose="020B0604020202020204" pitchFamily="34" charset="0"/>
+            </a:endParaRPr>
           </a:p>
           <a:p>
             <a:pPr marL="460375" indent="-460375">
@@ -3353,6 +3377,18 @@
               </a:rPr>
               <a:t>Harvey, P. H., &amp; Clutton-Brock, T. H. (1985). Life History Variation in Primates. Evolution, 39(3), 559–581. </a:t>
             </a:r>
+            <a:r>
+              <a:rPr lang="en-US" dirty="0">
+                <a:latin typeface="Arial" panose="020B0604020202020204" pitchFamily="34" charset="0"/>
+                <a:cs typeface="Arial" panose="020B0604020202020204" pitchFamily="34" charset="0"/>
+                <a:hlinkClick r:id="rId4"/>
+              </a:rPr>
+              <a:t>https://doi.org/10.1111/j.1558-5646.1985.tb00395.x</a:t>
+            </a:r>
+            <a:endParaRPr lang="en-US" dirty="0">
+              <a:latin typeface="Arial" panose="020B0604020202020204" pitchFamily="34" charset="0"/>
+              <a:cs typeface="Arial" panose="020B0604020202020204" pitchFamily="34" charset="0"/>
+            </a:endParaRPr>
           </a:p>
           <a:p>
             <a:pPr marL="460375" indent="-460375">
@@ -3379,6 +3415,18 @@
               </a:rPr>
               <a:t>Jones, K. E., Bielby, J., Cardillo, M., et al. (2009). PanTHERIA: A species-level database of life history, ecology, and geography of extant and recently extinct mammals. Ecology, 90(9), 2648–2648. </a:t>
             </a:r>
+            <a:r>
+              <a:rPr lang="en-US" u="sng" dirty="0">
+                <a:latin typeface="Arial" panose="020B0604020202020204" pitchFamily="34" charset="0"/>
+                <a:cs typeface="Arial" panose="020B0604020202020204" pitchFamily="34" charset="0"/>
+                <a:hlinkClick r:id="rId5"/>
+              </a:rPr>
+              <a:t>https://doi.org/10.1890/08-1494.1</a:t>
+            </a:r>
+            <a:endParaRPr lang="en-US" dirty="0">
+              <a:latin typeface="Arial" panose="020B0604020202020204" pitchFamily="34" charset="0"/>
+              <a:cs typeface="Arial" panose="020B0604020202020204" pitchFamily="34" charset="0"/>
+            </a:endParaRPr>
           </a:p>
           <a:p>
             <a:pPr marL="460375" indent="-460375">
@@ -3417,8 +3465,20 @@
                 <a:latin typeface="Arial" panose="020B0604020202020204" pitchFamily="34" charset="0"/>
                 <a:cs typeface="Arial" panose="020B0604020202020204" pitchFamily="34" charset="0"/>
               </a:rPr>
-              <a:t>Myhrvold, N.P., Baldridge, E., Chan, B., et al. (2015), An amniote life-history database to perform comparative analyses with birds, mammals, and reptiles. Ecology, 96: 3109-3109.</a:t>
-            </a:r>
+              <a:t>Myhrvold, N.P., Baldridge, E., Chan, B., et al. (2015), An amniote life-history database to perform comparative analyses with birds, mammals, and reptiles. Ecology, 96: 3109-3109. </a:t>
+            </a:r>
+            <a:r>
+              <a:rPr lang="en-US" dirty="0">
+                <a:latin typeface="Arial" panose="020B0604020202020204" pitchFamily="34" charset="0"/>
+                <a:cs typeface="Arial" panose="020B0604020202020204" pitchFamily="34" charset="0"/>
+                <a:hlinkClick r:id="rId6"/>
+              </a:rPr>
+              <a:t>https://doi.org/10.1890/15-0846R.1</a:t>
+            </a:r>
+            <a:endParaRPr lang="en-US" dirty="0">
+              <a:latin typeface="Arial" panose="020B0604020202020204" pitchFamily="34" charset="0"/>
+              <a:cs typeface="Arial" panose="020B0604020202020204" pitchFamily="34" charset="0"/>
+            </a:endParaRPr>
           </a:p>
           <a:p>
             <a:pPr marL="460375" indent="-460375">
@@ -3430,8 +3490,20 @@
                 <a:latin typeface="Arial" panose="020B0604020202020204" pitchFamily="34" charset="0"/>
                 <a:cs typeface="Arial" panose="020B0604020202020204" pitchFamily="34" charset="0"/>
               </a:rPr>
-              <a:t>Stearns, S. C. (1989). Trade-Offs in Life-History Evolution. Functional Ecology, 3(3), 259.</a:t>
-            </a:r>
+              <a:t>Stearns, S. C. (1989). Trade-Offs in Life-History Evolution. Functional Ecology, 3(3), 259. </a:t>
+            </a:r>
+            <a:r>
+              <a:rPr lang="en-US" dirty="0">
+                <a:latin typeface="Arial" panose="020B0604020202020204" pitchFamily="34" charset="0"/>
+                <a:cs typeface="Arial" panose="020B0604020202020204" pitchFamily="34" charset="0"/>
+                <a:hlinkClick r:id="rId7"/>
+              </a:rPr>
+              <a:t>https://doi.org/10.2307/2389364</a:t>
+            </a:r>
+            <a:endParaRPr lang="en-US" dirty="0">
+              <a:latin typeface="Arial" panose="020B0604020202020204" pitchFamily="34" charset="0"/>
+              <a:cs typeface="Arial" panose="020B0604020202020204" pitchFamily="34" charset="0"/>
+            </a:endParaRPr>
           </a:p>
           <a:p>
             <a:pPr marL="460375" indent="-460375">
@@ -3473,6 +3545,18 @@
               </a:rPr>
               <a:t>(9), 830–840. </a:t>
             </a:r>
+            <a:r>
+              <a:rPr lang="en-US" dirty="0">
+                <a:latin typeface="Arial" panose="020B0604020202020204" pitchFamily="34" charset="0"/>
+                <a:cs typeface="Arial" panose="020B0604020202020204" pitchFamily="34" charset="0"/>
+                <a:hlinkClick r:id="rId8"/>
+              </a:rPr>
+              <a:t>https://doi.org/10.1016/j.tree.2024.06.001</a:t>
+            </a:r>
+            <a:endParaRPr lang="en-US" dirty="0">
+              <a:latin typeface="Arial" panose="020B0604020202020204" pitchFamily="34" charset="0"/>
+              <a:cs typeface="Arial" panose="020B0604020202020204" pitchFamily="34" charset="0"/>
+            </a:endParaRPr>
           </a:p>
           <a:p>
             <a:pPr marL="460375" indent="-460375">
@@ -3491,8 +3575,20 @@
                 <a:latin typeface="Arial" panose="020B0604020202020204" pitchFamily="34" charset="0"/>
                 <a:cs typeface="Arial" panose="020B0604020202020204" pitchFamily="34" charset="0"/>
               </a:rPr>
-              <a:t> KB, Altmann J, Brockman DK, et al. (2010) The Primate Life History Database: A unique shared ecological data resource. Methods Ecol Evol., 1(2):199-211.</a:t>
-            </a:r>
+              <a:t> KB, Altmann J, Brockman DK, et al. (2010) The Primate Life History Database: A unique shared ecological data resource. Methods Ecol Evol., 1(2):199-211. </a:t>
+            </a:r>
+            <a:r>
+              <a:rPr lang="en-US" dirty="0">
+                <a:latin typeface="Arial" panose="020B0604020202020204" pitchFamily="34" charset="0"/>
+                <a:cs typeface="Arial" panose="020B0604020202020204" pitchFamily="34" charset="0"/>
+                <a:hlinkClick r:id="rId9"/>
+              </a:rPr>
+              <a:t>https://doi.org/10.1111/j.2041-210x.2010.00023.x</a:t>
+            </a:r>
+            <a:endParaRPr lang="en-US" dirty="0">
+              <a:latin typeface="Arial" panose="020B0604020202020204" pitchFamily="34" charset="0"/>
+              <a:cs typeface="Arial" panose="020B0604020202020204" pitchFamily="34" charset="0"/>
+            </a:endParaRPr>
           </a:p>
         </p:txBody>
       </p:sp>
@@ -3676,7 +3772,7 @@
         <p:spPr>
           <a:xfrm>
             <a:off x="28991530" y="5466463"/>
-            <a:ext cx="9022919" cy="20141091"/>
+            <a:ext cx="9022919" cy="20848320"/>
           </a:xfrm>
           <a:custGeom>
             <a:avLst/>
@@ -3877,7 +3973,7 @@
               </a:lnSpc>
             </a:pPr>
             <a:r>
-              <a:rPr lang="en-US" sz="6000" b="1" u="sng" spc="300" dirty="0">
+              <a:rPr lang="en-US" sz="5600" b="1" u="sng" spc="300" dirty="0">
                 <a:latin typeface="Arial" panose="020B0604020202020204" pitchFamily="34" charset="0"/>
                 <a:cs typeface="Arial" panose="020B0604020202020204" pitchFamily="34" charset="0"/>
               </a:rPr>
@@ -3913,7 +4009,7 @@
                 <a:latin typeface="Arial" panose="020B0604020202020204" pitchFamily="34" charset="0"/>
                 <a:cs typeface="Arial" panose="020B0604020202020204" pitchFamily="34" charset="0"/>
               </a:rPr>
-              <a:t>We generated descriptive statistics of the data to compare their structures and find common variables.</a:t>
+              <a:t>We compared the structures of the datasets and selected seven key LH traits commonly studied in primates and shared across all or most datasets.</a:t>
             </a:r>
           </a:p>
           <a:p>
@@ -3929,7 +4025,71 @@
                 <a:latin typeface="Arial" panose="020B0604020202020204" pitchFamily="34" charset="0"/>
                 <a:cs typeface="Arial" panose="020B0604020202020204" pitchFamily="34" charset="0"/>
               </a:rPr>
-              <a:t>We selected seven key LH traits commonly studied in primates and shared across all or most of our datasets.</a:t>
+              <a:t>We compared these datasets using three metrics: The presence of values, taxonomic representation, and metadata accessibility and content.</a:t>
+            </a:r>
+          </a:p>
+          <a:p>
+            <a:pPr marL="914400" lvl="1" indent="-457200">
+              <a:lnSpc>
+                <a:spcPct val="150000"/>
+              </a:lnSpc>
+              <a:buFont typeface="Wingdings" panose="05000000000000000000" pitchFamily="2" charset="2"/>
+              <a:buChar char="v"/>
+            </a:pPr>
+            <a:r>
+              <a:rPr lang="en-US" sz="2800" dirty="0">
+                <a:latin typeface="Arial" panose="020B0604020202020204" pitchFamily="34" charset="0"/>
+                <a:cs typeface="Arial" panose="020B0604020202020204" pitchFamily="34" charset="0"/>
+              </a:rPr>
+              <a:t>For each database, we quantified the proportion of values equivalent to “NA” for all available key traits for each species.</a:t>
+            </a:r>
+          </a:p>
+          <a:p>
+            <a:pPr marL="914400" lvl="1" indent="-457200">
+              <a:lnSpc>
+                <a:spcPct val="150000"/>
+              </a:lnSpc>
+              <a:buFont typeface="Wingdings" panose="05000000000000000000" pitchFamily="2" charset="2"/>
+              <a:buChar char="v"/>
+            </a:pPr>
+            <a:r>
+              <a:rPr lang="en-US" sz="2800" dirty="0">
+                <a:latin typeface="Arial" panose="020B0604020202020204" pitchFamily="34" charset="0"/>
+                <a:cs typeface="Arial" panose="020B0604020202020204" pitchFamily="34" charset="0"/>
+              </a:rPr>
+              <a:t>We quantified the relative proportions of primate species and compared each database to examine biases in species coverage.</a:t>
+            </a:r>
+          </a:p>
+          <a:p>
+            <a:pPr marL="914400" lvl="1" indent="-457200">
+              <a:lnSpc>
+                <a:spcPct val="150000"/>
+              </a:lnSpc>
+              <a:buFont typeface="Wingdings" panose="05000000000000000000" pitchFamily="2" charset="2"/>
+              <a:buChar char="v"/>
+            </a:pPr>
+            <a:r>
+              <a:rPr lang="en-US" sz="2800" dirty="0">
+                <a:latin typeface="Arial" panose="020B0604020202020204" pitchFamily="34" charset="0"/>
+                <a:cs typeface="Arial" panose="020B0604020202020204" pitchFamily="34" charset="0"/>
+              </a:rPr>
+              <a:t>We designed a rubric to objectively score the metadata availability, accessibility, and content of each dataset.</a:t>
+            </a:r>
+          </a:p>
+          <a:p>
+            <a:pPr marL="914400" lvl="1" indent="-457200">
+              <a:lnSpc>
+                <a:spcPct val="150000"/>
+              </a:lnSpc>
+              <a:buFont typeface="Wingdings" panose="05000000000000000000" pitchFamily="2" charset="2"/>
+              <a:buChar char="v"/>
+            </a:pPr>
+            <a:r>
+              <a:rPr lang="en-US" sz="2800" dirty="0">
+                <a:latin typeface="Arial" panose="020B0604020202020204" pitchFamily="34" charset="0"/>
+                <a:cs typeface="Arial" panose="020B0604020202020204" pitchFamily="34" charset="0"/>
+              </a:rPr>
+              <a:t>We categorically scored the proportion of variables described by the authors and evaluated the detail of description based on the presence of variable units, measurement type, and citation.</a:t>
             </a:r>
           </a:p>
           <a:p>
@@ -3945,71 +4105,7 @@
                 <a:latin typeface="Arial" panose="020B0604020202020204" pitchFamily="34" charset="0"/>
                 <a:cs typeface="Arial" panose="020B0604020202020204" pitchFamily="34" charset="0"/>
               </a:rPr>
-              <a:t>We compared these datasets using three metrics: The presence of values, taxonomic representation, and metadata accessibility and content.</a:t>
-            </a:r>
-          </a:p>
-          <a:p>
-            <a:pPr marL="914400" lvl="1" indent="-457200">
-              <a:lnSpc>
-                <a:spcPct val="150000"/>
-              </a:lnSpc>
-              <a:buFont typeface="Wingdings" panose="05000000000000000000" pitchFamily="2" charset="2"/>
-              <a:buChar char="v"/>
-            </a:pPr>
-            <a:r>
-              <a:rPr lang="en-US" sz="2800" dirty="0">
-                <a:latin typeface="Arial" panose="020B0604020202020204" pitchFamily="34" charset="0"/>
-                <a:cs typeface="Arial" panose="020B0604020202020204" pitchFamily="34" charset="0"/>
-              </a:rPr>
-              <a:t>For each database, we quantified the proportion of values equivalent to “NA” for all available key traits for each species.</a:t>
-            </a:r>
-          </a:p>
-          <a:p>
-            <a:pPr marL="914400" lvl="1" indent="-457200">
-              <a:lnSpc>
-                <a:spcPct val="150000"/>
-              </a:lnSpc>
-              <a:buFont typeface="Wingdings" panose="05000000000000000000" pitchFamily="2" charset="2"/>
-              <a:buChar char="v"/>
-            </a:pPr>
-            <a:r>
-              <a:rPr lang="en-US" sz="2800" dirty="0">
-                <a:latin typeface="Arial" panose="020B0604020202020204" pitchFamily="34" charset="0"/>
-                <a:cs typeface="Arial" panose="020B0604020202020204" pitchFamily="34" charset="0"/>
-              </a:rPr>
-              <a:t>We quantified the relative proportions of primate species at the family level and compared each database to examine biases in species coverage.</a:t>
-            </a:r>
-          </a:p>
-          <a:p>
-            <a:pPr marL="914400" lvl="1" indent="-457200">
-              <a:lnSpc>
-                <a:spcPct val="150000"/>
-              </a:lnSpc>
-              <a:buFont typeface="Wingdings" panose="05000000000000000000" pitchFamily="2" charset="2"/>
-              <a:buChar char="v"/>
-            </a:pPr>
-            <a:r>
-              <a:rPr lang="en-US" sz="2800" dirty="0">
-                <a:latin typeface="Arial" panose="020B0604020202020204" pitchFamily="34" charset="0"/>
-                <a:cs typeface="Arial" panose="020B0604020202020204" pitchFamily="34" charset="0"/>
-              </a:rPr>
-              <a:t>We designed a rubric to objectively score the metadata availability, accessibility, and content of each dataset.</a:t>
-            </a:r>
-          </a:p>
-          <a:p>
-            <a:pPr marL="914400" lvl="1" indent="-457200">
-              <a:lnSpc>
-                <a:spcPct val="150000"/>
-              </a:lnSpc>
-              <a:buFont typeface="Wingdings" panose="05000000000000000000" pitchFamily="2" charset="2"/>
-              <a:buChar char="v"/>
-            </a:pPr>
-            <a:r>
-              <a:rPr lang="en-US" sz="2800" dirty="0">
-                <a:latin typeface="Arial" panose="020B0604020202020204" pitchFamily="34" charset="0"/>
-                <a:cs typeface="Arial" panose="020B0604020202020204" pitchFamily="34" charset="0"/>
-              </a:rPr>
-              <a:t>We categorically scored the proportion of variables described by the authors and evaluated the detail of description based on the presence of variable units, measurement type, and citation.</a:t>
+              <a:t>We attempted to validate the division of age of sexual maturity (ASM) into sex classes by comparison to the dimorphism rates of adult body mass using Wilcoxon rank sum and signed rank tests with continuity corrections.</a:t>
             </a:r>
           </a:p>
           <a:p>
@@ -4025,7 +4121,7 @@
                 <a:latin typeface="Arial" panose="020B0604020202020204" pitchFamily="34" charset="0"/>
                 <a:cs typeface="Arial" panose="020B0604020202020204" pitchFamily="34" charset="0"/>
               </a:rPr>
-              <a:t>Additionally, we attempted to validate the division of age of sexual maturity (ASM) into sex classes by comparison to the dimorphism rates of adult body mass using Wilcoxon rank sum and signed rank tests with continuity corrections .</a:t>
+              <a:t>We evaluated the difference between ASM and age at first reproduction (AFR) when a species has data for both.</a:t>
             </a:r>
           </a:p>
         </p:txBody>
@@ -4046,8 +4142,8 @@
         </p:nvSpPr>
         <p:spPr>
           <a:xfrm>
-            <a:off x="4736692" y="5485290"/>
-            <a:ext cx="8488295" cy="20848320"/>
+            <a:off x="4736692" y="5485289"/>
+            <a:ext cx="8488295" cy="12292789"/>
           </a:xfrm>
           <a:prstGeom prst="rect">
             <a:avLst/>
@@ -4073,7 +4169,7 @@
               </a:lnSpc>
             </a:pPr>
             <a:r>
-              <a:rPr lang="en-US" sz="6000" b="1" u="sng" spc="300" dirty="0">
+              <a:rPr lang="en-US" sz="5600" b="1" u="sng" spc="300" dirty="0">
                 <a:latin typeface="Arial" panose="020B0604020202020204" pitchFamily="34" charset="0"/>
                 <a:cs typeface="Arial" panose="020B0604020202020204" pitchFamily="34" charset="0"/>
               </a:rPr>
@@ -4287,13 +4383,15 @@
         </p:nvSpPr>
         <p:spPr>
           <a:xfrm>
-            <a:off x="5476886" y="18023771"/>
-            <a:ext cx="7007905" cy="7878503"/>
+            <a:off x="4736692" y="18038623"/>
+            <a:ext cx="8488295" cy="6475812"/>
           </a:xfrm>
           <a:prstGeom prst="rect">
             <a:avLst/>
           </a:prstGeom>
-          <a:noFill/>
+          <a:solidFill>
+            <a:schemeClr val="bg1"/>
+          </a:solidFill>
           <a:ln>
             <a:solidFill>
               <a:schemeClr val="tx1"/>
@@ -4312,7 +4410,7 @@
               </a:lnSpc>
             </a:pPr>
             <a:r>
-              <a:rPr lang="en-US" sz="6000" b="1" u="sng" spc="300" dirty="0">
+              <a:rPr lang="en-US" sz="5600" b="1" u="sng" spc="300" dirty="0">
                 <a:latin typeface="Arial" panose="020B0604020202020204" pitchFamily="34" charset="0"/>
                 <a:cs typeface="Arial" panose="020B0604020202020204" pitchFamily="34" charset="0"/>
               </a:rPr>
@@ -4365,248 +4463,6 @@
                 <a:cs typeface="Arial" panose="020B0604020202020204" pitchFamily="34" charset="0"/>
               </a:rPr>
               <a:t>To offer recommendations for best practices when using collated primate LH data</a:t>
-            </a:r>
-          </a:p>
-        </p:txBody>
-      </p:sp>
-      <p:sp>
-        <p:nvSpPr>
-          <p:cNvPr id="4" name="TextBox 3">
-            <a:extLst>
-              <a:ext uri="{FF2B5EF4-FFF2-40B4-BE49-F238E27FC236}">
-                <a16:creationId xmlns:a16="http://schemas.microsoft.com/office/drawing/2014/main" id="{0620BADA-1FC1-3AFA-FD99-029D6F36C677}"/>
-              </a:ext>
-            </a:extLst>
-          </p:cNvPr>
-          <p:cNvSpPr txBox="1"/>
-          <p:nvPr/>
-        </p:nvSpPr>
-        <p:spPr>
-          <a:xfrm>
-            <a:off x="14411818" y="30769285"/>
-            <a:ext cx="7931966" cy="6654194"/>
-          </a:xfrm>
-          <a:prstGeom prst="rect">
-            <a:avLst/>
-          </a:prstGeom>
-          <a:noFill/>
-          <a:ln>
-            <a:solidFill>
-              <a:schemeClr val="tx1"/>
-            </a:solidFill>
-          </a:ln>
-        </p:spPr>
-        <p:txBody>
-          <a:bodyPr wrap="square" rtlCol="0">
-            <a:spAutoFit/>
-          </a:bodyPr>
-          <a:lstStyle/>
-          <a:p>
-            <a:pPr>
-              <a:lnSpc>
-                <a:spcPct val="150000"/>
-              </a:lnSpc>
-            </a:pPr>
-            <a:r>
-              <a:rPr lang="en-US" sz="4400" b="1" u="sng" dirty="0">
-                <a:latin typeface="Arial" panose="020B0604020202020204" pitchFamily="34" charset="0"/>
-                <a:cs typeface="Arial" panose="020B0604020202020204" pitchFamily="34" charset="0"/>
-              </a:rPr>
-              <a:t>&lt; Variable Definitions Table(s)&gt;</a:t>
-            </a:r>
-            <a:endParaRPr lang="en-US" sz="4400" dirty="0">
-              <a:latin typeface="Arial" panose="020B0604020202020204" pitchFamily="34" charset="0"/>
-              <a:cs typeface="Arial" panose="020B0604020202020204" pitchFamily="34" charset="0"/>
-            </a:endParaRPr>
-          </a:p>
-          <a:p>
-            <a:pPr>
-              <a:lnSpc>
-                <a:spcPct val="150000"/>
-              </a:lnSpc>
-            </a:pPr>
-            <a:r>
-              <a:rPr lang="en-US" dirty="0">
-                <a:latin typeface="Arial" panose="020B0604020202020204" pitchFamily="34" charset="0"/>
-                <a:cs typeface="Arial" panose="020B0604020202020204" pitchFamily="34" charset="0"/>
-              </a:rPr>
-              <a:t>HOW TO CONVERT THIS PAGE INTO ONE READABLE TABLE?</a:t>
-            </a:r>
-          </a:p>
-          <a:p>
-            <a:pPr>
-              <a:lnSpc>
-                <a:spcPct val="150000"/>
-              </a:lnSpc>
-            </a:pPr>
-            <a:r>
-              <a:rPr lang="en-US" dirty="0">
-                <a:latin typeface="Arial" panose="020B0604020202020204" pitchFamily="34" charset="0"/>
-                <a:cs typeface="Arial" panose="020B0604020202020204" pitchFamily="34" charset="0"/>
-                <a:hlinkClick r:id="rId2"/>
-              </a:rPr>
-              <a:t>https://bygentry.github.io/LHDB-PCA/Variable-Definitions.html</a:t>
-            </a:r>
-            <a:endParaRPr lang="en-US" dirty="0">
-              <a:latin typeface="Arial" panose="020B0604020202020204" pitchFamily="34" charset="0"/>
-              <a:cs typeface="Arial" panose="020B0604020202020204" pitchFamily="34" charset="0"/>
-            </a:endParaRPr>
-          </a:p>
-          <a:p>
-            <a:pPr marL="285750" indent="-285750">
-              <a:lnSpc>
-                <a:spcPct val="150000"/>
-              </a:lnSpc>
-              <a:buFont typeface="Arial" panose="020B0604020202020204" pitchFamily="34" charset="0"/>
-              <a:buChar char="•"/>
-            </a:pPr>
-            <a:r>
-              <a:rPr lang="en-US" dirty="0">
-                <a:latin typeface="Arial" panose="020B0604020202020204" pitchFamily="34" charset="0"/>
-                <a:cs typeface="Arial" panose="020B0604020202020204" pitchFamily="34" charset="0"/>
-              </a:rPr>
-              <a:t>remove notes column</a:t>
-            </a:r>
-          </a:p>
-          <a:p>
-            <a:pPr marL="285750" indent="-285750">
-              <a:lnSpc>
-                <a:spcPct val="150000"/>
-              </a:lnSpc>
-              <a:buFont typeface="Arial" panose="020B0604020202020204" pitchFamily="34" charset="0"/>
-              <a:buChar char="•"/>
-            </a:pPr>
-            <a:r>
-              <a:rPr lang="en-US" dirty="0">
-                <a:latin typeface="Arial" panose="020B0604020202020204" pitchFamily="34" charset="0"/>
-                <a:cs typeface="Arial" panose="020B0604020202020204" pitchFamily="34" charset="0"/>
-              </a:rPr>
-              <a:t>include unit discrepancies (</a:t>
-            </a:r>
-            <a:r>
-              <a:rPr lang="en-US" dirty="0" err="1">
-                <a:latin typeface="Arial" panose="020B0604020202020204" pitchFamily="34" charset="0"/>
-                <a:cs typeface="Arial" panose="020B0604020202020204" pitchFamily="34" charset="0"/>
-              </a:rPr>
-              <a:t>mo</a:t>
-            </a:r>
-            <a:r>
-              <a:rPr lang="en-US" dirty="0">
-                <a:latin typeface="Arial" panose="020B0604020202020204" pitchFamily="34" charset="0"/>
-                <a:cs typeface="Arial" panose="020B0604020202020204" pitchFamily="34" charset="0"/>
-              </a:rPr>
-              <a:t> vs days, grams vs kg, etc.)  to illustrate influence of researchers personal choices and callback </a:t>
-            </a:r>
-            <a:r>
-              <a:rPr lang="en-US" dirty="0" err="1">
-                <a:latin typeface="Arial" panose="020B0604020202020204" pitchFamily="34" charset="0"/>
-                <a:cs typeface="Arial" panose="020B0604020202020204" pitchFamily="34" charset="0"/>
-              </a:rPr>
-              <a:t>borries</a:t>
-            </a:r>
-            <a:r>
-              <a:rPr lang="en-US" dirty="0">
-                <a:latin typeface="Arial" panose="020B0604020202020204" pitchFamily="34" charset="0"/>
-                <a:cs typeface="Arial" panose="020B0604020202020204" pitchFamily="34" charset="0"/>
-              </a:rPr>
-              <a:t> statement </a:t>
-            </a:r>
-          </a:p>
-          <a:p>
-            <a:pPr marL="742950" lvl="1" indent="-285750">
-              <a:lnSpc>
-                <a:spcPct val="150000"/>
-              </a:lnSpc>
-              <a:buFont typeface="Arial" panose="020B0604020202020204" pitchFamily="34" charset="0"/>
-              <a:buChar char="•"/>
-            </a:pPr>
-            <a:r>
-              <a:rPr lang="en-US" dirty="0">
-                <a:latin typeface="Arial" panose="020B0604020202020204" pitchFamily="34" charset="0"/>
-                <a:cs typeface="Arial" panose="020B0604020202020204" pitchFamily="34" charset="0"/>
-              </a:rPr>
-              <a:t>“one would assume that researchers have long since agreed upon life history definitions and are using </a:t>
-            </a:r>
-            <a:r>
-              <a:rPr lang="en-US" b="1" u="sng" dirty="0">
-                <a:latin typeface="Arial" panose="020B0604020202020204" pitchFamily="34" charset="0"/>
-                <a:cs typeface="Arial" panose="020B0604020202020204" pitchFamily="34" charset="0"/>
-              </a:rPr>
-              <a:t>reliable</a:t>
-            </a:r>
-            <a:r>
-              <a:rPr lang="en-US" dirty="0">
-                <a:latin typeface="Arial" panose="020B0604020202020204" pitchFamily="34" charset="0"/>
-                <a:cs typeface="Arial" panose="020B0604020202020204" pitchFamily="34" charset="0"/>
-              </a:rPr>
-              <a:t> and </a:t>
-            </a:r>
-            <a:r>
-              <a:rPr lang="en-US" b="1" u="sng" dirty="0">
-                <a:latin typeface="Arial" panose="020B0604020202020204" pitchFamily="34" charset="0"/>
-                <a:cs typeface="Arial" panose="020B0604020202020204" pitchFamily="34" charset="0"/>
-              </a:rPr>
-              <a:t>accurate data </a:t>
-            </a:r>
-            <a:r>
-              <a:rPr lang="en-US" dirty="0">
-                <a:latin typeface="Arial" panose="020B0604020202020204" pitchFamily="34" charset="0"/>
-                <a:cs typeface="Arial" panose="020B0604020202020204" pitchFamily="34" charset="0"/>
-              </a:rPr>
-              <a:t>stored </a:t>
-            </a:r>
-            <a:r>
-              <a:rPr lang="en-US" b="1" u="sng" dirty="0">
-                <a:latin typeface="Arial" panose="020B0604020202020204" pitchFamily="34" charset="0"/>
-                <a:cs typeface="Arial" panose="020B0604020202020204" pitchFamily="34" charset="0"/>
-              </a:rPr>
-              <a:t>in</a:t>
-            </a:r>
-            <a:r>
-              <a:rPr lang="en-US" dirty="0">
-                <a:latin typeface="Arial" panose="020B0604020202020204" pitchFamily="34" charset="0"/>
-                <a:cs typeface="Arial" panose="020B0604020202020204" pitchFamily="34" charset="0"/>
-              </a:rPr>
-              <a:t> </a:t>
-            </a:r>
-            <a:r>
-              <a:rPr lang="en-US" b="1" u="sng" dirty="0">
-                <a:latin typeface="Arial" panose="020B0604020202020204" pitchFamily="34" charset="0"/>
-                <a:cs typeface="Arial" panose="020B0604020202020204" pitchFamily="34" charset="0"/>
-              </a:rPr>
-              <a:t>standardized repositories”</a:t>
-            </a:r>
-          </a:p>
-          <a:p>
-            <a:pPr marL="285750" indent="-285750">
-              <a:lnSpc>
-                <a:spcPct val="150000"/>
-              </a:lnSpc>
-              <a:buFont typeface="Arial" panose="020B0604020202020204" pitchFamily="34" charset="0"/>
-              <a:buChar char="•"/>
-            </a:pPr>
-            <a:r>
-              <a:rPr lang="en-US" dirty="0">
-                <a:latin typeface="Arial" panose="020B0604020202020204" pitchFamily="34" charset="0"/>
-                <a:cs typeface="Arial" panose="020B0604020202020204" pitchFamily="34" charset="0"/>
-              </a:rPr>
-              <a:t>is the best way to have 7 small 5x3 tables (one for each key LH trait) with the 3 fields being source, unit, description?</a:t>
-            </a:r>
-          </a:p>
-          <a:p>
-            <a:pPr marL="285750" indent="-285750">
-              <a:lnSpc>
-                <a:spcPct val="150000"/>
-              </a:lnSpc>
-              <a:buFont typeface="Arial" panose="020B0604020202020204" pitchFamily="34" charset="0"/>
-              <a:buChar char="•"/>
-            </a:pPr>
-            <a:r>
-              <a:rPr lang="en-US" dirty="0">
-                <a:latin typeface="Arial" panose="020B0604020202020204" pitchFamily="34" charset="0"/>
-                <a:cs typeface="Arial" panose="020B0604020202020204" pitchFamily="34" charset="0"/>
-              </a:rPr>
-              <a:t>highlight that no database reports  both ASM and AFR</a:t>
             </a:r>
           </a:p>
         </p:txBody>
@@ -4626,7 +4482,7 @@
           <p:nvPr/>
         </p:nvPicPr>
         <p:blipFill>
-          <a:blip r:embed="rId3"/>
+          <a:blip r:embed="rId10"/>
           <a:stretch>
             <a:fillRect/>
           </a:stretch>
@@ -4656,7 +4512,7 @@
           <p:nvPr/>
         </p:nvPicPr>
         <p:blipFill rotWithShape="1">
-          <a:blip r:embed="rId4">
+          <a:blip r:embed="rId11">
             <a:extLst>
               <a:ext uri="{28A0092B-C50C-407E-A947-70E740481C1C}">
                 <a14:useLocalDpi xmlns:a14="http://schemas.microsoft.com/office/drawing/2010/main" val="0"/>
@@ -4703,7 +4559,7 @@
           <p:nvPr/>
         </p:nvPicPr>
         <p:blipFill>
-          <a:blip r:embed="rId5"/>
+          <a:blip r:embed="rId12"/>
           <a:srcRect t="576" r="632" b="531"/>
           <a:stretch>
             <a:fillRect/>
@@ -4712,7 +4568,7 @@
         <p:spPr>
           <a:xfrm>
             <a:off x="13534601" y="5466463"/>
-            <a:ext cx="15324961" cy="12828613"/>
+            <a:ext cx="15292691" cy="12801600"/>
           </a:xfrm>
           <a:prstGeom prst="rect">
             <a:avLst/>
@@ -4738,8 +4594,8 @@
         </p:nvSpPr>
         <p:spPr>
           <a:xfrm>
-            <a:off x="13694799" y="18329217"/>
-            <a:ext cx="15343254" cy="1969193"/>
+            <a:off x="13574534" y="18167545"/>
+            <a:ext cx="15343254" cy="1685846"/>
           </a:xfrm>
           <a:prstGeom prst="rect">
             <a:avLst/>
@@ -4761,27 +4617,27 @@
               </a:lnSpc>
             </a:pPr>
             <a:r>
-              <a:rPr lang="en-US" sz="2800" b="1" dirty="0">
+              <a:rPr lang="en-US" sz="2400" b="1" dirty="0">
                 <a:latin typeface="Arial" panose="020B0604020202020204" pitchFamily="34" charset="0"/>
                 <a:cs typeface="Arial" panose="020B0604020202020204" pitchFamily="34" charset="0"/>
               </a:rPr>
               <a:t>Figure 1. </a:t>
             </a:r>
             <a:r>
-              <a:rPr lang="en-US" sz="2800" dirty="0">
+              <a:rPr lang="en-US" sz="2400" dirty="0">
                 <a:latin typeface="Arial" panose="020B0604020202020204" pitchFamily="34" charset="0"/>
                 <a:cs typeface="Arial" panose="020B0604020202020204" pitchFamily="34" charset="0"/>
               </a:rPr>
               <a:t>Heat map of missing values for key life history traits across all five databases. Low heat (yellow) signifies few missing values while high heat (red) signifies many missing values. Grey indicates that the trait was not recorded in a particular source.</a:t>
             </a:r>
             <a:r>
-              <a:rPr lang="en-US" sz="2800" b="1" dirty="0">
+              <a:rPr lang="en-US" sz="2400" b="1" dirty="0">
                 <a:latin typeface="Arial" panose="020B0604020202020204" pitchFamily="34" charset="0"/>
                 <a:cs typeface="Arial" panose="020B0604020202020204" pitchFamily="34" charset="0"/>
               </a:rPr>
               <a:t> </a:t>
             </a:r>
-            <a:endParaRPr lang="en-US" sz="2800" dirty="0">
+            <a:endParaRPr lang="en-US" sz="2400" dirty="0">
               <a:latin typeface="Arial" panose="020B0604020202020204" pitchFamily="34" charset="0"/>
               <a:cs typeface="Arial" panose="020B0604020202020204" pitchFamily="34" charset="0"/>
             </a:endParaRPr>
@@ -4802,8 +4658,8 @@
         </p:nvSpPr>
         <p:spPr>
           <a:xfrm>
-            <a:off x="29014414" y="25680880"/>
-            <a:ext cx="8977149" cy="12385122"/>
+            <a:off x="15442064" y="26911892"/>
+            <a:ext cx="10382467" cy="10972800"/>
           </a:xfrm>
           <a:prstGeom prst="rect">
             <a:avLst/>
@@ -4829,13 +4685,13 @@
               </a:lnSpc>
             </a:pPr>
             <a:r>
-              <a:rPr lang="en-US" sz="6000" b="1" u="sng" spc="300" dirty="0">
+              <a:rPr lang="en-US" sz="5600" b="1" u="sng" spc="300" dirty="0">
                 <a:latin typeface="Arial" panose="020B0604020202020204" pitchFamily="34" charset="0"/>
                 <a:cs typeface="Arial" panose="020B0604020202020204" pitchFamily="34" charset="0"/>
               </a:rPr>
               <a:t>RESULTS</a:t>
             </a:r>
-            <a:endParaRPr lang="en-US" dirty="0">
+            <a:endParaRPr lang="en-US" sz="5600" dirty="0">
               <a:latin typeface="Arial" panose="020B0604020202020204" pitchFamily="34" charset="0"/>
               <a:cs typeface="Arial" panose="020B0604020202020204" pitchFamily="34" charset="0"/>
             </a:endParaRPr>
@@ -5008,23 +4864,7 @@
                 <a:latin typeface="Arial" panose="020B0604020202020204" pitchFamily="34" charset="0"/>
                 <a:cs typeface="Arial" panose="020B0604020202020204" pitchFamily="34" charset="0"/>
               </a:rPr>
-              <a:t>Metadata content varied from complete and detailed to largely unavailable. </a:t>
-            </a:r>
-          </a:p>
-          <a:p>
-            <a:pPr marL="1143000" lvl="1" indent="-685800">
-              <a:lnSpc>
-                <a:spcPct val="150000"/>
-              </a:lnSpc>
-              <a:buFont typeface="Wingdings" panose="05000000000000000000" pitchFamily="2" charset="2"/>
-              <a:buChar char="v"/>
-            </a:pPr>
-            <a:r>
-              <a:rPr lang="en-US" sz="2800" dirty="0">
-                <a:latin typeface="Arial" panose="020B0604020202020204" pitchFamily="34" charset="0"/>
-                <a:cs typeface="Arial" panose="020B0604020202020204" pitchFamily="34" charset="0"/>
-              </a:rPr>
-              <a:t>For those with available metadata, quality and detail also ranged.</a:t>
+              <a:t>Metadata content varied from complete and detailed to largely unavailable. For those with available metadata, quality and detail also ranged.</a:t>
             </a:r>
           </a:p>
           <a:p>
@@ -5040,19 +4880,8 @@
                 <a:latin typeface="Arial" panose="020B0604020202020204" pitchFamily="34" charset="0"/>
                 <a:cs typeface="Arial" panose="020B0604020202020204" pitchFamily="34" charset="0"/>
               </a:rPr>
-              <a:t>ASM was significantly less dimorphic than adult mass across primates and within species (p &lt; </a:t>
-            </a:r>
-            <a:r>
-              <a:rPr lang="en-US" sz="2800">
-                <a:latin typeface="Arial" panose="020B0604020202020204" pitchFamily="34" charset="0"/>
-                <a:cs typeface="Arial" panose="020B0604020202020204" pitchFamily="34" charset="0"/>
-              </a:rPr>
-              <a:t>.00001 &amp; p &lt; .001).</a:t>
-            </a:r>
-            <a:endParaRPr lang="en-US" sz="2800" dirty="0">
-              <a:latin typeface="Arial" panose="020B0604020202020204" pitchFamily="34" charset="0"/>
-              <a:cs typeface="Arial" panose="020B0604020202020204" pitchFamily="34" charset="0"/>
-            </a:endParaRPr>
+              <a:t>ASM was significantly less dimorphic than adult mass across primates and within species (p &lt; .00001 &amp; p &lt; .001).</a:t>
+            </a:r>
           </a:p>
         </p:txBody>
       </p:sp>
@@ -5070,8 +4899,8 @@
         </p:nvSpPr>
         <p:spPr>
           <a:xfrm>
-            <a:off x="13733432" y="33192353"/>
-            <a:ext cx="14392814" cy="3503523"/>
+            <a:off x="26028186" y="26943346"/>
+            <a:ext cx="11914576" cy="10972800"/>
           </a:xfrm>
           <a:prstGeom prst="rect">
             <a:avLst/>
@@ -5097,7 +4926,7 @@
               </a:lnSpc>
             </a:pPr>
             <a:r>
-              <a:rPr lang="en-US" sz="6000" b="1" u="sng" spc="300" dirty="0">
+              <a:rPr lang="en-US" sz="5600" b="1" u="sng" spc="300" dirty="0">
                 <a:latin typeface="Arial" panose="020B0604020202020204" pitchFamily="34" charset="0"/>
                 <a:cs typeface="Arial" panose="020B0604020202020204" pitchFamily="34" charset="0"/>
               </a:rPr>
@@ -5105,59 +4934,99 @@
             </a:r>
           </a:p>
           <a:p>
-            <a:pPr>
+            <a:pPr marL="457200" indent="-457200">
               <a:lnSpc>
                 <a:spcPct val="150000"/>
               </a:lnSpc>
+              <a:buFont typeface="Wingdings" panose="05000000000000000000" pitchFamily="2" charset="2"/>
+              <a:buChar char="v"/>
             </a:pPr>
             <a:r>
-              <a:rPr lang="en-US" dirty="0">
-                <a:latin typeface="Arial" panose="020B0604020202020204" pitchFamily="34" charset="0"/>
-                <a:cs typeface="Arial" panose="020B0604020202020204" pitchFamily="34" charset="0"/>
-              </a:rPr>
-              <a:t>L</a:t>
-            </a:r>
-          </a:p>
-          <a:p>
-            <a:pPr>
+              <a:rPr lang="en-US" sz="2800" dirty="0">
+                <a:latin typeface="Arial" panose="020B0604020202020204" pitchFamily="34" charset="0"/>
+                <a:cs typeface="Arial" panose="020B0604020202020204" pitchFamily="34" charset="0"/>
+              </a:rPr>
+              <a:t>Many species of primate are understudied, making it difficult to compile a comprehensive LH characteristic dataset.</a:t>
+            </a:r>
+          </a:p>
+          <a:p>
+            <a:pPr marL="457200" indent="-457200">
               <a:lnSpc>
                 <a:spcPct val="150000"/>
               </a:lnSpc>
+              <a:buFont typeface="Wingdings" panose="05000000000000000000" pitchFamily="2" charset="2"/>
+              <a:buChar char="v"/>
             </a:pPr>
             <a:r>
-              <a:rPr lang="en-US" dirty="0">
-                <a:latin typeface="Arial" panose="020B0604020202020204" pitchFamily="34" charset="0"/>
-                <a:cs typeface="Arial" panose="020B0604020202020204" pitchFamily="34" charset="0"/>
-              </a:rPr>
-              <a:t>L</a:t>
-            </a:r>
-          </a:p>
-          <a:p>
-            <a:pPr>
+              <a:rPr lang="en-US" sz="2800" dirty="0">
+                <a:latin typeface="Arial" panose="020B0604020202020204" pitchFamily="34" charset="0"/>
+                <a:cs typeface="Arial" panose="020B0604020202020204" pitchFamily="34" charset="0"/>
+              </a:rPr>
+              <a:t>Existing datasets lack consistency in which traits are recorded, which species are included, and how traits are defined and measured.</a:t>
+            </a:r>
+          </a:p>
+          <a:p>
+            <a:pPr marL="914400" lvl="1" indent="-457200">
               <a:lnSpc>
                 <a:spcPct val="150000"/>
               </a:lnSpc>
+              <a:buFont typeface="Wingdings" panose="05000000000000000000" pitchFamily="2" charset="2"/>
+              <a:buChar char="v"/>
             </a:pPr>
             <a:r>
-              <a:rPr lang="en-US" dirty="0">
-                <a:latin typeface="Arial" panose="020B0604020202020204" pitchFamily="34" charset="0"/>
-                <a:cs typeface="Arial" panose="020B0604020202020204" pitchFamily="34" charset="0"/>
-              </a:rPr>
-              <a:t>L</a:t>
-            </a:r>
-          </a:p>
-          <a:p>
-            <a:pPr>
+              <a:rPr lang="en-US" sz="2800" dirty="0">
+                <a:latin typeface="Arial" panose="020B0604020202020204" pitchFamily="34" charset="0"/>
+                <a:cs typeface="Arial" panose="020B0604020202020204" pitchFamily="34" charset="0"/>
+              </a:rPr>
+              <a:t>Ex: [2], [7], and [8] report AFR while [3,4] and [9] report ASM. Of the 117 species with data for both, AFR is younger than ASM for 82%. </a:t>
+            </a:r>
+          </a:p>
+          <a:p>
+            <a:pPr marL="914400" lvl="1" indent="-457200">
               <a:lnSpc>
                 <a:spcPct val="150000"/>
               </a:lnSpc>
+              <a:buFont typeface="Wingdings" panose="05000000000000000000" pitchFamily="2" charset="2"/>
+              <a:buChar char="v"/>
             </a:pPr>
             <a:r>
-              <a:rPr lang="en-US" dirty="0">
+              <a:rPr lang="en-US" sz="2800" dirty="0">
                 <a:latin typeface="Arial" panose="020B0604020202020204" pitchFamily="34" charset="0"/>
                 <a:cs typeface="Arial" panose="020B0604020202020204" pitchFamily="34" charset="0"/>
               </a:rPr>
               <a:t>Ex: IBI descriptions for Amniotes &amp; PanTHERIA specify live offspring, while KP doesn’t specify; AnAge lacks any description of IBI, and Ernest does not record data for IBI.</a:t>
+            </a:r>
+          </a:p>
+          <a:p>
+            <a:pPr marL="457200" indent="-457200">
+              <a:lnSpc>
+                <a:spcPct val="150000"/>
+              </a:lnSpc>
+              <a:buFont typeface="Wingdings" panose="05000000000000000000" pitchFamily="2" charset="2"/>
+              <a:buChar char="v"/>
+            </a:pPr>
+            <a:r>
+              <a:rPr lang="en-US" sz="2800" dirty="0">
+                <a:latin typeface="Arial" panose="020B0604020202020204" pitchFamily="34" charset="0"/>
+                <a:cs typeface="Arial" panose="020B0604020202020204" pitchFamily="34" charset="0"/>
+              </a:rPr>
+              <a:t>Despite dramatic differences in the number of species recorded, all datasets maintain relatively equal proportions of cladistic representation.</a:t>
+            </a:r>
+          </a:p>
+          <a:p>
+            <a:pPr marL="457200" indent="-457200">
+              <a:lnSpc>
+                <a:spcPct val="150000"/>
+              </a:lnSpc>
+              <a:buFont typeface="Wingdings" panose="05000000000000000000" pitchFamily="2" charset="2"/>
+              <a:buChar char="v"/>
+            </a:pPr>
+            <a:r>
+              <a:rPr lang="en-US" sz="2800" dirty="0">
+                <a:latin typeface="Arial" panose="020B0604020202020204" pitchFamily="34" charset="0"/>
+                <a:cs typeface="Arial" panose="020B0604020202020204" pitchFamily="34" charset="0"/>
+              </a:rPr>
+              <a:t>Going forward, anthropologists must come together to establish LH data collection protocols and a standardized repository filled with reliable and accurate data. </a:t>
             </a:r>
           </a:p>
         </p:txBody>
@@ -5176,8 +5045,8 @@
         </p:nvSpPr>
         <p:spPr>
           <a:xfrm>
-            <a:off x="299864" y="26541434"/>
-            <a:ext cx="3931921" cy="593047"/>
+            <a:off x="299864" y="30953964"/>
+            <a:ext cx="3931921" cy="7185365"/>
           </a:xfrm>
           <a:prstGeom prst="rect">
             <a:avLst/>
@@ -5207,13 +5076,63 @@
               </a:rPr>
               <a:t>ACKNOWLEDGEMENTS</a:t>
             </a:r>
-            <a:endParaRPr lang="en-US" dirty="0">
-              <a:latin typeface="Arial" panose="020B0604020202020204" pitchFamily="34" charset="0"/>
-              <a:cs typeface="Arial" panose="020B0604020202020204" pitchFamily="34" charset="0"/>
-            </a:endParaRPr>
-          </a:p>
-        </p:txBody>
-      </p:sp>
+          </a:p>
+          <a:p>
+            <a:pPr>
+              <a:lnSpc>
+                <a:spcPct val="150000"/>
+              </a:lnSpc>
+            </a:pPr>
+            <a:r>
+              <a:rPr lang="en-US" sz="2200" dirty="0">
+                <a:latin typeface="Arial" panose="020B0604020202020204" pitchFamily="34" charset="0"/>
+                <a:cs typeface="Arial" panose="020B0604020202020204" pitchFamily="34" charset="0"/>
+              </a:rPr>
+              <a:t>Special thanks to Dr. Finkel and Dr. Hodges-Simeon for their continued support and to Nicole Merullo for her commitment and mentorship. We are grateful to Boston University and Dartmouth College, the American Association of Biological Anthropologists (AABA), and the AABA Committee of Diversity for facilitating scientific inquiry. </a:t>
+            </a:r>
+          </a:p>
+        </p:txBody>
+      </p:sp>
+      <p:pic>
+        <p:nvPicPr>
+          <p:cNvPr id="11" name="Picture 10">
+            <a:extLst>
+              <a:ext uri="{FF2B5EF4-FFF2-40B4-BE49-F238E27FC236}">
+                <a16:creationId xmlns:a16="http://schemas.microsoft.com/office/drawing/2014/main" id="{3422488E-57F3-7910-F955-AE55A30FD5E9}"/>
+              </a:ext>
+            </a:extLst>
+          </p:cNvPr>
+          <p:cNvPicPr>
+            <a:picLocks noChangeAspect="1"/>
+          </p:cNvPicPr>
+          <p:nvPr/>
+        </p:nvPicPr>
+        <p:blipFill>
+          <a:blip r:embed="rId13">
+            <a:extLst>
+              <a:ext uri="{28A0092B-C50C-407E-A947-70E740481C1C}">
+                <a14:useLocalDpi xmlns:a14="http://schemas.microsoft.com/office/drawing/2010/main" val="0"/>
+              </a:ext>
+            </a:extLst>
+          </a:blip>
+          <a:srcRect/>
+          <a:stretch/>
+        </p:blipFill>
+        <p:spPr>
+          <a:xfrm>
+            <a:off x="4853236" y="30676005"/>
+            <a:ext cx="10119365" cy="6969521"/>
+          </a:xfrm>
+          <a:prstGeom prst="rect">
+            <a:avLst/>
+          </a:prstGeom>
+          <a:ln w="38100">
+            <a:solidFill>
+              <a:schemeClr val="tx1"/>
+            </a:solidFill>
+          </a:ln>
+        </p:spPr>
+      </p:pic>
       <p:graphicFrame>
         <p:nvGraphicFramePr>
           <p:cNvPr id="6" name="Table 5">
@@ -5229,14 +5148,14 @@
           <p:nvPr>
             <p:extLst>
               <p:ext uri="{D42A27DB-BD31-4B8C-83A1-F6EECF244321}">
-                <p14:modId xmlns:p14="http://schemas.microsoft.com/office/powerpoint/2010/main" val="2889211633"/>
+                <p14:modId xmlns:p14="http://schemas.microsoft.com/office/powerpoint/2010/main" val="3583799410"/>
               </p:ext>
             </p:extLst>
           </p:nvPr>
         </p:nvGraphicFramePr>
         <p:xfrm>
-          <a:off x="13667857" y="22161523"/>
-          <a:ext cx="15102725" cy="4138398"/>
+          <a:off x="13833349" y="21665104"/>
+          <a:ext cx="14843910" cy="3718560"/>
         </p:xfrm>
         <a:graphic>
           <a:graphicData uri="http://schemas.openxmlformats.org/drawingml/2006/table">
@@ -5245,56 +5164,49 @@
                 <a:tableStyleId>{5C22544A-7EE6-4342-B048-85BDC9FD1C3A}</a:tableStyleId>
               </a:tblPr>
               <a:tblGrid>
-                <a:gridCol w="2197387">
+                <a:gridCol w="2420766">
                   <a:extLst>
                     <a:ext uri="{9D8B030D-6E8A-4147-A177-3AD203B41FA5}">
                       <a16:colId xmlns:a16="http://schemas.microsoft.com/office/drawing/2014/main" val="2495585869"/>
                     </a:ext>
                   </a:extLst>
                 </a:gridCol>
-                <a:gridCol w="1851702">
-                  <a:extLst>
-                    <a:ext uri="{9D8B030D-6E8A-4147-A177-3AD203B41FA5}">
-                      <a16:colId xmlns:a16="http://schemas.microsoft.com/office/drawing/2014/main" val="3601265924"/>
-                    </a:ext>
-                  </a:extLst>
-                </a:gridCol>
-                <a:gridCol w="1562373">
+                <a:gridCol w="1574765">
                   <a:extLst>
                     <a:ext uri="{9D8B030D-6E8A-4147-A177-3AD203B41FA5}">
                       <a16:colId xmlns:a16="http://schemas.microsoft.com/office/drawing/2014/main" val="984202891"/>
                     </a:ext>
                   </a:extLst>
                 </a:gridCol>
-                <a:gridCol w="2112098">
+                <a:gridCol w="2318404">
                   <a:extLst>
                     <a:ext uri="{9D8B030D-6E8A-4147-A177-3AD203B41FA5}">
                       <a16:colId xmlns:a16="http://schemas.microsoft.com/office/drawing/2014/main" val="1450671555"/>
                     </a:ext>
                   </a:extLst>
                 </a:gridCol>
-                <a:gridCol w="2112098">
+                <a:gridCol w="1911689">
                   <a:extLst>
                     <a:ext uri="{9D8B030D-6E8A-4147-A177-3AD203B41FA5}">
                       <a16:colId xmlns:a16="http://schemas.microsoft.com/office/drawing/2014/main" val="2092606652"/>
                     </a:ext>
                   </a:extLst>
                 </a:gridCol>
-                <a:gridCol w="1070515">
+                <a:gridCol w="2000595">
                   <a:extLst>
                     <a:ext uri="{9D8B030D-6E8A-4147-A177-3AD203B41FA5}">
                       <a16:colId xmlns:a16="http://schemas.microsoft.com/office/drawing/2014/main" val="3671337353"/>
                     </a:ext>
                   </a:extLst>
                 </a:gridCol>
-                <a:gridCol w="2155470">
+                <a:gridCol w="2327266">
                   <a:extLst>
                     <a:ext uri="{9D8B030D-6E8A-4147-A177-3AD203B41FA5}">
                       <a16:colId xmlns:a16="http://schemas.microsoft.com/office/drawing/2014/main" val="1165741138"/>
                     </a:ext>
                   </a:extLst>
                 </a:gridCol>
-                <a:gridCol w="2041082">
+                <a:gridCol w="2290425">
                   <a:extLst>
                     <a:ext uri="{9D8B030D-6E8A-4147-A177-3AD203B41FA5}">
                       <a16:colId xmlns:a16="http://schemas.microsoft.com/office/drawing/2014/main" val="3607082557"/>
@@ -5302,14 +5214,14 @@
                   </a:extLst>
                 </a:gridCol>
               </a:tblGrid>
-              <a:tr h="826167">
+              <a:tr h="578529">
                 <a:tc>
                   <a:txBody>
                     <a:bodyPr/>
                     <a:lstStyle/>
                     <a:p>
                       <a:r>
-                        <a:rPr lang="en-US" sz="2600" b="1" dirty="0">
+                        <a:rPr lang="en-US" sz="2600" b="0" dirty="0">
                           <a:latin typeface="Arial" panose="020B0604020202020204" pitchFamily="34" charset="0"/>
                           <a:cs typeface="Arial" panose="020B0604020202020204" pitchFamily="34" charset="0"/>
                         </a:rPr>
@@ -5325,23 +5237,7 @@
                     <a:lstStyle/>
                     <a:p>
                       <a:r>
-                        <a:rPr lang="en-US" sz="2600" dirty="0">
-                          <a:latin typeface="Arial" panose="020B0604020202020204" pitchFamily="34" charset="0"/>
-                          <a:cs typeface="Arial" panose="020B0604020202020204" pitchFamily="34" charset="0"/>
-                        </a:rPr>
-                        <a:t>Actively Updated?</a:t>
-                      </a:r>
-                    </a:p>
-                  </a:txBody>
-                  <a:tcPr/>
-                </a:tc>
-                <a:tc>
-                  <a:txBody>
-                    <a:bodyPr/>
-                    <a:lstStyle/>
-                    <a:p>
-                      <a:r>
-                        <a:rPr lang="en-US" sz="2600" dirty="0">
+                        <a:rPr lang="en-US" sz="2600" b="0" dirty="0">
                           <a:latin typeface="Arial" panose="020B0604020202020204" pitchFamily="34" charset="0"/>
                           <a:cs typeface="Arial" panose="020B0604020202020204" pitchFamily="34" charset="0"/>
                         </a:rPr>
@@ -5357,7 +5253,7 @@
                     <a:lstStyle/>
                     <a:p>
                       <a:r>
-                        <a:rPr lang="en-US" sz="2600" dirty="0">
+                        <a:rPr lang="en-US" sz="2600" b="0" dirty="0">
                           <a:latin typeface="Arial" panose="020B0604020202020204" pitchFamily="34" charset="0"/>
                           <a:cs typeface="Arial" panose="020B0604020202020204" pitchFamily="34" charset="0"/>
                         </a:rPr>
@@ -5373,11 +5269,11 @@
                     <a:lstStyle/>
                     <a:p>
                       <a:r>
-                        <a:rPr lang="en-US" sz="2600" dirty="0">
+                        <a:rPr lang="en-US" sz="2600" b="0" dirty="0">
                           <a:latin typeface="Arial" panose="020B0604020202020204" pitchFamily="34" charset="0"/>
                           <a:cs typeface="Arial" panose="020B0604020202020204" pitchFamily="34" charset="0"/>
                         </a:rPr>
-                        <a:t>Metadata Score (x/8)</a:t>
+                        <a:t>Meta-data Score (x/8)</a:t>
                       </a:r>
                     </a:p>
                   </a:txBody>
@@ -5389,11 +5285,11 @@
                     <a:lstStyle/>
                     <a:p>
                       <a:r>
-                        <a:rPr lang="en-US" sz="2600" dirty="0">
+                        <a:rPr lang="en-US" sz="2600" b="0" dirty="0">
                           <a:latin typeface="Arial" panose="020B0604020202020204" pitchFamily="34" charset="0"/>
                           <a:cs typeface="Arial" panose="020B0604020202020204" pitchFamily="34" charset="0"/>
                         </a:rPr>
-                        <a:t>N LH stats</a:t>
+                        <a:t>N LH vars</a:t>
                       </a:r>
                     </a:p>
                   </a:txBody>
@@ -5405,7 +5301,7 @@
                     <a:lstStyle/>
                     <a:p>
                       <a:r>
-                        <a:rPr lang="en-US" sz="2600" dirty="0">
+                        <a:rPr lang="en-US" sz="2600" b="0" dirty="0">
                           <a:latin typeface="Arial" panose="020B0604020202020204" pitchFamily="34" charset="0"/>
                           <a:cs typeface="Arial" panose="020B0604020202020204" pitchFamily="34" charset="0"/>
                         </a:rPr>
@@ -5421,7 +5317,7 @@
                     <a:lstStyle/>
                     <a:p>
                       <a:r>
-                        <a:rPr lang="en-US" sz="2600" dirty="0">
+                        <a:rPr lang="en-US" sz="2600" b="0" dirty="0">
                           <a:latin typeface="Arial" panose="020B0604020202020204" pitchFamily="34" charset="0"/>
                           <a:cs typeface="Arial" panose="020B0604020202020204" pitchFamily="34" charset="0"/>
                         </a:rPr>
@@ -5437,7 +5333,7 @@
                   </a:ext>
                 </a:extLst>
               </a:tr>
-              <a:tr h="559910">
+              <a:tr h="366463">
                 <a:tc>
                   <a:txBody>
                     <a:bodyPr/>
@@ -5449,22 +5345,6 @@
                           <a:cs typeface="Arial" panose="020B0604020202020204" pitchFamily="34" charset="0"/>
                         </a:rPr>
                         <a:t>Amniotes</a:t>
-                      </a:r>
-                    </a:p>
-                  </a:txBody>
-                  <a:tcPr/>
-                </a:tc>
-                <a:tc>
-                  <a:txBody>
-                    <a:bodyPr/>
-                    <a:lstStyle/>
-                    <a:p>
-                      <a:r>
-                        <a:rPr lang="en-US" sz="2600" dirty="0">
-                          <a:latin typeface="Arial" panose="020B0604020202020204" pitchFamily="34" charset="0"/>
-                          <a:cs typeface="Arial" panose="020B0604020202020204" pitchFamily="34" charset="0"/>
-                        </a:rPr>
-                        <a:t>No</a:t>
                       </a:r>
                     </a:p>
                   </a:txBody>
@@ -5572,7 +5452,7 @@
                   </a:ext>
                 </a:extLst>
               </a:tr>
-              <a:tr h="559910">
+              <a:tr h="366463">
                 <a:tc>
                   <a:txBody>
                     <a:bodyPr/>
@@ -5584,22 +5464,6 @@
                           <a:cs typeface="Arial" panose="020B0604020202020204" pitchFamily="34" charset="0"/>
                         </a:rPr>
                         <a:t>AnAge</a:t>
-                      </a:r>
-                    </a:p>
-                  </a:txBody>
-                  <a:tcPr/>
-                </a:tc>
-                <a:tc>
-                  <a:txBody>
-                    <a:bodyPr/>
-                    <a:lstStyle/>
-                    <a:p>
-                      <a:r>
-                        <a:rPr lang="en-US" sz="2600" dirty="0">
-                          <a:latin typeface="Arial" panose="020B0604020202020204" pitchFamily="34" charset="0"/>
-                          <a:cs typeface="Arial" panose="020B0604020202020204" pitchFamily="34" charset="0"/>
-                        </a:rPr>
-                        <a:t>Yes</a:t>
                       </a:r>
                     </a:p>
                   </a:txBody>
@@ -5707,7 +5571,7 @@
                   </a:ext>
                 </a:extLst>
               </a:tr>
-              <a:tr h="559910">
+              <a:tr h="366463">
                 <a:tc>
                   <a:txBody>
                     <a:bodyPr/>
@@ -5719,22 +5583,6 @@
                           <a:cs typeface="Arial" panose="020B0604020202020204" pitchFamily="34" charset="0"/>
                         </a:rPr>
                         <a:t>Ernest</a:t>
-                      </a:r>
-                    </a:p>
-                  </a:txBody>
-                  <a:tcPr/>
-                </a:tc>
-                <a:tc>
-                  <a:txBody>
-                    <a:bodyPr/>
-                    <a:lstStyle/>
-                    <a:p>
-                      <a:r>
-                        <a:rPr lang="en-US" sz="2600" dirty="0">
-                          <a:latin typeface="Arial" panose="020B0604020202020204" pitchFamily="34" charset="0"/>
-                          <a:cs typeface="Arial" panose="020B0604020202020204" pitchFamily="34" charset="0"/>
-                        </a:rPr>
-                        <a:t>No</a:t>
                       </a:r>
                     </a:p>
                   </a:txBody>
@@ -5842,7 +5690,7 @@
                   </a:ext>
                 </a:extLst>
               </a:tr>
-              <a:tr h="1014838">
+              <a:tr h="664215">
                 <a:tc>
                   <a:txBody>
                     <a:bodyPr/>
@@ -5854,22 +5702,6 @@
                           <a:cs typeface="Arial" panose="020B0604020202020204" pitchFamily="34" charset="0"/>
                         </a:rPr>
                         <a:t>Kappeler &amp; Pereira</a:t>
-                      </a:r>
-                    </a:p>
-                  </a:txBody>
-                  <a:tcPr/>
-                </a:tc>
-                <a:tc>
-                  <a:txBody>
-                    <a:bodyPr/>
-                    <a:lstStyle/>
-                    <a:p>
-                      <a:r>
-                        <a:rPr lang="en-US" sz="2600" dirty="0">
-                          <a:latin typeface="Arial" panose="020B0604020202020204" pitchFamily="34" charset="0"/>
-                          <a:cs typeface="Arial" panose="020B0604020202020204" pitchFamily="34" charset="0"/>
-                        </a:rPr>
-                        <a:t>No</a:t>
                       </a:r>
                     </a:p>
                   </a:txBody>
@@ -5977,7 +5809,7 @@
                   </a:ext>
                 </a:extLst>
               </a:tr>
-              <a:tr h="559910">
+              <a:tr h="366463">
                 <a:tc>
                   <a:txBody>
                     <a:bodyPr/>
@@ -5989,22 +5821,6 @@
                           <a:cs typeface="Arial" panose="020B0604020202020204" pitchFamily="34" charset="0"/>
                         </a:rPr>
                         <a:t>PanTHERIA</a:t>
-                      </a:r>
-                    </a:p>
-                  </a:txBody>
-                  <a:tcPr/>
-                </a:tc>
-                <a:tc>
-                  <a:txBody>
-                    <a:bodyPr/>
-                    <a:lstStyle/>
-                    <a:p>
-                      <a:r>
-                        <a:rPr lang="en-US" sz="2600" dirty="0">
-                          <a:latin typeface="Arial" panose="020B0604020202020204" pitchFamily="34" charset="0"/>
-                          <a:cs typeface="Arial" panose="020B0604020202020204" pitchFamily="34" charset="0"/>
-                        </a:rPr>
-                        <a:t>No</a:t>
                       </a:r>
                     </a:p>
                   </a:txBody>
@@ -6116,46 +5932,6 @@
           </a:graphicData>
         </a:graphic>
       </p:graphicFrame>
-      <p:pic>
-        <p:nvPicPr>
-          <p:cNvPr id="11" name="Picture 10">
-            <a:extLst>
-              <a:ext uri="{FF2B5EF4-FFF2-40B4-BE49-F238E27FC236}">
-                <a16:creationId xmlns:a16="http://schemas.microsoft.com/office/drawing/2014/main" id="{3422488E-57F3-7910-F955-AE55A30FD5E9}"/>
-              </a:ext>
-            </a:extLst>
-          </p:cNvPr>
-          <p:cNvPicPr>
-            <a:picLocks noChangeAspect="1"/>
-          </p:cNvPicPr>
-          <p:nvPr/>
-        </p:nvPicPr>
-        <p:blipFill>
-          <a:blip r:embed="rId6">
-            <a:extLst>
-              <a:ext uri="{28A0092B-C50C-407E-A947-70E740481C1C}">
-                <a14:useLocalDpi xmlns:a14="http://schemas.microsoft.com/office/drawing/2010/main" val="0"/>
-              </a:ext>
-            </a:extLst>
-          </a:blip>
-          <a:srcRect/>
-          <a:stretch/>
-        </p:blipFill>
-        <p:spPr>
-          <a:xfrm>
-            <a:off x="4892222" y="30218561"/>
-            <a:ext cx="8488295" cy="6187438"/>
-          </a:xfrm>
-          <a:prstGeom prst="rect">
-            <a:avLst/>
-          </a:prstGeom>
-          <a:ln w="38100">
-            <a:solidFill>
-              <a:schemeClr val="tx1"/>
-            </a:solidFill>
-          </a:ln>
-        </p:spPr>
-      </p:pic>
       <p:sp>
         <p:nvSpPr>
           <p:cNvPr id="15" name="TextBox 14">
@@ -6170,8 +5946,8 @@
         </p:nvSpPr>
         <p:spPr>
           <a:xfrm>
-            <a:off x="13694799" y="20225437"/>
-            <a:ext cx="15102725" cy="1965282"/>
+            <a:off x="13833349" y="19901007"/>
+            <a:ext cx="14843910" cy="1697644"/>
           </a:xfrm>
           <a:prstGeom prst="rect">
             <a:avLst/>
@@ -6190,20 +5966,20 @@
               </a:lnSpc>
             </a:pPr>
             <a:r>
-              <a:rPr lang="en-US" sz="2800" b="1" dirty="0">
+              <a:rPr lang="en-US" sz="2400" b="1" dirty="0">
                 <a:latin typeface="Arial" panose="020B0604020202020204" pitchFamily="34" charset="0"/>
                 <a:cs typeface="Arial" panose="020B0604020202020204" pitchFamily="34" charset="0"/>
               </a:rPr>
               <a:t>Table 1. </a:t>
             </a:r>
             <a:r>
-              <a:rPr lang="en-US" sz="2800" dirty="0">
+              <a:rPr lang="en-US" sz="2400" dirty="0">
                 <a:latin typeface="Arial" panose="020B0604020202020204" pitchFamily="34" charset="0"/>
                 <a:cs typeface="Arial" panose="020B0604020202020204" pitchFamily="34" charset="0"/>
               </a:rPr>
               <a:t>Descriptive statistics of primate life-history statistics for each database. AnAge is the only database that is continually updated, with its last update in 2023. Each database has fewer missing values for our selected key life-history traits compared to all recorded statistics.</a:t>
             </a:r>
-            <a:endParaRPr lang="en-US" sz="2800" dirty="0"/>
+            <a:endParaRPr lang="en-US" sz="2400" dirty="0"/>
           </a:p>
         </p:txBody>
       </p:sp>
@@ -6221,8 +5997,8 @@
         </p:nvSpPr>
         <p:spPr>
           <a:xfrm>
-            <a:off x="4892222" y="36405999"/>
-            <a:ext cx="8488295" cy="1305165"/>
+            <a:off x="4736689" y="37561479"/>
+            <a:ext cx="10986532" cy="577850"/>
           </a:xfrm>
           <a:prstGeom prst="rect">
             <a:avLst/>
@@ -6241,20 +6017,369 @@
               </a:lnSpc>
             </a:pPr>
             <a:r>
-              <a:rPr lang="en-US" sz="2800" b="1" dirty="0">
+              <a:rPr lang="en-US" sz="2400" b="1" dirty="0">
                 <a:latin typeface="Arial" panose="020B0604020202020204" pitchFamily="34" charset="0"/>
                 <a:cs typeface="Arial" panose="020B0604020202020204" pitchFamily="34" charset="0"/>
               </a:rPr>
               <a:t>Figure 2. </a:t>
             </a:r>
             <a:r>
-              <a:rPr lang="en-US" sz="2800" dirty="0">
+              <a:rPr lang="en-US" sz="2400" dirty="0">
                 <a:latin typeface="Arial" panose="020B0604020202020204" pitchFamily="34" charset="0"/>
                 <a:cs typeface="Arial" panose="020B0604020202020204" pitchFamily="34" charset="0"/>
               </a:rPr>
               <a:t>Relative proportions of different primate clades for each database. </a:t>
             </a:r>
-            <a:endParaRPr lang="en-US" sz="2800" b="1" dirty="0">
+            <a:endParaRPr lang="en-US" sz="2400" b="1" dirty="0">
+              <a:latin typeface="Arial" panose="020B0604020202020204" pitchFamily="34" charset="0"/>
+              <a:cs typeface="Arial" panose="020B0604020202020204" pitchFamily="34" charset="0"/>
+            </a:endParaRPr>
+          </a:p>
+        </p:txBody>
+      </p:sp>
+      <p:graphicFrame>
+        <p:nvGraphicFramePr>
+          <p:cNvPr id="18" name="Table 17">
+            <a:extLst>
+              <a:ext uri="{FF2B5EF4-FFF2-40B4-BE49-F238E27FC236}">
+                <a16:creationId xmlns:a16="http://schemas.microsoft.com/office/drawing/2014/main" id="{89EB3D43-2416-755D-0631-818DB781FAA2}"/>
+              </a:ext>
+            </a:extLst>
+          </p:cNvPr>
+          <p:cNvGraphicFramePr>
+            <a:graphicFrameLocks noGrp="1"/>
+          </p:cNvGraphicFramePr>
+          <p:nvPr>
+            <p:extLst>
+              <p:ext uri="{D42A27DB-BD31-4B8C-83A1-F6EECF244321}">
+                <p14:modId xmlns:p14="http://schemas.microsoft.com/office/powerpoint/2010/main" val="1443579096"/>
+              </p:ext>
+            </p:extLst>
+          </p:nvPr>
+        </p:nvGraphicFramePr>
+        <p:xfrm>
+          <a:off x="4736689" y="25759939"/>
+          <a:ext cx="10352460" cy="4724400"/>
+        </p:xfrm>
+        <a:graphic>
+          <a:graphicData uri="http://schemas.openxmlformats.org/drawingml/2006/table">
+            <a:tbl>
+              <a:tblPr firstRow="1" bandRow="1">
+                <a:tableStyleId>{5C22544A-7EE6-4342-B048-85BDC9FD1C3A}</a:tableStyleId>
+              </a:tblPr>
+              <a:tblGrid>
+                <a:gridCol w="1799885">
+                  <a:extLst>
+                    <a:ext uri="{9D8B030D-6E8A-4147-A177-3AD203B41FA5}">
+                      <a16:colId xmlns:a16="http://schemas.microsoft.com/office/drawing/2014/main" val="2953196259"/>
+                    </a:ext>
+                  </a:extLst>
+                </a:gridCol>
+                <a:gridCol w="1212330">
+                  <a:extLst>
+                    <a:ext uri="{9D8B030D-6E8A-4147-A177-3AD203B41FA5}">
+                      <a16:colId xmlns:a16="http://schemas.microsoft.com/office/drawing/2014/main" val="2850544499"/>
+                    </a:ext>
+                  </a:extLst>
+                </a:gridCol>
+                <a:gridCol w="3176461">
+                  <a:extLst>
+                    <a:ext uri="{9D8B030D-6E8A-4147-A177-3AD203B41FA5}">
+                      <a16:colId xmlns:a16="http://schemas.microsoft.com/office/drawing/2014/main" val="3719952992"/>
+                    </a:ext>
+                  </a:extLst>
+                </a:gridCol>
+                <a:gridCol w="4163784">
+                  <a:extLst>
+                    <a:ext uri="{9D8B030D-6E8A-4147-A177-3AD203B41FA5}">
+                      <a16:colId xmlns:a16="http://schemas.microsoft.com/office/drawing/2014/main" val="569871792"/>
+                    </a:ext>
+                  </a:extLst>
+                </a:gridCol>
+              </a:tblGrid>
+              <a:tr h="572218">
+                <a:tc>
+                  <a:txBody>
+                    <a:bodyPr/>
+                    <a:lstStyle/>
+                    <a:p>
+                      <a:r>
+                        <a:rPr lang="en-US" sz="2600" b="0" dirty="0"/>
+                        <a:t>Variable</a:t>
+                      </a:r>
+                    </a:p>
+                  </a:txBody>
+                  <a:tcPr/>
+                </a:tc>
+                <a:tc>
+                  <a:txBody>
+                    <a:bodyPr/>
+                    <a:lstStyle/>
+                    <a:p>
+                      <a:r>
+                        <a:rPr lang="en-US" sz="2600" b="0" dirty="0"/>
+                        <a:t>N unit types</a:t>
+                      </a:r>
+                    </a:p>
+                  </a:txBody>
+                  <a:tcPr/>
+                </a:tc>
+                <a:tc>
+                  <a:txBody>
+                    <a:bodyPr/>
+                    <a:lstStyle/>
+                    <a:p>
+                      <a:r>
+                        <a:rPr lang="en-US" sz="2600" b="0" dirty="0"/>
+                        <a:t>Description</a:t>
+                      </a:r>
+                    </a:p>
+                  </a:txBody>
+                  <a:tcPr/>
+                </a:tc>
+                <a:tc>
+                  <a:txBody>
+                    <a:bodyPr/>
+                    <a:lstStyle/>
+                    <a:p>
+                      <a:r>
+                        <a:rPr lang="en-US" sz="2600" b="0" dirty="0"/>
+                        <a:t>Database Comparison</a:t>
+                      </a:r>
+                    </a:p>
+                  </a:txBody>
+                  <a:tcPr/>
+                </a:tc>
+                <a:extLst>
+                  <a:ext uri="{0D108BD9-81ED-4DB2-BD59-A6C34878D82A}">
+                    <a16:rowId xmlns:a16="http://schemas.microsoft.com/office/drawing/2014/main" val="120293628"/>
+                  </a:ext>
+                </a:extLst>
+              </a:tr>
+              <a:tr h="828730">
+                <a:tc>
+                  <a:txBody>
+                    <a:bodyPr/>
+                    <a:lstStyle/>
+                    <a:p>
+                      <a:r>
+                        <a:rPr lang="en-US" sz="2600" b="0" dirty="0"/>
+                        <a:t>Weaning Age</a:t>
+                      </a:r>
+                    </a:p>
+                  </a:txBody>
+                  <a:tcPr/>
+                </a:tc>
+                <a:tc>
+                  <a:txBody>
+                    <a:bodyPr/>
+                    <a:lstStyle/>
+                    <a:p>
+                      <a:r>
+                        <a:rPr lang="en-US" sz="2600" b="0" dirty="0"/>
+                        <a:t>2</a:t>
+                      </a:r>
+                    </a:p>
+                  </a:txBody>
+                  <a:tcPr/>
+                </a:tc>
+                <a:tc>
+                  <a:txBody>
+                    <a:bodyPr/>
+                    <a:lstStyle/>
+                    <a:p>
+                      <a:r>
+                        <a:rPr lang="en-US" sz="2600" b="0" dirty="0"/>
+                        <a:t>Mean duration from birth to solid food transition</a:t>
+                      </a:r>
+                    </a:p>
+                  </a:txBody>
+                  <a:tcPr/>
+                </a:tc>
+                <a:tc>
+                  <a:txBody>
+                    <a:bodyPr/>
+                    <a:lstStyle/>
+                    <a:p>
+                      <a:r>
+                        <a:rPr lang="en-US" sz="2600" b="0" dirty="0"/>
+                        <a:t>[2] defines as eating solid food, [7] as first solid food OR last nursing</a:t>
+                      </a:r>
+                    </a:p>
+                  </a:txBody>
+                  <a:tcPr/>
+                </a:tc>
+                <a:extLst>
+                  <a:ext uri="{0D108BD9-81ED-4DB2-BD59-A6C34878D82A}">
+                    <a16:rowId xmlns:a16="http://schemas.microsoft.com/office/drawing/2014/main" val="1699839922"/>
+                  </a:ext>
+                </a:extLst>
+              </a:tr>
+              <a:tr h="828730">
+                <a:tc>
+                  <a:txBody>
+                    <a:bodyPr/>
+                    <a:lstStyle/>
+                    <a:p>
+                      <a:r>
+                        <a:rPr lang="en-US" sz="2600" b="0" dirty="0"/>
+                        <a:t>IBI</a:t>
+                      </a:r>
+                    </a:p>
+                  </a:txBody>
+                  <a:tcPr/>
+                </a:tc>
+                <a:tc>
+                  <a:txBody>
+                    <a:bodyPr/>
+                    <a:lstStyle/>
+                    <a:p>
+                      <a:r>
+                        <a:rPr lang="en-US" sz="2600" b="0" dirty="0"/>
+                        <a:t>4</a:t>
+                      </a:r>
+                    </a:p>
+                  </a:txBody>
+                  <a:tcPr/>
+                </a:tc>
+                <a:tc>
+                  <a:txBody>
+                    <a:bodyPr/>
+                    <a:lstStyle/>
+                    <a:p>
+                      <a:r>
+                        <a:rPr lang="en-US" sz="2600" b="0" dirty="0"/>
+                        <a:t>Mean duration between successive births</a:t>
+                      </a:r>
+                    </a:p>
+                  </a:txBody>
+                  <a:tcPr/>
+                </a:tc>
+                <a:tc>
+                  <a:txBody>
+                    <a:bodyPr/>
+                    <a:lstStyle/>
+                    <a:p>
+                      <a:r>
+                        <a:rPr lang="en-US" sz="2600" b="0" dirty="0"/>
+                        <a:t>[2] records litters/year, [7] specifies between successful births</a:t>
+                      </a:r>
+                    </a:p>
+                  </a:txBody>
+                  <a:tcPr/>
+                </a:tc>
+                <a:extLst>
+                  <a:ext uri="{0D108BD9-81ED-4DB2-BD59-A6C34878D82A}">
+                    <a16:rowId xmlns:a16="http://schemas.microsoft.com/office/drawing/2014/main" val="1346406341"/>
+                  </a:ext>
+                </a:extLst>
+              </a:tr>
+              <a:tr h="828730">
+                <a:tc>
+                  <a:txBody>
+                    <a:bodyPr/>
+                    <a:lstStyle/>
+                    <a:p>
+                      <a:r>
+                        <a:rPr lang="en-US" sz="2600" b="0" dirty="0"/>
+                        <a:t>Gestation Length</a:t>
+                      </a:r>
+                    </a:p>
+                  </a:txBody>
+                  <a:tcPr/>
+                </a:tc>
+                <a:tc>
+                  <a:txBody>
+                    <a:bodyPr/>
+                    <a:lstStyle/>
+                    <a:p>
+                      <a:r>
+                        <a:rPr lang="en-US" sz="2600" b="0" dirty="0"/>
+                        <a:t>2</a:t>
+                      </a:r>
+                    </a:p>
+                  </a:txBody>
+                  <a:tcPr/>
+                </a:tc>
+                <a:tc>
+                  <a:txBody>
+                    <a:bodyPr/>
+                    <a:lstStyle/>
+                    <a:p>
+                      <a:r>
+                        <a:rPr lang="en-US" sz="2600" b="0" dirty="0"/>
+                        <a:t>Mean duration between conception and birth</a:t>
+                      </a:r>
+                    </a:p>
+                  </a:txBody>
+                  <a:tcPr/>
+                </a:tc>
+                <a:tc>
+                  <a:txBody>
+                    <a:bodyPr/>
+                    <a:lstStyle/>
+                    <a:p>
+                      <a:r>
+                        <a:rPr lang="en-US" sz="2600" b="0" dirty="0"/>
+                        <a:t>[2] specifies live offspring, [7] specifies “non-inactive” fetal growth</a:t>
+                      </a:r>
+                    </a:p>
+                  </a:txBody>
+                  <a:tcPr/>
+                </a:tc>
+                <a:extLst>
+                  <a:ext uri="{0D108BD9-81ED-4DB2-BD59-A6C34878D82A}">
+                    <a16:rowId xmlns:a16="http://schemas.microsoft.com/office/drawing/2014/main" val="1869094669"/>
+                  </a:ext>
+                </a:extLst>
+              </a:tr>
+            </a:tbl>
+          </a:graphicData>
+        </a:graphic>
+      </p:graphicFrame>
+      <p:sp>
+        <p:nvSpPr>
+          <p:cNvPr id="27" name="TextBox 26">
+            <a:extLst>
+              <a:ext uri="{FF2B5EF4-FFF2-40B4-BE49-F238E27FC236}">
+                <a16:creationId xmlns:a16="http://schemas.microsoft.com/office/drawing/2014/main" id="{B43F7CFC-7592-878E-53F7-EDAD4EDD4DD2}"/>
+              </a:ext>
+            </a:extLst>
+          </p:cNvPr>
+          <p:cNvSpPr txBox="1"/>
+          <p:nvPr/>
+        </p:nvSpPr>
+        <p:spPr>
+          <a:xfrm>
+            <a:off x="4736689" y="24878777"/>
+            <a:ext cx="9022918" cy="830997"/>
+          </a:xfrm>
+          <a:prstGeom prst="rect">
+            <a:avLst/>
+          </a:prstGeom>
+          <a:noFill/>
+        </p:spPr>
+        <p:txBody>
+          <a:bodyPr wrap="square" rtlCol="0">
+            <a:spAutoFit/>
+          </a:bodyPr>
+          <a:lstStyle/>
+          <a:p>
+            <a:r>
+              <a:rPr lang="en-US" sz="2400" b="1" dirty="0">
+                <a:latin typeface="Arial" panose="020B0604020202020204" pitchFamily="34" charset="0"/>
+                <a:cs typeface="Arial" panose="020B0604020202020204" pitchFamily="34" charset="0"/>
+              </a:rPr>
+              <a:t>Table 2.</a:t>
+            </a:r>
+            <a:r>
+              <a:rPr lang="en-US" sz="2400" dirty="0">
+                <a:latin typeface="Arial" panose="020B0604020202020204" pitchFamily="34" charset="0"/>
+                <a:cs typeface="Arial" panose="020B0604020202020204" pitchFamily="34" charset="0"/>
+              </a:rPr>
+              <a:t> Example discrepancies in how key LH traits are recorded differently between databases. IBI = Inter-birth interval.</a:t>
+            </a:r>
+            <a:endParaRPr lang="en-US" sz="2400" b="1" dirty="0">
               <a:latin typeface="Arial" panose="020B0604020202020204" pitchFamily="34" charset="0"/>
               <a:cs typeface="Arial" panose="020B0604020202020204" pitchFamily="34" charset="0"/>
             </a:endParaRPr>

</xml_diff>